<commit_message>
加了 用AI看人生 Signed-off-by: jeniuluo <jeniuluo@gmail.com>
</commit_message>
<xml_diff>
--- a/articles/pics/個人-icon.pptx
+++ b/articles/pics/個人-icon.pptx
@@ -5,7 +5,8 @@
     <p:sldMasterId id="2147483648" r:id="rId1"/>
   </p:sldMasterIdLst>
   <p:sldIdLst>
-    <p:sldId id="256" r:id="rId3"/>
+    <p:sldId id="256" r:id="rId2"/>
+    <p:sldId id="257" r:id="rId3"/>
   </p:sldIdLst>
   <p:sldSz cx="12192000" cy="6858000"/>
   <p:notesSz cx="6858000" cy="9144000"/>
@@ -119,6 +120,9 @@
         </p15:guide>
       </p15:sldGuideLst>
     </p:ext>
+    <p:ext uri="{2D200454-40CA-4A62-9FC3-DE9A4176ACB9}">
+      <p15:notesGuideLst xmlns:p15="http://schemas.microsoft.com/office/powerpoint/2012/main"/>
+    </p:ext>
   </p:extLst>
 </p:presentation>
 </file>
@@ -149,7 +153,7 @@
           <p:nvPr>
             <p:ph type="ctrTitle"/>
             <p:custDataLst>
-              <p:tags r:id="rId2"/>
+              <p:tags r:id="rId1"/>
             </p:custDataLst>
           </p:nvPr>
         </p:nvSpPr>
@@ -173,7 +177,6 @@
               <a:rPr lang="zh-HK" altLang="en-US" dirty="0"/>
               <a:t>按一下以編輯母片標題樣式</a:t>
             </a:r>
-            <a:endParaRPr lang="zh-HK" altLang="en-US" dirty="0"/>
           </a:p>
         </p:txBody>
       </p:sp>
@@ -186,7 +189,7 @@
           <p:nvPr>
             <p:ph type="subTitle" idx="1"/>
             <p:custDataLst>
-              <p:tags r:id="rId3"/>
+              <p:tags r:id="rId2"/>
             </p:custDataLst>
           </p:nvPr>
         </p:nvSpPr>
@@ -246,7 +249,6 @@
               <a:rPr lang="zh-HK" altLang="en-US" dirty="0"/>
               <a:t>按一下以編輯母片副標題樣式</a:t>
             </a:r>
-            <a:endParaRPr lang="zh-HK" altLang="en-US" dirty="0"/>
           </a:p>
         </p:txBody>
       </p:sp>
@@ -259,7 +261,7 @@
           <p:nvPr>
             <p:ph type="dt" sz="half" idx="10"/>
             <p:custDataLst>
-              <p:tags r:id="rId4"/>
+              <p:tags r:id="rId3"/>
             </p:custDataLst>
           </p:nvPr>
         </p:nvSpPr>
@@ -270,6 +272,7 @@
           <a:p>
             <a:fld id="{760FBDFE-C587-4B4C-A407-44438C67B59E}" type="datetimeFigureOut">
               <a:rPr lang="zh-HK" altLang="en-US" smtClean="0"/>
+              <a:t>27/8/2026</a:t>
             </a:fld>
             <a:endParaRPr lang="zh-HK" altLang="en-US"/>
           </a:p>
@@ -284,7 +287,7 @@
           <p:nvPr>
             <p:ph type="ftr" sz="quarter" idx="11"/>
             <p:custDataLst>
-              <p:tags r:id="rId5"/>
+              <p:tags r:id="rId4"/>
             </p:custDataLst>
           </p:nvPr>
         </p:nvSpPr>
@@ -306,7 +309,7 @@
           <p:nvPr>
             <p:ph type="sldNum" sz="quarter" idx="12"/>
             <p:custDataLst>
-              <p:tags r:id="rId6"/>
+              <p:tags r:id="rId5"/>
             </p:custDataLst>
           </p:nvPr>
         </p:nvSpPr>
@@ -317,6 +320,7 @@
           <a:p>
             <a:fld id="{49AE70B2-8BF9-45C0-BB95-33D1B9D3A854}" type="slidenum">
               <a:rPr lang="zh-HK" altLang="en-US" smtClean="0"/>
+              <a:t>‹#›</a:t>
             </a:fld>
             <a:endParaRPr lang="zh-HK" altLang="en-US" dirty="0"/>
           </a:p>
@@ -356,7 +360,7 @@
           <p:nvPr>
             <p:ph type="dt" sz="half" idx="10"/>
             <p:custDataLst>
-              <p:tags r:id="rId2"/>
+              <p:tags r:id="rId1"/>
             </p:custDataLst>
           </p:nvPr>
         </p:nvSpPr>
@@ -367,6 +371,7 @@
           <a:p>
             <a:fld id="{760FBDFE-C587-4B4C-A407-44438C67B59E}" type="datetimeFigureOut">
               <a:rPr lang="zh-HK" altLang="en-US" smtClean="0"/>
+              <a:t>27/8/2026</a:t>
             </a:fld>
             <a:endParaRPr lang="zh-HK" altLang="en-US"/>
           </a:p>
@@ -381,7 +386,7 @@
           <p:nvPr>
             <p:ph type="ftr" sz="quarter" idx="11"/>
             <p:custDataLst>
-              <p:tags r:id="rId3"/>
+              <p:tags r:id="rId2"/>
             </p:custDataLst>
           </p:nvPr>
         </p:nvSpPr>
@@ -403,7 +408,7 @@
           <p:nvPr>
             <p:ph type="sldNum" sz="quarter" idx="12"/>
             <p:custDataLst>
-              <p:tags r:id="rId4"/>
+              <p:tags r:id="rId3"/>
             </p:custDataLst>
           </p:nvPr>
         </p:nvSpPr>
@@ -414,6 +419,7 @@
           <a:p>
             <a:fld id="{49AE70B2-8BF9-45C0-BB95-33D1B9D3A854}" type="slidenum">
               <a:rPr lang="zh-HK" altLang="en-US" smtClean="0"/>
+              <a:t>‹#›</a:t>
             </a:fld>
             <a:endParaRPr lang="zh-HK" altLang="en-US"/>
           </a:p>
@@ -428,7 +434,7 @@
           <p:nvPr>
             <p:ph sz="quarter" idx="13"/>
             <p:custDataLst>
-              <p:tags r:id="rId5"/>
+              <p:tags r:id="rId4"/>
             </p:custDataLst>
           </p:nvPr>
         </p:nvSpPr>
@@ -447,7 +453,6 @@
               <a:rPr lang="zh-HK" altLang="en-US" dirty="0"/>
               <a:t>按一下以編輯母片文字樣式</a:t>
             </a:r>
-            <a:endParaRPr lang="zh-HK" altLang="en-US" dirty="0"/>
           </a:p>
           <a:p>
             <a:pPr lvl="1"/>
@@ -455,7 +460,6 @@
               <a:rPr lang="zh-HK" altLang="en-US" dirty="0"/>
               <a:t>第二層</a:t>
             </a:r>
-            <a:endParaRPr lang="zh-HK" altLang="en-US" dirty="0"/>
           </a:p>
           <a:p>
             <a:pPr lvl="2"/>
@@ -463,7 +467,6 @@
               <a:rPr lang="zh-HK" altLang="en-US" dirty="0"/>
               <a:t>第三層</a:t>
             </a:r>
-            <a:endParaRPr lang="zh-HK" altLang="en-US" dirty="0"/>
           </a:p>
           <a:p>
             <a:pPr lvl="3"/>
@@ -471,7 +474,6 @@
               <a:rPr lang="zh-HK" altLang="en-US" dirty="0"/>
               <a:t>第四層</a:t>
             </a:r>
-            <a:endParaRPr lang="zh-HK" altLang="en-US" dirty="0"/>
           </a:p>
           <a:p>
             <a:pPr lvl="4"/>
@@ -479,7 +481,6 @@
               <a:rPr lang="zh-HK" altLang="en-US" dirty="0"/>
               <a:t>第五層</a:t>
             </a:r>
-            <a:endParaRPr lang="zh-HK" altLang="en-US" dirty="0"/>
           </a:p>
         </p:txBody>
       </p:sp>
@@ -517,7 +518,7 @@
           <p:nvPr>
             <p:ph type="dt" sz="half" idx="10"/>
             <p:custDataLst>
-              <p:tags r:id="rId2"/>
+              <p:tags r:id="rId1"/>
             </p:custDataLst>
           </p:nvPr>
         </p:nvSpPr>
@@ -528,6 +529,7 @@
           <a:p>
             <a:fld id="{760FBDFE-C587-4B4C-A407-44438C67B59E}" type="datetimeFigureOut">
               <a:rPr lang="zh-HK" altLang="en-US" smtClean="0"/>
+              <a:t>27/8/2026</a:t>
             </a:fld>
             <a:endParaRPr lang="zh-HK" altLang="en-US"/>
           </a:p>
@@ -542,7 +544,7 @@
           <p:nvPr>
             <p:ph type="ftr" sz="quarter" idx="11"/>
             <p:custDataLst>
-              <p:tags r:id="rId3"/>
+              <p:tags r:id="rId2"/>
             </p:custDataLst>
           </p:nvPr>
         </p:nvSpPr>
@@ -564,7 +566,7 @@
           <p:nvPr>
             <p:ph type="sldNum" sz="quarter" idx="12"/>
             <p:custDataLst>
-              <p:tags r:id="rId4"/>
+              <p:tags r:id="rId3"/>
             </p:custDataLst>
           </p:nvPr>
         </p:nvSpPr>
@@ -575,6 +577,7 @@
           <a:p>
             <a:fld id="{49AE70B2-8BF9-45C0-BB95-33D1B9D3A854}" type="slidenum">
               <a:rPr lang="zh-HK" altLang="en-US" smtClean="0"/>
+              <a:t>‹#›</a:t>
             </a:fld>
             <a:endParaRPr lang="zh-HK" altLang="en-US"/>
           </a:p>
@@ -589,7 +592,7 @@
           <p:nvPr>
             <p:ph type="title" hasCustomPrompt="1"/>
             <p:custDataLst>
-              <p:tags r:id="rId5"/>
+              <p:tags r:id="rId4"/>
             </p:custDataLst>
           </p:nvPr>
         </p:nvSpPr>
@@ -611,10 +614,9 @@
           <a:p>
             <a:pPr lvl="0"/>
             <a:r>
-              <a:rPr lang="zh-HK" altLang="en-US" smtClean="0"/>
+              <a:rPr lang="zh-HK" altLang="en-US"/>
               <a:t>按一下以編輯標題</a:t>
             </a:r>
-            <a:endParaRPr lang="zh-HK" altLang="en-US"/>
           </a:p>
         </p:txBody>
       </p:sp>
@@ -627,7 +629,7 @@
           <p:nvPr>
             <p:ph type="body" sz="quarter" idx="13"/>
             <p:custDataLst>
-              <p:tags r:id="rId6"/>
+              <p:tags r:id="rId5"/>
             </p:custDataLst>
           </p:nvPr>
         </p:nvSpPr>
@@ -656,7 +658,6 @@
               <a:rPr lang="zh-HK" altLang="en-US" dirty="0"/>
               <a:t>按一下以編輯母片文字樣式</a:t>
             </a:r>
-            <a:endParaRPr lang="zh-HK" altLang="en-US" dirty="0"/>
           </a:p>
         </p:txBody>
       </p:sp>
@@ -694,7 +695,7 @@
           <p:nvPr>
             <p:ph type="title"/>
             <p:custDataLst>
-              <p:tags r:id="rId2"/>
+              <p:tags r:id="rId1"/>
             </p:custDataLst>
           </p:nvPr>
         </p:nvSpPr>
@@ -712,10 +713,9 @@
           <a:p>
             <a:pPr lvl="0"/>
             <a:r>
-              <a:rPr lang="zh-HK" altLang="en-US" smtClean="0"/>
+              <a:rPr lang="zh-HK" altLang="en-US"/>
               <a:t>按一下以編輯母片標題樣式</a:t>
             </a:r>
-            <a:endParaRPr lang="zh-HK" altLang="en-US"/>
           </a:p>
         </p:txBody>
       </p:sp>
@@ -728,7 +728,7 @@
           <p:nvPr>
             <p:ph idx="1"/>
             <p:custDataLst>
-              <p:tags r:id="rId3"/>
+              <p:tags r:id="rId2"/>
             </p:custDataLst>
           </p:nvPr>
         </p:nvSpPr>
@@ -746,42 +746,37 @@
           <a:p>
             <a:pPr lvl="0"/>
             <a:r>
-              <a:rPr lang="zh-HK" altLang="en-US" smtClean="0"/>
+              <a:rPr lang="zh-HK" altLang="en-US"/>
               <a:t>按一下以編輯母片文字樣式</a:t>
             </a:r>
-            <a:endParaRPr lang="zh-HK" altLang="en-US" smtClean="0"/>
           </a:p>
           <a:p>
             <a:pPr lvl="1"/>
             <a:r>
-              <a:rPr lang="zh-HK" altLang="en-US" smtClean="0"/>
+              <a:rPr lang="zh-HK" altLang="en-US"/>
               <a:t>第二層</a:t>
             </a:r>
-            <a:endParaRPr lang="zh-HK" altLang="en-US" smtClean="0"/>
           </a:p>
           <a:p>
             <a:pPr lvl="2"/>
             <a:r>
-              <a:rPr lang="zh-HK" altLang="en-US" smtClean="0"/>
+              <a:rPr lang="zh-HK" altLang="en-US"/>
               <a:t>第三層</a:t>
             </a:r>
-            <a:endParaRPr lang="zh-HK" altLang="en-US" smtClean="0"/>
           </a:p>
           <a:p>
             <a:pPr lvl="3"/>
             <a:r>
-              <a:rPr lang="zh-HK" altLang="en-US" smtClean="0"/>
+              <a:rPr lang="zh-HK" altLang="en-US"/>
               <a:t>第四層</a:t>
             </a:r>
-            <a:endParaRPr lang="zh-HK" altLang="en-US" smtClean="0"/>
           </a:p>
           <a:p>
             <a:pPr lvl="4"/>
             <a:r>
-              <a:rPr lang="zh-HK" altLang="en-US" smtClean="0"/>
+              <a:rPr lang="zh-HK" altLang="en-US"/>
               <a:t>第五層</a:t>
             </a:r>
-            <a:endParaRPr lang="zh-HK" altLang="en-US"/>
           </a:p>
         </p:txBody>
       </p:sp>
@@ -794,7 +789,7 @@
           <p:nvPr>
             <p:ph type="dt" sz="half" idx="10"/>
             <p:custDataLst>
-              <p:tags r:id="rId4"/>
+              <p:tags r:id="rId3"/>
             </p:custDataLst>
           </p:nvPr>
         </p:nvSpPr>
@@ -805,6 +800,7 @@
           <a:p>
             <a:fld id="{760FBDFE-C587-4B4C-A407-44438C67B59E}" type="datetimeFigureOut">
               <a:rPr lang="zh-HK" altLang="en-US" smtClean="0"/>
+              <a:t>27/8/2026</a:t>
             </a:fld>
             <a:endParaRPr lang="zh-HK" altLang="en-US"/>
           </a:p>
@@ -819,7 +815,7 @@
           <p:nvPr>
             <p:ph type="ftr" sz="quarter" idx="11"/>
             <p:custDataLst>
-              <p:tags r:id="rId5"/>
+              <p:tags r:id="rId4"/>
             </p:custDataLst>
           </p:nvPr>
         </p:nvSpPr>
@@ -841,7 +837,7 @@
           <p:nvPr>
             <p:ph type="sldNum" sz="quarter" idx="12"/>
             <p:custDataLst>
-              <p:tags r:id="rId6"/>
+              <p:tags r:id="rId5"/>
             </p:custDataLst>
           </p:nvPr>
         </p:nvSpPr>
@@ -852,6 +848,7 @@
           <a:p>
             <a:fld id="{49AE70B2-8BF9-45C0-BB95-33D1B9D3A854}" type="slidenum">
               <a:rPr lang="zh-HK" altLang="en-US" smtClean="0"/>
+              <a:t>‹#›</a:t>
             </a:fld>
             <a:endParaRPr lang="zh-HK" altLang="en-US"/>
           </a:p>
@@ -891,7 +888,7 @@
           <p:nvPr>
             <p:ph type="title" hasCustomPrompt="1"/>
             <p:custDataLst>
-              <p:tags r:id="rId2"/>
+              <p:tags r:id="rId1"/>
             </p:custDataLst>
           </p:nvPr>
         </p:nvSpPr>
@@ -915,7 +912,6 @@
               <a:rPr lang="zh-HK" altLang="en-US" dirty="0"/>
               <a:t>按一下以編輯標題</a:t>
             </a:r>
-            <a:endParaRPr lang="zh-HK" altLang="en-US" dirty="0"/>
           </a:p>
         </p:txBody>
       </p:sp>
@@ -928,7 +924,7 @@
           <p:nvPr>
             <p:ph type="body" idx="1" hasCustomPrompt="1"/>
             <p:custDataLst>
-              <p:tags r:id="rId3"/>
+              <p:tags r:id="rId2"/>
             </p:custDataLst>
           </p:nvPr>
         </p:nvSpPr>
@@ -1041,7 +1037,6 @@
               <a:rPr lang="zh-HK" altLang="en-US" dirty="0"/>
               <a:t>按一下以編輯文字</a:t>
             </a:r>
-            <a:endParaRPr lang="zh-HK" altLang="en-US" dirty="0"/>
           </a:p>
         </p:txBody>
       </p:sp>
@@ -1054,7 +1049,7 @@
           <p:nvPr>
             <p:ph type="dt" sz="half" idx="10"/>
             <p:custDataLst>
-              <p:tags r:id="rId4"/>
+              <p:tags r:id="rId3"/>
             </p:custDataLst>
           </p:nvPr>
         </p:nvSpPr>
@@ -1065,6 +1060,7 @@
           <a:p>
             <a:fld id="{760FBDFE-C587-4B4C-A407-44438C67B59E}" type="datetimeFigureOut">
               <a:rPr lang="zh-HK" altLang="en-US" smtClean="0"/>
+              <a:t>27/8/2026</a:t>
             </a:fld>
             <a:endParaRPr lang="zh-HK" altLang="en-US"/>
           </a:p>
@@ -1079,7 +1075,7 @@
           <p:nvPr>
             <p:ph type="ftr" sz="quarter" idx="11"/>
             <p:custDataLst>
-              <p:tags r:id="rId5"/>
+              <p:tags r:id="rId4"/>
             </p:custDataLst>
           </p:nvPr>
         </p:nvSpPr>
@@ -1101,7 +1097,7 @@
           <p:nvPr>
             <p:ph type="sldNum" sz="quarter" idx="12"/>
             <p:custDataLst>
-              <p:tags r:id="rId6"/>
+              <p:tags r:id="rId5"/>
             </p:custDataLst>
           </p:nvPr>
         </p:nvSpPr>
@@ -1112,6 +1108,7 @@
           <a:p>
             <a:fld id="{49AE70B2-8BF9-45C0-BB95-33D1B9D3A854}" type="slidenum">
               <a:rPr lang="zh-HK" altLang="en-US" smtClean="0"/>
+              <a:t>‹#›</a:t>
             </a:fld>
             <a:endParaRPr lang="zh-HK" altLang="en-US"/>
           </a:p>
@@ -1151,7 +1148,7 @@
           <p:nvPr>
             <p:ph type="title"/>
             <p:custDataLst>
-              <p:tags r:id="rId2"/>
+              <p:tags r:id="rId1"/>
             </p:custDataLst>
           </p:nvPr>
         </p:nvSpPr>
@@ -1169,10 +1166,9 @@
           <a:p>
             <a:pPr lvl="0"/>
             <a:r>
-              <a:rPr lang="zh-HK" altLang="en-US" smtClean="0"/>
+              <a:rPr lang="zh-HK" altLang="en-US"/>
               <a:t>按一下以編輯母片標題樣式</a:t>
             </a:r>
-            <a:endParaRPr lang="zh-HK" altLang="en-US"/>
           </a:p>
         </p:txBody>
       </p:sp>
@@ -1185,7 +1181,7 @@
           <p:nvPr>
             <p:ph sz="half" idx="1"/>
             <p:custDataLst>
-              <p:tags r:id="rId3"/>
+              <p:tags r:id="rId2"/>
             </p:custDataLst>
           </p:nvPr>
         </p:nvSpPr>
@@ -1203,42 +1199,37 @@
           <a:p>
             <a:pPr lvl="0"/>
             <a:r>
-              <a:rPr lang="zh-HK" altLang="en-US" smtClean="0"/>
+              <a:rPr lang="zh-HK" altLang="en-US"/>
               <a:t>按一下以編輯母片文字樣式</a:t>
             </a:r>
-            <a:endParaRPr lang="zh-HK" altLang="en-US" smtClean="0"/>
           </a:p>
           <a:p>
             <a:pPr lvl="1"/>
             <a:r>
-              <a:rPr lang="zh-HK" altLang="en-US" smtClean="0"/>
+              <a:rPr lang="zh-HK" altLang="en-US"/>
               <a:t>第二層</a:t>
             </a:r>
-            <a:endParaRPr lang="zh-HK" altLang="en-US" smtClean="0"/>
           </a:p>
           <a:p>
             <a:pPr lvl="2"/>
             <a:r>
-              <a:rPr lang="zh-HK" altLang="en-US" smtClean="0"/>
+              <a:rPr lang="zh-HK" altLang="en-US"/>
               <a:t>第三層</a:t>
             </a:r>
-            <a:endParaRPr lang="zh-HK" altLang="en-US" smtClean="0"/>
           </a:p>
           <a:p>
             <a:pPr lvl="3"/>
             <a:r>
-              <a:rPr lang="zh-HK" altLang="en-US" smtClean="0"/>
+              <a:rPr lang="zh-HK" altLang="en-US"/>
               <a:t>第四層</a:t>
             </a:r>
-            <a:endParaRPr lang="zh-HK" altLang="en-US" smtClean="0"/>
           </a:p>
           <a:p>
             <a:pPr lvl="4"/>
             <a:r>
-              <a:rPr lang="zh-HK" altLang="en-US" smtClean="0"/>
+              <a:rPr lang="zh-HK" altLang="en-US"/>
               <a:t>第五層</a:t>
             </a:r>
-            <a:endParaRPr lang="zh-HK" altLang="en-US"/>
           </a:p>
         </p:txBody>
       </p:sp>
@@ -1251,7 +1242,7 @@
           <p:nvPr>
             <p:ph sz="half" idx="2"/>
             <p:custDataLst>
-              <p:tags r:id="rId4"/>
+              <p:tags r:id="rId3"/>
             </p:custDataLst>
           </p:nvPr>
         </p:nvSpPr>
@@ -1272,7 +1263,6 @@
               <a:rPr lang="zh-HK" altLang="en-US" dirty="0"/>
               <a:t>按一下以編輯母片文字樣式</a:t>
             </a:r>
-            <a:endParaRPr lang="zh-HK" altLang="en-US" dirty="0"/>
           </a:p>
           <a:p>
             <a:pPr lvl="1"/>
@@ -1280,7 +1270,6 @@
               <a:rPr lang="zh-HK" altLang="en-US" dirty="0"/>
               <a:t>第二層</a:t>
             </a:r>
-            <a:endParaRPr lang="zh-HK" altLang="en-US" dirty="0"/>
           </a:p>
           <a:p>
             <a:pPr lvl="2"/>
@@ -1288,7 +1277,6 @@
               <a:rPr lang="zh-HK" altLang="en-US" dirty="0"/>
               <a:t>第三層</a:t>
             </a:r>
-            <a:endParaRPr lang="zh-HK" altLang="en-US" dirty="0"/>
           </a:p>
           <a:p>
             <a:pPr lvl="3"/>
@@ -1296,7 +1284,6 @@
               <a:rPr lang="zh-HK" altLang="en-US" dirty="0"/>
               <a:t>第四層</a:t>
             </a:r>
-            <a:endParaRPr lang="zh-HK" altLang="en-US" dirty="0"/>
           </a:p>
           <a:p>
             <a:pPr lvl="4"/>
@@ -1304,7 +1291,6 @@
               <a:rPr lang="zh-HK" altLang="en-US" dirty="0"/>
               <a:t>第五層</a:t>
             </a:r>
-            <a:endParaRPr lang="zh-HK" altLang="en-US" dirty="0"/>
           </a:p>
         </p:txBody>
       </p:sp>
@@ -1317,7 +1303,7 @@
           <p:nvPr>
             <p:ph type="dt" sz="half" idx="10"/>
             <p:custDataLst>
-              <p:tags r:id="rId5"/>
+              <p:tags r:id="rId4"/>
             </p:custDataLst>
           </p:nvPr>
         </p:nvSpPr>
@@ -1328,6 +1314,7 @@
           <a:p>
             <a:fld id="{760FBDFE-C587-4B4C-A407-44438C67B59E}" type="datetimeFigureOut">
               <a:rPr lang="zh-HK" altLang="en-US" smtClean="0"/>
+              <a:t>27/8/2026</a:t>
             </a:fld>
             <a:endParaRPr lang="zh-HK" altLang="en-US"/>
           </a:p>
@@ -1342,7 +1329,7 @@
           <p:nvPr>
             <p:ph type="ftr" sz="quarter" idx="11"/>
             <p:custDataLst>
-              <p:tags r:id="rId6"/>
+              <p:tags r:id="rId5"/>
             </p:custDataLst>
           </p:nvPr>
         </p:nvSpPr>
@@ -1364,7 +1351,7 @@
           <p:nvPr>
             <p:ph type="sldNum" sz="quarter" idx="12"/>
             <p:custDataLst>
-              <p:tags r:id="rId7"/>
+              <p:tags r:id="rId6"/>
             </p:custDataLst>
           </p:nvPr>
         </p:nvSpPr>
@@ -1375,6 +1362,7 @@
           <a:p>
             <a:fld id="{49AE70B2-8BF9-45C0-BB95-33D1B9D3A854}" type="slidenum">
               <a:rPr lang="zh-HK" altLang="en-US" smtClean="0"/>
+              <a:t>‹#›</a:t>
             </a:fld>
             <a:endParaRPr lang="zh-HK" altLang="en-US"/>
           </a:p>
@@ -1414,7 +1402,7 @@
           <p:nvPr>
             <p:ph type="title"/>
             <p:custDataLst>
-              <p:tags r:id="rId2"/>
+              <p:tags r:id="rId1"/>
             </p:custDataLst>
           </p:nvPr>
         </p:nvSpPr>
@@ -1432,10 +1420,9 @@
           <a:p>
             <a:pPr lvl="0"/>
             <a:r>
-              <a:rPr lang="zh-HK" altLang="en-US" smtClean="0"/>
+              <a:rPr lang="zh-HK" altLang="en-US"/>
               <a:t>按一下以編輯母片標題樣式</a:t>
             </a:r>
-            <a:endParaRPr lang="zh-HK" altLang="en-US"/>
           </a:p>
         </p:txBody>
       </p:sp>
@@ -1448,7 +1435,7 @@
           <p:nvPr>
             <p:ph type="body" idx="1" hasCustomPrompt="1"/>
             <p:custDataLst>
-              <p:tags r:id="rId3"/>
+              <p:tags r:id="rId2"/>
             </p:custDataLst>
           </p:nvPr>
         </p:nvSpPr>
@@ -1516,7 +1503,6 @@
               <a:rPr lang="zh-HK" altLang="en-US" dirty="0"/>
               <a:t>按一下以編輯文字</a:t>
             </a:r>
-            <a:endParaRPr lang="zh-HK" altLang="en-US" dirty="0"/>
           </a:p>
         </p:txBody>
       </p:sp>
@@ -1529,7 +1515,7 @@
           <p:nvPr>
             <p:ph sz="half" idx="2"/>
             <p:custDataLst>
-              <p:tags r:id="rId4"/>
+              <p:tags r:id="rId3"/>
             </p:custDataLst>
           </p:nvPr>
         </p:nvSpPr>
@@ -1547,42 +1533,37 @@
           <a:p>
             <a:pPr lvl="0"/>
             <a:r>
-              <a:rPr lang="zh-HK" altLang="en-US" smtClean="0"/>
+              <a:rPr lang="zh-HK" altLang="en-US"/>
               <a:t>按一下以編輯母片文字樣式</a:t>
             </a:r>
-            <a:endParaRPr lang="zh-HK" altLang="en-US" smtClean="0"/>
           </a:p>
           <a:p>
             <a:pPr lvl="1"/>
             <a:r>
-              <a:rPr lang="zh-HK" altLang="en-US" smtClean="0"/>
+              <a:rPr lang="zh-HK" altLang="en-US"/>
               <a:t>第二層</a:t>
             </a:r>
-            <a:endParaRPr lang="zh-HK" altLang="en-US" smtClean="0"/>
           </a:p>
           <a:p>
             <a:pPr lvl="2"/>
             <a:r>
-              <a:rPr lang="zh-HK" altLang="en-US" smtClean="0"/>
+              <a:rPr lang="zh-HK" altLang="en-US"/>
               <a:t>第三層</a:t>
             </a:r>
-            <a:endParaRPr lang="zh-HK" altLang="en-US" smtClean="0"/>
           </a:p>
           <a:p>
             <a:pPr lvl="3"/>
             <a:r>
-              <a:rPr lang="zh-HK" altLang="en-US" smtClean="0"/>
+              <a:rPr lang="zh-HK" altLang="en-US"/>
               <a:t>第四層</a:t>
             </a:r>
-            <a:endParaRPr lang="zh-HK" altLang="en-US" smtClean="0"/>
           </a:p>
           <a:p>
             <a:pPr lvl="4"/>
             <a:r>
-              <a:rPr lang="zh-HK" altLang="en-US" smtClean="0"/>
+              <a:rPr lang="zh-HK" altLang="en-US"/>
               <a:t>第五層</a:t>
             </a:r>
-            <a:endParaRPr lang="zh-HK" altLang="en-US"/>
           </a:p>
         </p:txBody>
       </p:sp>
@@ -1595,7 +1576,7 @@
           <p:nvPr>
             <p:ph type="body" sz="quarter" idx="3" hasCustomPrompt="1"/>
             <p:custDataLst>
-              <p:tags r:id="rId5"/>
+              <p:tags r:id="rId4"/>
             </p:custDataLst>
           </p:nvPr>
         </p:nvSpPr>
@@ -1660,10 +1641,9 @@
           <a:p>
             <a:pPr lvl="0"/>
             <a:r>
-              <a:rPr lang="zh-HK" altLang="en-US" smtClean="0"/>
+              <a:rPr lang="zh-HK" altLang="en-US"/>
               <a:t>按一下以編輯文字</a:t>
             </a:r>
-            <a:endParaRPr lang="zh-HK" altLang="en-US"/>
           </a:p>
         </p:txBody>
       </p:sp>
@@ -1676,7 +1656,7 @@
           <p:nvPr>
             <p:ph sz="quarter" idx="4"/>
             <p:custDataLst>
-              <p:tags r:id="rId6"/>
+              <p:tags r:id="rId5"/>
             </p:custDataLst>
           </p:nvPr>
         </p:nvSpPr>
@@ -1694,42 +1674,37 @@
           <a:p>
             <a:pPr lvl="0"/>
             <a:r>
-              <a:rPr lang="zh-HK" altLang="en-US" smtClean="0"/>
+              <a:rPr lang="zh-HK" altLang="en-US"/>
               <a:t>按一下以編輯母片文字樣式</a:t>
             </a:r>
-            <a:endParaRPr lang="zh-HK" altLang="en-US" smtClean="0"/>
           </a:p>
           <a:p>
             <a:pPr lvl="1"/>
             <a:r>
-              <a:rPr lang="zh-HK" altLang="en-US" smtClean="0"/>
+              <a:rPr lang="zh-HK" altLang="en-US"/>
               <a:t>第二層</a:t>
             </a:r>
-            <a:endParaRPr lang="zh-HK" altLang="en-US" smtClean="0"/>
           </a:p>
           <a:p>
             <a:pPr lvl="2"/>
             <a:r>
-              <a:rPr lang="zh-HK" altLang="en-US" smtClean="0"/>
+              <a:rPr lang="zh-HK" altLang="en-US"/>
               <a:t>第三層</a:t>
             </a:r>
-            <a:endParaRPr lang="zh-HK" altLang="en-US" smtClean="0"/>
           </a:p>
           <a:p>
             <a:pPr lvl="3"/>
             <a:r>
-              <a:rPr lang="zh-HK" altLang="en-US" smtClean="0"/>
+              <a:rPr lang="zh-HK" altLang="en-US"/>
               <a:t>第四層</a:t>
             </a:r>
-            <a:endParaRPr lang="zh-HK" altLang="en-US" smtClean="0"/>
           </a:p>
           <a:p>
             <a:pPr lvl="4"/>
             <a:r>
-              <a:rPr lang="zh-HK" altLang="en-US" smtClean="0"/>
+              <a:rPr lang="zh-HK" altLang="en-US"/>
               <a:t>第五層</a:t>
             </a:r>
-            <a:endParaRPr lang="zh-HK" altLang="en-US"/>
           </a:p>
         </p:txBody>
       </p:sp>
@@ -1742,7 +1717,7 @@
           <p:nvPr>
             <p:ph type="dt" sz="half" idx="10"/>
             <p:custDataLst>
-              <p:tags r:id="rId7"/>
+              <p:tags r:id="rId6"/>
             </p:custDataLst>
           </p:nvPr>
         </p:nvSpPr>
@@ -1753,6 +1728,7 @@
           <a:p>
             <a:fld id="{760FBDFE-C587-4B4C-A407-44438C67B59E}" type="datetimeFigureOut">
               <a:rPr lang="zh-HK" altLang="en-US" smtClean="0"/>
+              <a:t>27/8/2026</a:t>
             </a:fld>
             <a:endParaRPr lang="zh-HK" altLang="en-US"/>
           </a:p>
@@ -1767,7 +1743,7 @@
           <p:nvPr>
             <p:ph type="ftr" sz="quarter" idx="11"/>
             <p:custDataLst>
-              <p:tags r:id="rId8"/>
+              <p:tags r:id="rId7"/>
             </p:custDataLst>
           </p:nvPr>
         </p:nvSpPr>
@@ -1789,7 +1765,7 @@
           <p:nvPr>
             <p:ph type="sldNum" sz="quarter" idx="12"/>
             <p:custDataLst>
-              <p:tags r:id="rId9"/>
+              <p:tags r:id="rId8"/>
             </p:custDataLst>
           </p:nvPr>
         </p:nvSpPr>
@@ -1800,6 +1776,7 @@
           <a:p>
             <a:fld id="{49AE70B2-8BF9-45C0-BB95-33D1B9D3A854}" type="slidenum">
               <a:rPr lang="zh-HK" altLang="en-US" smtClean="0"/>
+              <a:t>‹#›</a:t>
             </a:fld>
             <a:endParaRPr lang="zh-HK" altLang="en-US"/>
           </a:p>
@@ -1839,7 +1816,7 @@
           <p:nvPr>
             <p:ph type="title"/>
             <p:custDataLst>
-              <p:tags r:id="rId2"/>
+              <p:tags r:id="rId1"/>
             </p:custDataLst>
           </p:nvPr>
         </p:nvSpPr>
@@ -1857,10 +1834,9 @@
           <a:p>
             <a:pPr lvl="0"/>
             <a:r>
-              <a:rPr lang="zh-HK" altLang="en-US" smtClean="0"/>
+              <a:rPr lang="zh-HK" altLang="en-US"/>
               <a:t>按一下以編輯母片標題樣式</a:t>
             </a:r>
-            <a:endParaRPr lang="zh-HK" altLang="en-US"/>
           </a:p>
         </p:txBody>
       </p:sp>
@@ -1873,7 +1849,7 @@
           <p:nvPr>
             <p:ph type="dt" sz="half" idx="10"/>
             <p:custDataLst>
-              <p:tags r:id="rId3"/>
+              <p:tags r:id="rId2"/>
             </p:custDataLst>
           </p:nvPr>
         </p:nvSpPr>
@@ -1884,6 +1860,7 @@
           <a:p>
             <a:fld id="{760FBDFE-C587-4B4C-A407-44438C67B59E}" type="datetimeFigureOut">
               <a:rPr lang="zh-HK" altLang="en-US" smtClean="0"/>
+              <a:t>27/8/2026</a:t>
             </a:fld>
             <a:endParaRPr lang="zh-HK" altLang="en-US"/>
           </a:p>
@@ -1898,7 +1875,7 @@
           <p:nvPr>
             <p:ph type="ftr" sz="quarter" idx="11"/>
             <p:custDataLst>
-              <p:tags r:id="rId4"/>
+              <p:tags r:id="rId3"/>
             </p:custDataLst>
           </p:nvPr>
         </p:nvSpPr>
@@ -1920,7 +1897,7 @@
           <p:nvPr>
             <p:ph type="sldNum" sz="quarter" idx="12"/>
             <p:custDataLst>
-              <p:tags r:id="rId5"/>
+              <p:tags r:id="rId4"/>
             </p:custDataLst>
           </p:nvPr>
         </p:nvSpPr>
@@ -1931,6 +1908,7 @@
           <a:p>
             <a:fld id="{49AE70B2-8BF9-45C0-BB95-33D1B9D3A854}" type="slidenum">
               <a:rPr lang="zh-HK" altLang="en-US" smtClean="0"/>
+              <a:t>‹#›</a:t>
             </a:fld>
             <a:endParaRPr lang="zh-HK" altLang="en-US"/>
           </a:p>
@@ -1970,7 +1948,7 @@
           <p:nvPr>
             <p:ph type="dt" sz="half" idx="10"/>
             <p:custDataLst>
-              <p:tags r:id="rId2"/>
+              <p:tags r:id="rId1"/>
             </p:custDataLst>
           </p:nvPr>
         </p:nvSpPr>
@@ -1981,6 +1959,7 @@
           <a:p>
             <a:fld id="{760FBDFE-C587-4B4C-A407-44438C67B59E}" type="datetimeFigureOut">
               <a:rPr lang="zh-HK" altLang="en-US" smtClean="0"/>
+              <a:t>27/8/2026</a:t>
             </a:fld>
             <a:endParaRPr lang="zh-HK" altLang="en-US"/>
           </a:p>
@@ -1995,7 +1974,7 @@
           <p:nvPr>
             <p:ph type="ftr" sz="quarter" idx="11"/>
             <p:custDataLst>
-              <p:tags r:id="rId3"/>
+              <p:tags r:id="rId2"/>
             </p:custDataLst>
           </p:nvPr>
         </p:nvSpPr>
@@ -2017,7 +1996,7 @@
           <p:nvPr>
             <p:ph type="sldNum" sz="quarter" idx="12"/>
             <p:custDataLst>
-              <p:tags r:id="rId4"/>
+              <p:tags r:id="rId3"/>
             </p:custDataLst>
           </p:nvPr>
         </p:nvSpPr>
@@ -2028,6 +2007,7 @@
           <a:p>
             <a:fld id="{49AE70B2-8BF9-45C0-BB95-33D1B9D3A854}" type="slidenum">
               <a:rPr lang="zh-HK" altLang="en-US" smtClean="0"/>
+              <a:t>‹#›</a:t>
             </a:fld>
             <a:endParaRPr lang="zh-HK" altLang="en-US"/>
           </a:p>
@@ -2067,7 +2047,7 @@
           <p:nvPr>
             <p:ph type="pic" idx="1"/>
             <p:custDataLst>
-              <p:tags r:id="rId2"/>
+              <p:tags r:id="rId1"/>
             </p:custDataLst>
           </p:nvPr>
         </p:nvSpPr>
@@ -2102,7 +2082,7 @@
           <p:nvPr>
             <p:ph type="body" sz="half" idx="2"/>
             <p:custDataLst>
-              <p:tags r:id="rId3"/>
+              <p:tags r:id="rId2"/>
             </p:custDataLst>
           </p:nvPr>
         </p:nvSpPr>
@@ -2125,10 +2105,9 @@
           <a:p>
             <a:pPr lvl="0"/>
             <a:r>
-              <a:rPr lang="zh-HK" altLang="en-US" smtClean="0"/>
+              <a:rPr lang="zh-HK" altLang="en-US"/>
               <a:t>按一下以編輯母片文字樣式</a:t>
             </a:r>
-            <a:endParaRPr lang="zh-HK" altLang="en-US"/>
           </a:p>
         </p:txBody>
       </p:sp>
@@ -2141,7 +2120,7 @@
           <p:nvPr>
             <p:ph type="dt" sz="half" idx="10"/>
             <p:custDataLst>
-              <p:tags r:id="rId4"/>
+              <p:tags r:id="rId3"/>
             </p:custDataLst>
           </p:nvPr>
         </p:nvSpPr>
@@ -2152,6 +2131,7 @@
           <a:p>
             <a:fld id="{9EFD9D74-47D9-4702-A33C-335B63B48DBF}" type="datetimeFigureOut">
               <a:rPr lang="zh-HK" altLang="en-US" smtClean="0"/>
+              <a:t>27/8/2026</a:t>
             </a:fld>
             <a:endParaRPr lang="zh-HK" altLang="en-US" dirty="0"/>
           </a:p>
@@ -2166,7 +2146,7 @@
           <p:nvPr>
             <p:ph type="ftr" sz="quarter" idx="11"/>
             <p:custDataLst>
-              <p:tags r:id="rId5"/>
+              <p:tags r:id="rId4"/>
             </p:custDataLst>
           </p:nvPr>
         </p:nvSpPr>
@@ -2188,7 +2168,7 @@
           <p:nvPr>
             <p:ph type="sldNum" sz="quarter" idx="12"/>
             <p:custDataLst>
-              <p:tags r:id="rId6"/>
+              <p:tags r:id="rId5"/>
             </p:custDataLst>
           </p:nvPr>
         </p:nvSpPr>
@@ -2199,6 +2179,7 @@
           <a:p>
             <a:fld id="{FABC47A4-756D-490B-A52F-7D9E2C9FC05F}" type="slidenum">
               <a:rPr lang="zh-HK" altLang="en-US" smtClean="0"/>
+              <a:t>‹#›</a:t>
             </a:fld>
             <a:endParaRPr lang="zh-HK" altLang="en-US"/>
           </a:p>
@@ -2213,19 +2194,19 @@
           <p:nvPr>
             <p:ph type="title"/>
             <p:custDataLst>
-              <p:tags r:id="rId7"/>
+              <p:tags r:id="rId6"/>
             </p:custDataLst>
           </p:nvPr>
         </p:nvSpPr>
         <p:spPr/>
         <p:txBody>
           <a:bodyPr/>
+          <a:lstStyle/>
           <a:p>
             <a:r>
               <a:rPr lang="zh-HK" altLang="en-US"/>
               <a:t>按一下以編輯母片標題樣式</a:t>
             </a:r>
-            <a:endParaRPr lang="zh-HK" altLang="en-US"/>
           </a:p>
         </p:txBody>
       </p:sp>
@@ -2263,7 +2244,7 @@
           <p:nvPr>
             <p:ph type="title" orient="vert" hasCustomPrompt="1"/>
             <p:custDataLst>
-              <p:tags r:id="rId2"/>
+              <p:tags r:id="rId1"/>
             </p:custDataLst>
           </p:nvPr>
         </p:nvSpPr>
@@ -2286,10 +2267,9 @@
           <a:p>
             <a:pPr lvl="0"/>
             <a:r>
-              <a:rPr lang="zh-HK" altLang="en-US" smtClean="0"/>
+              <a:rPr lang="zh-HK" altLang="en-US"/>
               <a:t>按一下以編輯標題</a:t>
             </a:r>
-            <a:endParaRPr lang="zh-HK" altLang="en-US"/>
           </a:p>
         </p:txBody>
       </p:sp>
@@ -2302,7 +2282,7 @@
           <p:nvPr>
             <p:ph type="body" orient="vert" idx="1"/>
             <p:custDataLst>
-              <p:tags r:id="rId3"/>
+              <p:tags r:id="rId2"/>
             </p:custDataLst>
           </p:nvPr>
         </p:nvSpPr>
@@ -2340,7 +2320,6 @@
               <a:rPr lang="zh-HK" altLang="en-US" dirty="0"/>
               <a:t>按一下以編輯母片文字樣式</a:t>
             </a:r>
-            <a:endParaRPr lang="zh-HK" altLang="en-US" dirty="0"/>
           </a:p>
           <a:p>
             <a:pPr lvl="1"/>
@@ -2348,7 +2327,6 @@
               <a:rPr lang="zh-HK" altLang="en-US" dirty="0"/>
               <a:t>第二層</a:t>
             </a:r>
-            <a:endParaRPr lang="zh-HK" altLang="en-US" dirty="0"/>
           </a:p>
           <a:p>
             <a:pPr lvl="2"/>
@@ -2356,7 +2334,6 @@
               <a:rPr lang="zh-HK" altLang="en-US" dirty="0"/>
               <a:t>第三層</a:t>
             </a:r>
-            <a:endParaRPr lang="zh-HK" altLang="en-US" dirty="0"/>
           </a:p>
           <a:p>
             <a:pPr lvl="3"/>
@@ -2364,7 +2341,6 @@
               <a:rPr lang="zh-HK" altLang="en-US" dirty="0"/>
               <a:t>第四層</a:t>
             </a:r>
-            <a:endParaRPr lang="zh-HK" altLang="en-US" dirty="0"/>
           </a:p>
           <a:p>
             <a:pPr lvl="4"/>
@@ -2372,7 +2348,6 @@
               <a:rPr lang="zh-HK" altLang="en-US" dirty="0"/>
               <a:t>第五層</a:t>
             </a:r>
-            <a:endParaRPr lang="zh-HK" altLang="en-US" dirty="0"/>
           </a:p>
         </p:txBody>
       </p:sp>
@@ -2385,7 +2360,7 @@
           <p:nvPr>
             <p:ph type="dt" sz="half" idx="10"/>
             <p:custDataLst>
-              <p:tags r:id="rId4"/>
+              <p:tags r:id="rId3"/>
             </p:custDataLst>
           </p:nvPr>
         </p:nvSpPr>
@@ -2396,6 +2371,7 @@
           <a:p>
             <a:fld id="{760FBDFE-C587-4B4C-A407-44438C67B59E}" type="datetimeFigureOut">
               <a:rPr lang="zh-HK" altLang="en-US" smtClean="0"/>
+              <a:t>27/8/2026</a:t>
             </a:fld>
             <a:endParaRPr lang="zh-HK" altLang="en-US"/>
           </a:p>
@@ -2410,7 +2386,7 @@
           <p:nvPr>
             <p:ph type="ftr" sz="quarter" idx="11"/>
             <p:custDataLst>
-              <p:tags r:id="rId5"/>
+              <p:tags r:id="rId4"/>
             </p:custDataLst>
           </p:nvPr>
         </p:nvSpPr>
@@ -2432,7 +2408,7 @@
           <p:nvPr>
             <p:ph type="sldNum" sz="quarter" idx="12"/>
             <p:custDataLst>
-              <p:tags r:id="rId6"/>
+              <p:tags r:id="rId5"/>
             </p:custDataLst>
           </p:nvPr>
         </p:nvSpPr>
@@ -2443,6 +2419,7 @@
           <a:p>
             <a:fld id="{49AE70B2-8BF9-45C0-BB95-33D1B9D3A854}" type="slidenum">
               <a:rPr lang="zh-HK" altLang="en-US" smtClean="0"/>
+              <a:t>‹#›</a:t>
             </a:fld>
             <a:endParaRPr lang="zh-HK" altLang="en-US"/>
           </a:p>
@@ -2487,7 +2464,7 @@
           <p:nvPr>
             <p:ph type="title"/>
             <p:custDataLst>
-              <p:tags r:id="rId12"/>
+              <p:tags r:id="rId14"/>
             </p:custDataLst>
           </p:nvPr>
         </p:nvSpPr>
@@ -2510,7 +2487,6 @@
               <a:rPr lang="zh-HK" altLang="en-US" dirty="0"/>
               <a:t>按一下以編輯母片標題樣式</a:t>
             </a:r>
-            <a:endParaRPr lang="zh-HK" altLang="en-US" dirty="0"/>
           </a:p>
         </p:txBody>
       </p:sp>
@@ -2523,7 +2499,7 @@
           <p:nvPr>
             <p:ph type="body" idx="1"/>
             <p:custDataLst>
-              <p:tags r:id="rId13"/>
+              <p:tags r:id="rId15"/>
             </p:custDataLst>
           </p:nvPr>
         </p:nvSpPr>
@@ -2547,7 +2523,6 @@
               <a:rPr lang="zh-HK" altLang="en-US" dirty="0"/>
               <a:t>按一下以編輯母片文字樣式</a:t>
             </a:r>
-            <a:endParaRPr lang="zh-HK" altLang="en-US" dirty="0"/>
           </a:p>
           <a:p>
             <a:pPr lvl="1"/>
@@ -2555,7 +2530,6 @@
               <a:rPr lang="zh-HK" altLang="en-US" dirty="0"/>
               <a:t>第二層</a:t>
             </a:r>
-            <a:endParaRPr lang="zh-HK" altLang="en-US" dirty="0"/>
           </a:p>
           <a:p>
             <a:pPr lvl="2"/>
@@ -2563,7 +2537,6 @@
               <a:rPr lang="zh-HK" altLang="en-US" dirty="0"/>
               <a:t>第三層</a:t>
             </a:r>
-            <a:endParaRPr lang="zh-HK" altLang="en-US" dirty="0"/>
           </a:p>
           <a:p>
             <a:pPr lvl="3"/>
@@ -2571,7 +2544,6 @@
               <a:rPr lang="zh-HK" altLang="en-US" dirty="0"/>
               <a:t>第四層</a:t>
             </a:r>
-            <a:endParaRPr lang="zh-HK" altLang="en-US" dirty="0"/>
           </a:p>
           <a:p>
             <a:pPr lvl="4"/>
@@ -2579,7 +2551,6 @@
               <a:rPr lang="zh-HK" altLang="en-US" dirty="0"/>
               <a:t>第五層</a:t>
             </a:r>
-            <a:endParaRPr lang="zh-HK" altLang="en-US" dirty="0"/>
           </a:p>
         </p:txBody>
       </p:sp>
@@ -2592,7 +2563,7 @@
           <p:nvPr>
             <p:ph type="dt" sz="half" idx="2"/>
             <p:custDataLst>
-              <p:tags r:id="rId14"/>
+              <p:tags r:id="rId16"/>
             </p:custDataLst>
           </p:nvPr>
         </p:nvSpPr>
@@ -2623,6 +2594,7 @@
           <a:p>
             <a:fld id="{760FBDFE-C587-4B4C-A407-44438C67B59E}" type="datetimeFigureOut">
               <a:rPr lang="zh-HK" altLang="en-US" smtClean="0"/>
+              <a:t>27/8/2026</a:t>
             </a:fld>
             <a:endParaRPr lang="zh-HK" altLang="en-US"/>
           </a:p>
@@ -2637,7 +2609,7 @@
           <p:nvPr>
             <p:ph type="ftr" sz="quarter" idx="3"/>
             <p:custDataLst>
-              <p:tags r:id="rId15"/>
+              <p:tags r:id="rId17"/>
             </p:custDataLst>
           </p:nvPr>
         </p:nvSpPr>
@@ -2679,7 +2651,7 @@
           <p:nvPr>
             <p:ph type="sldNum" sz="quarter" idx="4"/>
             <p:custDataLst>
-              <p:tags r:id="rId16"/>
+              <p:tags r:id="rId18"/>
             </p:custDataLst>
           </p:nvPr>
         </p:nvSpPr>
@@ -2710,6 +2682,7 @@
           <a:p>
             <a:fld id="{49AE70B2-8BF9-45C0-BB95-33D1B9D3A854}" type="slidenum">
               <a:rPr lang="zh-HK" altLang="en-US" smtClean="0"/>
+              <a:t>‹#›</a:t>
             </a:fld>
             <a:endParaRPr lang="zh-HK" altLang="en-US" dirty="0"/>
           </a:p>
@@ -2717,7 +2690,7 @@
       </p:sp>
     </p:spTree>
     <p:custDataLst>
-      <p:tags r:id="rId17"/>
+      <p:tags r:id="rId13"/>
     </p:custDataLst>
   </p:cSld>
   <p:clrMap bg1="lt1" tx1="dk1" bg2="lt2" tx2="dk2" accent1="accent1" accent2="accent2" accent3="accent3" accent4="accent4" accent5="accent5" accent6="accent6" hlink="hlink" folHlink="folHlink"/>
@@ -3081,27 +3054,6 @@
       </p:grpSpPr>
       <p:sp>
         <p:nvSpPr>
-          <p:cNvPr id="2" name="標題 1"/>
-          <p:cNvSpPr>
-            <a:spLocks noGrp="1"/>
-          </p:cNvSpPr>
-          <p:nvPr>
-            <p:ph type="ctrTitle"/>
-            <p:custDataLst>
-              <p:tags r:id="rId1"/>
-            </p:custDataLst>
-          </p:nvPr>
-        </p:nvSpPr>
-        <p:spPr/>
-        <p:txBody>
-          <a:bodyPr/>
-          <a:p>
-            <a:endParaRPr lang="zh-HK" altLang="en-US"/>
-          </a:p>
-        </p:txBody>
-      </p:sp>
-      <p:sp>
-        <p:nvSpPr>
           <p:cNvPr id="4" name="橢圓 3"/>
           <p:cNvSpPr/>
           <p:nvPr/>
@@ -3179,6 +3131,7 @@
         </p:style>
         <p:txBody>
           <a:bodyPr rtlCol="0" anchor="ctr"/>
+          <a:lstStyle/>
           <a:p>
             <a:pPr algn="ctr"/>
             <a:endParaRPr lang="zh-TW" altLang="en-US" sz="20000" b="1">
@@ -3216,10 +3169,11 @@
           <a:bodyPr wrap="none">
             <a:spAutoFit/>
           </a:bodyPr>
+          <a:lstStyle/>
           <a:p>
             <a:pPr algn="ctr"/>
             <a:r>
-              <a:rPr lang="zh-TW" altLang="zh-HK" sz="20000" b="1">
+              <a:rPr lang="zh-TW" altLang="zh-HK" sz="20000" b="1" dirty="0">
                 <a:solidFill>
                   <a:srgbClr val="FAFAFA"/>
                 </a:solidFill>
@@ -3228,9 +3182,561 @@
               </a:rPr>
               <a:t>仁</a:t>
             </a:r>
-            <a:endParaRPr lang="zh-TW" altLang="zh-HK" sz="20000" b="1">
+          </a:p>
+        </p:txBody>
+      </p:sp>
+    </p:spTree>
+    <p:custDataLst>
+      <p:tags r:id="rId1"/>
+    </p:custDataLst>
+  </p:cSld>
+  <p:clrMapOvr>
+    <a:masterClrMapping/>
+  </p:clrMapOvr>
+</p:sld>
+</file>
+
+<file path=ppt/slides/slide2.xml><?xml version="1.0" encoding="utf-8"?>
+<p:sld xmlns:a="http://schemas.openxmlformats.org/drawingml/2006/main" xmlns:r="http://schemas.openxmlformats.org/officeDocument/2006/relationships" xmlns:p="http://schemas.openxmlformats.org/presentationml/2006/main">
+  <p:cSld>
+    <p:spTree>
+      <p:nvGrpSpPr>
+        <p:cNvPr id="1" name=""/>
+        <p:cNvGrpSpPr/>
+        <p:nvPr/>
+      </p:nvGrpSpPr>
+      <p:grpSpPr>
+        <a:xfrm>
+          <a:off x="0" y="0"/>
+          <a:ext cx="0" cy="0"/>
+          <a:chOff x="0" y="0"/>
+          <a:chExt cx="0" cy="0"/>
+        </a:xfrm>
+      </p:grpSpPr>
+      <p:grpSp>
+        <p:nvGrpSpPr>
+          <p:cNvPr id="14" name="群組 13">
+            <a:extLst>
+              <a:ext uri="{FF2B5EF4-FFF2-40B4-BE49-F238E27FC236}">
+                <a16:creationId xmlns:a16="http://schemas.microsoft.com/office/drawing/2014/main" id="{C4482227-3512-9FD2-45A1-0573E8C0664E}"/>
+              </a:ext>
+            </a:extLst>
+          </p:cNvPr>
+          <p:cNvGrpSpPr/>
+          <p:nvPr/>
+        </p:nvGrpSpPr>
+        <p:grpSpPr>
+          <a:xfrm>
+            <a:off x="4471280" y="2096759"/>
+            <a:ext cx="2473674" cy="2026942"/>
+            <a:chOff x="5842880" y="1237245"/>
+            <a:chExt cx="2473674" cy="2026942"/>
+          </a:xfrm>
+        </p:grpSpPr>
+        <p:sp>
+          <p:nvSpPr>
+            <p:cNvPr id="11" name="手繪多邊形: 圖案 10">
+              <a:extLst>
+                <a:ext uri="{FF2B5EF4-FFF2-40B4-BE49-F238E27FC236}">
+                  <a16:creationId xmlns:a16="http://schemas.microsoft.com/office/drawing/2014/main" id="{48CD69A2-17C5-3192-6461-0E16956DE80E}"/>
+                </a:ext>
+              </a:extLst>
+            </p:cNvPr>
+            <p:cNvSpPr/>
+            <p:nvPr/>
+          </p:nvSpPr>
+          <p:spPr>
+            <a:xfrm>
+              <a:off x="5842880" y="1237245"/>
+              <a:ext cx="941001" cy="2026942"/>
+            </a:xfrm>
+            <a:custGeom>
+              <a:avLst/>
+              <a:gdLst/>
+              <a:ahLst/>
+              <a:cxnLst/>
+              <a:rect l="l" t="t" r="r" b="b"/>
+              <a:pathLst>
+                <a:path w="941001" h="2026942">
+                  <a:moveTo>
+                    <a:pt x="727336" y="0"/>
+                  </a:moveTo>
+                  <a:cubicBezTo>
+                    <a:pt x="751551" y="0"/>
+                    <a:pt x="784109" y="11668"/>
+                    <a:pt x="825010" y="35003"/>
+                  </a:cubicBezTo>
+                  <a:cubicBezTo>
+                    <a:pt x="902337" y="85658"/>
+                    <a:pt x="941001" y="132186"/>
+                    <a:pt x="941001" y="174588"/>
+                  </a:cubicBezTo>
+                  <a:cubicBezTo>
+                    <a:pt x="941001" y="196759"/>
+                    <a:pt x="926888" y="219589"/>
+                    <a:pt x="898664" y="243080"/>
+                  </a:cubicBezTo>
+                  <a:cubicBezTo>
+                    <a:pt x="879856" y="269830"/>
+                    <a:pt x="853235" y="310046"/>
+                    <a:pt x="818801" y="363727"/>
+                  </a:cubicBezTo>
+                  <a:cubicBezTo>
+                    <a:pt x="769854" y="461996"/>
+                    <a:pt x="720034" y="551696"/>
+                    <a:pt x="669341" y="632826"/>
+                  </a:cubicBezTo>
+                  <a:lnTo>
+                    <a:pt x="631613" y="691360"/>
+                  </a:lnTo>
+                  <a:lnTo>
+                    <a:pt x="634604" y="694469"/>
+                  </a:lnTo>
+                  <a:cubicBezTo>
+                    <a:pt x="640031" y="700312"/>
+                    <a:pt x="645666" y="706573"/>
+                    <a:pt x="651510" y="713251"/>
+                  </a:cubicBezTo>
+                  <a:cubicBezTo>
+                    <a:pt x="704053" y="780876"/>
+                    <a:pt x="730324" y="827728"/>
+                    <a:pt x="730324" y="853805"/>
+                  </a:cubicBezTo>
+                  <a:cubicBezTo>
+                    <a:pt x="730324" y="864852"/>
+                    <a:pt x="724775" y="896802"/>
+                    <a:pt x="713677" y="949655"/>
+                  </a:cubicBezTo>
+                  <a:cubicBezTo>
+                    <a:pt x="703691" y="1002405"/>
+                    <a:pt x="698698" y="1144447"/>
+                    <a:pt x="698698" y="1375782"/>
+                  </a:cubicBezTo>
+                  <a:lnTo>
+                    <a:pt x="691092" y="1770165"/>
+                  </a:lnTo>
+                  <a:cubicBezTo>
+                    <a:pt x="691092" y="1823846"/>
+                    <a:pt x="680110" y="1881602"/>
+                    <a:pt x="658146" y="1943432"/>
+                  </a:cubicBezTo>
+                  <a:cubicBezTo>
+                    <a:pt x="641175" y="1999106"/>
+                    <a:pt x="617154" y="2026942"/>
+                    <a:pt x="586083" y="2026942"/>
+                  </a:cubicBezTo>
+                  <a:cubicBezTo>
+                    <a:pt x="551520" y="2026942"/>
+                    <a:pt x="522558" y="1996764"/>
+                    <a:pt x="499197" y="1936409"/>
+                  </a:cubicBezTo>
+                  <a:cubicBezTo>
+                    <a:pt x="465721" y="1860142"/>
+                    <a:pt x="448982" y="1803589"/>
+                    <a:pt x="448982" y="1766750"/>
+                  </a:cubicBezTo>
+                  <a:cubicBezTo>
+                    <a:pt x="451570" y="1751434"/>
+                    <a:pt x="460779" y="1714582"/>
+                    <a:pt x="476612" y="1656192"/>
+                  </a:cubicBezTo>
+                  <a:cubicBezTo>
+                    <a:pt x="512081" y="1547717"/>
+                    <a:pt x="529815" y="1315219"/>
+                    <a:pt x="529815" y="958697"/>
+                  </a:cubicBezTo>
+                  <a:cubicBezTo>
+                    <a:pt x="529815" y="936474"/>
+                    <a:pt x="528908" y="914225"/>
+                    <a:pt x="527094" y="891949"/>
+                  </a:cubicBezTo>
+                  <a:lnTo>
+                    <a:pt x="521047" y="842395"/>
+                  </a:lnTo>
+                  <a:lnTo>
+                    <a:pt x="514642" y="850507"/>
+                  </a:lnTo>
+                  <a:cubicBezTo>
+                    <a:pt x="423138" y="969175"/>
+                    <a:pt x="320587" y="1069397"/>
+                    <a:pt x="206990" y="1151174"/>
+                  </a:cubicBezTo>
+                  <a:cubicBezTo>
+                    <a:pt x="127955" y="1209046"/>
+                    <a:pt x="73330" y="1237982"/>
+                    <a:pt x="43113" y="1237982"/>
+                  </a:cubicBezTo>
+                  <a:cubicBezTo>
+                    <a:pt x="14371" y="1237982"/>
+                    <a:pt x="0" y="1226664"/>
+                    <a:pt x="0" y="1204027"/>
+                  </a:cubicBezTo>
+                  <a:cubicBezTo>
+                    <a:pt x="0" y="1186073"/>
+                    <a:pt x="13129" y="1167744"/>
+                    <a:pt x="39388" y="1149039"/>
+                  </a:cubicBezTo>
+                  <a:cubicBezTo>
+                    <a:pt x="139895" y="1050318"/>
+                    <a:pt x="241553" y="929839"/>
+                    <a:pt x="344362" y="787602"/>
+                  </a:cubicBezTo>
+                  <a:cubicBezTo>
+                    <a:pt x="437160" y="659621"/>
+                    <a:pt x="522093" y="513052"/>
+                    <a:pt x="599161" y="347894"/>
+                  </a:cubicBezTo>
+                  <a:cubicBezTo>
+                    <a:pt x="646167" y="249534"/>
+                    <a:pt x="669671" y="158289"/>
+                    <a:pt x="669671" y="74158"/>
+                  </a:cubicBezTo>
+                  <a:cubicBezTo>
+                    <a:pt x="669671" y="24720"/>
+                    <a:pt x="688893" y="0"/>
+                    <a:pt x="727336" y="0"/>
+                  </a:cubicBezTo>
+                  <a:close/>
+                </a:path>
+              </a:pathLst>
+            </a:custGeom>
+            <a:ln>
+              <a:noFill/>
+            </a:ln>
+          </p:spPr>
+          <p:style>
+            <a:lnRef idx="2">
+              <a:schemeClr val="accent1">
+                <a:shade val="15000"/>
+              </a:schemeClr>
+            </a:lnRef>
+            <a:fillRef idx="1">
+              <a:schemeClr val="accent1"/>
+            </a:fillRef>
+            <a:effectRef idx="0">
+              <a:schemeClr val="accent1"/>
+            </a:effectRef>
+            <a:fontRef idx="minor">
+              <a:schemeClr val="lt1"/>
+            </a:fontRef>
+          </p:style>
+          <p:txBody>
+            <a:bodyPr wrap="square" rtlCol="0" anchor="ctr">
+              <a:noAutofit/>
+            </a:bodyPr>
+            <a:lstStyle/>
+            <a:p>
+              <a:pPr algn="ctr"/>
+              <a:endParaRPr lang="zh-TW" altLang="en-US"/>
+            </a:p>
+          </p:txBody>
+        </p:sp>
+        <p:sp>
+          <p:nvSpPr>
+            <p:cNvPr id="9" name="手繪多邊形: 圖案 8">
+              <a:extLst>
+                <a:ext uri="{FF2B5EF4-FFF2-40B4-BE49-F238E27FC236}">
+                  <a16:creationId xmlns:a16="http://schemas.microsoft.com/office/drawing/2014/main" id="{EA662C18-2F59-2FAE-4C81-3A0A46DCEF67}"/>
+                </a:ext>
+              </a:extLst>
+            </p:cNvPr>
+            <p:cNvSpPr/>
+            <p:nvPr/>
+          </p:nvSpPr>
+          <p:spPr>
+            <a:xfrm>
+              <a:off x="6978685" y="1728093"/>
+              <a:ext cx="1016440" cy="292751"/>
+            </a:xfrm>
+            <a:custGeom>
+              <a:avLst/>
+              <a:gdLst/>
+              <a:ahLst/>
+              <a:cxnLst/>
+              <a:rect l="l" t="t" r="r" b="b"/>
+              <a:pathLst>
+                <a:path w="1016440" h="292751">
+                  <a:moveTo>
+                    <a:pt x="788223" y="0"/>
+                  </a:moveTo>
+                  <a:cubicBezTo>
+                    <a:pt x="801676" y="0"/>
+                    <a:pt x="839097" y="11189"/>
+                    <a:pt x="900488" y="33567"/>
+                  </a:cubicBezTo>
+                  <a:cubicBezTo>
+                    <a:pt x="977789" y="82048"/>
+                    <a:pt x="1016440" y="120997"/>
+                    <a:pt x="1016440" y="150411"/>
+                  </a:cubicBezTo>
+                  <a:cubicBezTo>
+                    <a:pt x="1012740" y="190278"/>
+                    <a:pt x="971813" y="211492"/>
+                    <a:pt x="893658" y="214053"/>
+                  </a:cubicBezTo>
+                  <a:cubicBezTo>
+                    <a:pt x="797265" y="216614"/>
+                    <a:pt x="685258" y="225138"/>
+                    <a:pt x="557639" y="239626"/>
+                  </a:cubicBezTo>
+                  <a:cubicBezTo>
+                    <a:pt x="485849" y="247465"/>
+                    <a:pt x="394099" y="261952"/>
+                    <a:pt x="282390" y="283088"/>
+                  </a:cubicBezTo>
+                  <a:cubicBezTo>
+                    <a:pt x="254113" y="289530"/>
+                    <a:pt x="235991" y="292751"/>
+                    <a:pt x="228023" y="292751"/>
+                  </a:cubicBezTo>
+                  <a:cubicBezTo>
+                    <a:pt x="181249" y="292751"/>
+                    <a:pt x="135976" y="281174"/>
+                    <a:pt x="92203" y="258020"/>
+                  </a:cubicBezTo>
+                  <a:cubicBezTo>
+                    <a:pt x="30734" y="233132"/>
+                    <a:pt x="0" y="205800"/>
+                    <a:pt x="0" y="176023"/>
+                  </a:cubicBezTo>
+                  <a:cubicBezTo>
+                    <a:pt x="0" y="154576"/>
+                    <a:pt x="26220" y="138213"/>
+                    <a:pt x="78660" y="126934"/>
+                  </a:cubicBezTo>
+                  <a:cubicBezTo>
+                    <a:pt x="323628" y="89189"/>
+                    <a:pt x="521964" y="54277"/>
+                    <a:pt x="673668" y="22197"/>
+                  </a:cubicBezTo>
+                  <a:cubicBezTo>
+                    <a:pt x="733662" y="7399"/>
+                    <a:pt x="771847" y="0"/>
+                    <a:pt x="788223" y="0"/>
+                  </a:cubicBezTo>
+                  <a:close/>
+                </a:path>
+              </a:pathLst>
+            </a:custGeom>
+            <a:ln>
+              <a:noFill/>
+            </a:ln>
+          </p:spPr>
+          <p:style>
+            <a:lnRef idx="2">
+              <a:schemeClr val="accent1">
+                <a:shade val="15000"/>
+              </a:schemeClr>
+            </a:lnRef>
+            <a:fillRef idx="1">
+              <a:schemeClr val="accent1"/>
+            </a:fillRef>
+            <a:effectRef idx="0">
+              <a:schemeClr val="accent1"/>
+            </a:effectRef>
+            <a:fontRef idx="minor">
+              <a:schemeClr val="lt1"/>
+            </a:fontRef>
+          </p:style>
+          <p:txBody>
+            <a:bodyPr wrap="square" rtlCol="0" anchor="ctr">
+              <a:noAutofit/>
+            </a:bodyPr>
+            <a:lstStyle/>
+            <a:p>
+              <a:pPr algn="ctr"/>
+              <a:endParaRPr lang="zh-TW" altLang="en-US"/>
+            </a:p>
+          </p:txBody>
+        </p:sp>
+        <p:sp>
+          <p:nvSpPr>
+            <p:cNvPr id="8" name="手繪多邊形: 圖案 7">
+              <a:extLst>
+                <a:ext uri="{FF2B5EF4-FFF2-40B4-BE49-F238E27FC236}">
+                  <a16:creationId xmlns:a16="http://schemas.microsoft.com/office/drawing/2014/main" id="{4DEE273E-BD3E-366B-0F0D-690230A6942B}"/>
+                </a:ext>
+              </a:extLst>
+            </p:cNvPr>
+            <p:cNvSpPr/>
+            <p:nvPr/>
+          </p:nvSpPr>
+          <p:spPr>
+            <a:xfrm>
+              <a:off x="6783881" y="2453916"/>
+              <a:ext cx="1532673" cy="329694"/>
+            </a:xfrm>
+            <a:custGeom>
+              <a:avLst/>
+              <a:gdLst/>
+              <a:ahLst/>
+              <a:cxnLst/>
+              <a:rect l="l" t="t" r="r" b="b"/>
+              <a:pathLst>
+                <a:path w="1532673" h="329694">
+                  <a:moveTo>
+                    <a:pt x="1291068" y="0"/>
+                  </a:moveTo>
+                  <a:cubicBezTo>
+                    <a:pt x="1305194" y="0"/>
+                    <a:pt x="1344452" y="11733"/>
+                    <a:pt x="1408844" y="35197"/>
+                  </a:cubicBezTo>
+                  <a:cubicBezTo>
+                    <a:pt x="1491397" y="86964"/>
+                    <a:pt x="1532673" y="128202"/>
+                    <a:pt x="1532673" y="158910"/>
+                  </a:cubicBezTo>
+                  <a:cubicBezTo>
+                    <a:pt x="1528844" y="200277"/>
+                    <a:pt x="1485783" y="222306"/>
+                    <a:pt x="1403489" y="224996"/>
+                  </a:cubicBezTo>
+                  <a:cubicBezTo>
+                    <a:pt x="1232691" y="228463"/>
+                    <a:pt x="1036321" y="239807"/>
+                    <a:pt x="814378" y="259029"/>
+                  </a:cubicBezTo>
+                  <a:cubicBezTo>
+                    <a:pt x="691907" y="269248"/>
+                    <a:pt x="527914" y="289155"/>
+                    <a:pt x="322399" y="318751"/>
+                  </a:cubicBezTo>
+                  <a:cubicBezTo>
+                    <a:pt x="280307" y="326046"/>
+                    <a:pt x="253363" y="329694"/>
+                    <a:pt x="241566" y="329694"/>
+                  </a:cubicBezTo>
+                  <a:cubicBezTo>
+                    <a:pt x="191947" y="329694"/>
+                    <a:pt x="143349" y="317108"/>
+                    <a:pt x="95773" y="291936"/>
+                  </a:cubicBezTo>
+                  <a:cubicBezTo>
+                    <a:pt x="31925" y="266117"/>
+                    <a:pt x="0" y="237750"/>
+                    <a:pt x="0" y="206835"/>
+                  </a:cubicBezTo>
+                  <a:cubicBezTo>
+                    <a:pt x="0" y="184845"/>
+                    <a:pt x="27164" y="168016"/>
+                    <a:pt x="81492" y="156349"/>
+                  </a:cubicBezTo>
+                  <a:cubicBezTo>
+                    <a:pt x="497904" y="110066"/>
+                    <a:pt x="838891" y="66695"/>
+                    <a:pt x="1104451" y="26233"/>
+                  </a:cubicBezTo>
+                  <a:cubicBezTo>
+                    <a:pt x="1202708" y="8745"/>
+                    <a:pt x="1264913" y="0"/>
+                    <a:pt x="1291068" y="0"/>
+                  </a:cubicBezTo>
+                  <a:close/>
+                </a:path>
+              </a:pathLst>
+            </a:custGeom>
+            <a:ln>
+              <a:noFill/>
+            </a:ln>
+          </p:spPr>
+          <p:style>
+            <a:lnRef idx="2">
+              <a:schemeClr val="accent1">
+                <a:shade val="15000"/>
+              </a:schemeClr>
+            </a:lnRef>
+            <a:fillRef idx="1">
+              <a:schemeClr val="accent1"/>
+            </a:fillRef>
+            <a:effectRef idx="0">
+              <a:schemeClr val="accent1"/>
+            </a:effectRef>
+            <a:fontRef idx="minor">
+              <a:schemeClr val="lt1"/>
+            </a:fontRef>
+          </p:style>
+          <p:txBody>
+            <a:bodyPr wrap="square" rtlCol="0" anchor="ctr">
+              <a:noAutofit/>
+            </a:bodyPr>
+            <a:lstStyle/>
+            <a:p>
+              <a:pPr algn="ctr"/>
+              <a:endParaRPr lang="zh-TW" altLang="en-US"/>
+            </a:p>
+          </p:txBody>
+        </p:sp>
+      </p:grpSp>
+      <p:sp>
+        <p:nvSpPr>
+          <p:cNvPr id="13" name="橢圓 12">
+            <a:extLst>
+              <a:ext uri="{FF2B5EF4-FFF2-40B4-BE49-F238E27FC236}">
+                <a16:creationId xmlns:a16="http://schemas.microsoft.com/office/drawing/2014/main" id="{06F8E624-18F6-FDCF-D0FC-2FFE7E8EF11C}"/>
+              </a:ext>
+            </a:extLst>
+          </p:cNvPr>
+          <p:cNvSpPr/>
+          <p:nvPr/>
+        </p:nvSpPr>
+        <p:spPr>
+          <a:xfrm>
+            <a:off x="885478" y="1490230"/>
+            <a:ext cx="3240000" cy="3240000"/>
+          </a:xfrm>
+          <a:prstGeom prst="ellipse">
+            <a:avLst/>
+          </a:prstGeom>
+          <a:gradFill>
+            <a:gsLst>
+              <a:gs pos="88000">
+                <a:srgbClr val="0070C0"/>
+              </a:gs>
+              <a:gs pos="25000">
+                <a:srgbClr val="00B0F0"/>
+              </a:gs>
+              <a:gs pos="73000">
+                <a:srgbClr val="00B0F0"/>
+              </a:gs>
+              <a:gs pos="10000">
+                <a:schemeClr val="bg1"/>
+              </a:gs>
+            </a:gsLst>
+            <a:lin ang="7800000" scaled="0"/>
+          </a:gradFill>
+          <a:ln w="92075">
+            <a:noFill/>
+          </a:ln>
+        </p:spPr>
+        <p:style>
+          <a:lnRef idx="2">
+            <a:schemeClr val="accent1">
+              <a:lumMod val="75000"/>
+            </a:schemeClr>
+          </a:lnRef>
+          <a:fillRef idx="1">
+            <a:schemeClr val="accent1"/>
+          </a:fillRef>
+          <a:effectRef idx="0">
+            <a:srgbClr val="FFFFFF"/>
+          </a:effectRef>
+          <a:fontRef idx="minor">
+            <a:schemeClr val="lt1"/>
+          </a:fontRef>
+        </p:style>
+        <p:txBody>
+          <a:bodyPr wrap="square" rtlCol="0" anchor="ctr">
+            <a:noAutofit/>
+          </a:bodyPr>
+          <a:lstStyle/>
+          <a:p>
+            <a:pPr algn="ctr"/>
+            <a:endParaRPr lang="zh-TW" altLang="en-US" sz="20000" b="1">
               <a:solidFill>
-                <a:srgbClr val="FAFAFA"/>
+                <a:schemeClr val="accent5">
+                  <a:lumMod val="50000"/>
+                </a:schemeClr>
               </a:solidFill>
               <a:latin typeface="標楷體" panose="03000509000000000000" charset="-120"/>
               <a:ea typeface="標楷體" panose="03000509000000000000" charset="-120"/>
@@ -3240,370 +3746,605 @@
       </p:sp>
       <p:sp>
         <p:nvSpPr>
-          <p:cNvPr id="6" name="任意多邊形 5"/>
+          <p:cNvPr id="18" name="手繪多邊形: 圖案 17">
+            <a:extLst>
+              <a:ext uri="{FF2B5EF4-FFF2-40B4-BE49-F238E27FC236}">
+                <a16:creationId xmlns:a16="http://schemas.microsoft.com/office/drawing/2014/main" id="{0A5D89D8-AB2B-0AD9-AA4E-4342EFC036E5}"/>
+              </a:ext>
+            </a:extLst>
+          </p:cNvPr>
           <p:cNvSpPr/>
           <p:nvPr/>
         </p:nvSpPr>
         <p:spPr>
           <a:xfrm>
-            <a:off x="2546985" y="3380105"/>
+            <a:off x="8316554" y="3110230"/>
             <a:ext cx="3240000" cy="3240000"/>
           </a:xfrm>
           <a:custGeom>
             <a:avLst/>
             <a:gdLst>
-              <a:gd name="idx" fmla="cos wd2 2700000"/>
-              <a:gd name="idy" fmla="sin hd2 2700000"/>
-              <a:gd name="il" fmla="+- hc 0 idx"/>
-              <a:gd name="ir" fmla="+- hc idx 0"/>
-              <a:gd name="it" fmla="+- vc 0 idy"/>
-              <a:gd name="ib" fmla="+- vc idy 0"/>
+              <a:gd name="csX0" fmla="*/ 1620000 w 3240000"/>
+              <a:gd name="csY0" fmla="*/ 0 h 3240000"/>
+              <a:gd name="csX1" fmla="*/ 3240000 w 3240000"/>
+              <a:gd name="csY1" fmla="*/ 1620000 h 3240000"/>
+              <a:gd name="csX2" fmla="*/ 1620000 w 3240000"/>
+              <a:gd name="csY2" fmla="*/ 3240000 h 3240000"/>
+              <a:gd name="csX3" fmla="*/ 0 w 3240000"/>
+              <a:gd name="csY3" fmla="*/ 1620000 h 3240000"/>
+              <a:gd name="csX4" fmla="*/ 1620000 w 3240000"/>
+              <a:gd name="csY4" fmla="*/ 0 h 3240000"/>
+              <a:gd name="csX5" fmla="*/ 1141811 w 3240000"/>
+              <a:gd name="csY5" fmla="*/ 560745 h 3240000"/>
+              <a:gd name="csX6" fmla="*/ 1083387 w 3240000"/>
+              <a:gd name="csY6" fmla="*/ 634410 h 3240000"/>
+              <a:gd name="csX7" fmla="*/ 1013532 w 3240000"/>
+              <a:gd name="csY7" fmla="*/ 908115 h 3240000"/>
+              <a:gd name="csX8" fmla="*/ 758879 w 3240000"/>
+              <a:gd name="csY8" fmla="*/ 1346931 h 3240000"/>
+              <a:gd name="csX9" fmla="*/ 454057 w 3240000"/>
+              <a:gd name="csY9" fmla="*/ 1708271 h 3240000"/>
+              <a:gd name="csX10" fmla="*/ 414685 w 3240000"/>
+              <a:gd name="csY10" fmla="*/ 1762885 h 3240000"/>
+              <a:gd name="csX11" fmla="*/ 458503 w 3240000"/>
+              <a:gd name="csY11" fmla="*/ 1797178 h 3240000"/>
+              <a:gd name="csX12" fmla="*/ 621074 w 3240000"/>
+              <a:gd name="csY12" fmla="*/ 1710812 h 3240000"/>
+              <a:gd name="csX13" fmla="*/ 927801 w 3240000"/>
+              <a:gd name="csY13" fmla="*/ 1413611 h 3240000"/>
+              <a:gd name="csX14" fmla="*/ 936057 w 3240000"/>
+              <a:gd name="csY14" fmla="*/ 1402815 h 3240000"/>
+              <a:gd name="csX15" fmla="*/ 937962 w 3240000"/>
+              <a:gd name="csY15" fmla="*/ 1418056 h 3240000"/>
+              <a:gd name="csX16" fmla="*/ 943677 w 3240000"/>
+              <a:gd name="csY16" fmla="*/ 1517758 h 3240000"/>
+              <a:gd name="csX17" fmla="*/ 890968 w 3240000"/>
+              <a:gd name="csY17" fmla="*/ 2214402 h 3240000"/>
+              <a:gd name="csX18" fmla="*/ 863026 w 3240000"/>
+              <a:gd name="csY18" fmla="*/ 2324900 h 3240000"/>
+              <a:gd name="csX19" fmla="*/ 913195 w 3240000"/>
+              <a:gd name="csY19" fmla="*/ 2494457 h 3240000"/>
+              <a:gd name="csX20" fmla="*/ 1000831 w 3240000"/>
+              <a:gd name="csY20" fmla="*/ 2585269 h 3240000"/>
+              <a:gd name="csX21" fmla="*/ 1070686 w 3240000"/>
+              <a:gd name="csY21" fmla="*/ 2502078 h 3240000"/>
+              <a:gd name="csX22" fmla="*/ 1103709 w 3240000"/>
+              <a:gd name="csY22" fmla="*/ 2331251 h 3240000"/>
+              <a:gd name="csX23" fmla="*/ 1111329 w 3240000"/>
+              <a:gd name="csY23" fmla="*/ 1936253 h 3240000"/>
+              <a:gd name="csX24" fmla="*/ 1125935 w 3240000"/>
+              <a:gd name="csY24" fmla="*/ 1509502 h 3240000"/>
+              <a:gd name="csX25" fmla="*/ 1143081 w 3240000"/>
+              <a:gd name="csY25" fmla="*/ 1412975 h 3240000"/>
+              <a:gd name="csX26" fmla="*/ 1064336 w 3240000"/>
+              <a:gd name="csY26" fmla="*/ 1271995 h 3240000"/>
+              <a:gd name="csX27" fmla="*/ 1047189 w 3240000"/>
+              <a:gd name="csY27" fmla="*/ 1253579 h 3240000"/>
+              <a:gd name="csX28" fmla="*/ 1045284 w 3240000"/>
+              <a:gd name="csY28" fmla="*/ 1251039 h 3240000"/>
+              <a:gd name="csX29" fmla="*/ 1062431 w 3240000"/>
+              <a:gd name="csY29" fmla="*/ 1224367 h 3240000"/>
+              <a:gd name="csX30" fmla="*/ 1229447 w 3240000"/>
+              <a:gd name="csY30" fmla="*/ 924626 h 3240000"/>
+              <a:gd name="csX31" fmla="*/ 1310733 w 3240000"/>
+              <a:gd name="csY31" fmla="*/ 804602 h 3240000"/>
+              <a:gd name="csX32" fmla="*/ 1353281 w 3240000"/>
+              <a:gd name="csY32" fmla="*/ 734747 h 3240000"/>
+              <a:gd name="csX33" fmla="*/ 1237703 w 3240000"/>
+              <a:gd name="csY33" fmla="*/ 595037 h 3240000"/>
+              <a:gd name="csX34" fmla="*/ 1141811 w 3240000"/>
+              <a:gd name="csY34" fmla="*/ 560745 h 3240000"/>
+              <a:gd name="csX35" fmla="*/ 2164234 w 3240000"/>
+              <a:gd name="csY35" fmla="*/ 1131651 h 3240000"/>
+              <a:gd name="csX36" fmla="*/ 2049291 w 3240000"/>
+              <a:gd name="csY36" fmla="*/ 1154512 h 3240000"/>
+              <a:gd name="csX37" fmla="*/ 1455524 w 3240000"/>
+              <a:gd name="csY37" fmla="*/ 1258660 h 3240000"/>
+              <a:gd name="csX38" fmla="*/ 1376778 w 3240000"/>
+              <a:gd name="csY38" fmla="*/ 1307558 h 3240000"/>
+              <a:gd name="csX39" fmla="*/ 1467589 w 3240000"/>
+              <a:gd name="csY39" fmla="*/ 1389479 h 3240000"/>
+              <a:gd name="csX40" fmla="*/ 1604759 w 3240000"/>
+              <a:gd name="csY40" fmla="*/ 1425041 h 3240000"/>
+              <a:gd name="csX41" fmla="*/ 1658738 w 3240000"/>
+              <a:gd name="csY41" fmla="*/ 1415516 h 3240000"/>
+              <a:gd name="csX42" fmla="*/ 1946413 w 3240000"/>
+              <a:gd name="csY42" fmla="*/ 1370427 h 3240000"/>
+              <a:gd name="csX43" fmla="*/ 2270921 w 3240000"/>
+              <a:gd name="csY43" fmla="*/ 1346296 h 3240000"/>
+              <a:gd name="csX44" fmla="*/ 2390310 w 3240000"/>
+              <a:gd name="csY44" fmla="*/ 1282156 h 3240000"/>
+              <a:gd name="csX45" fmla="*/ 2274097 w 3240000"/>
+              <a:gd name="csY45" fmla="*/ 1164673 h 3240000"/>
+              <a:gd name="csX46" fmla="*/ 2164234 w 3240000"/>
+              <a:gd name="csY46" fmla="*/ 1131651 h 3240000"/>
+              <a:gd name="csX47" fmla="*/ 2471596 w 3240000"/>
+              <a:gd name="csY47" fmla="*/ 1856872 h 3240000"/>
+              <a:gd name="csX48" fmla="*/ 2285527 w 3240000"/>
+              <a:gd name="csY48" fmla="*/ 1882909 h 3240000"/>
+              <a:gd name="csX49" fmla="*/ 1263740 w 3240000"/>
+              <a:gd name="csY49" fmla="*/ 2013093 h 3240000"/>
+              <a:gd name="csX50" fmla="*/ 1181819 w 3240000"/>
+              <a:gd name="csY50" fmla="*/ 2063262 h 3240000"/>
+              <a:gd name="csX51" fmla="*/ 1278346 w 3240000"/>
+              <a:gd name="csY51" fmla="*/ 2148993 h 3240000"/>
+              <a:gd name="csX52" fmla="*/ 1423771 w 3240000"/>
+              <a:gd name="csY52" fmla="*/ 2186460 h 3240000"/>
+              <a:gd name="csX53" fmla="*/ 1503787 w 3240000"/>
+              <a:gd name="csY53" fmla="*/ 2175665 h 3240000"/>
+              <a:gd name="csX54" fmla="*/ 1995947 w 3240000"/>
+              <a:gd name="csY54" fmla="*/ 2115970 h 3240000"/>
+              <a:gd name="csX55" fmla="*/ 2584634 w 3240000"/>
+              <a:gd name="csY55" fmla="*/ 2081678 h 3240000"/>
+              <a:gd name="csX56" fmla="*/ 2711008 w 3240000"/>
+              <a:gd name="csY56" fmla="*/ 2015633 h 3240000"/>
+              <a:gd name="csX57" fmla="*/ 2587809 w 3240000"/>
+              <a:gd name="csY57" fmla="*/ 1891799 h 3240000"/>
+              <a:gd name="csX58" fmla="*/ 2471596 w 3240000"/>
+              <a:gd name="csY58" fmla="*/ 1856872 h 3240000"/>
             </a:gdLst>
             <a:ahLst/>
             <a:cxnLst>
-              <a:cxn ang="3cd4">
-                <a:pos x="hc" y="t"/>
-              </a:cxn>
-              <a:cxn ang="3cd4">
-                <a:pos x="il" y="it"/>
-              </a:cxn>
-              <a:cxn ang="cd2">
-                <a:pos x="l" y="vc"/>
-              </a:cxn>
-              <a:cxn ang="cd4">
-                <a:pos x="il" y="ib"/>
-              </a:cxn>
-              <a:cxn ang="cd4">
-                <a:pos x="hc" y="b"/>
-              </a:cxn>
-              <a:cxn ang="cd4">
-                <a:pos x="ir" y="ib"/>
-              </a:cxn>
-              <a:cxn ang="0">
-                <a:pos x="r" y="vc"/>
-              </a:cxn>
-              <a:cxn ang="3cd4">
-                <a:pos x="ir" y="it"/>
+              <a:cxn ang="0">
+                <a:pos x="csX0" y="csY0"/>
+              </a:cxn>
+              <a:cxn ang="0">
+                <a:pos x="csX1" y="csY1"/>
+              </a:cxn>
+              <a:cxn ang="0">
+                <a:pos x="csX2" y="csY2"/>
+              </a:cxn>
+              <a:cxn ang="0">
+                <a:pos x="csX3" y="csY3"/>
+              </a:cxn>
+              <a:cxn ang="0">
+                <a:pos x="csX4" y="csY4"/>
+              </a:cxn>
+              <a:cxn ang="0">
+                <a:pos x="csX5" y="csY5"/>
+              </a:cxn>
+              <a:cxn ang="0">
+                <a:pos x="csX6" y="csY6"/>
+              </a:cxn>
+              <a:cxn ang="0">
+                <a:pos x="csX7" y="csY7"/>
+              </a:cxn>
+              <a:cxn ang="0">
+                <a:pos x="csX8" y="csY8"/>
+              </a:cxn>
+              <a:cxn ang="0">
+                <a:pos x="csX9" y="csY9"/>
+              </a:cxn>
+              <a:cxn ang="0">
+                <a:pos x="csX10" y="csY10"/>
+              </a:cxn>
+              <a:cxn ang="0">
+                <a:pos x="csX11" y="csY11"/>
+              </a:cxn>
+              <a:cxn ang="0">
+                <a:pos x="csX12" y="csY12"/>
+              </a:cxn>
+              <a:cxn ang="0">
+                <a:pos x="csX13" y="csY13"/>
+              </a:cxn>
+              <a:cxn ang="0">
+                <a:pos x="csX14" y="csY14"/>
+              </a:cxn>
+              <a:cxn ang="0">
+                <a:pos x="csX15" y="csY15"/>
+              </a:cxn>
+              <a:cxn ang="0">
+                <a:pos x="csX16" y="csY16"/>
+              </a:cxn>
+              <a:cxn ang="0">
+                <a:pos x="csX17" y="csY17"/>
+              </a:cxn>
+              <a:cxn ang="0">
+                <a:pos x="csX18" y="csY18"/>
+              </a:cxn>
+              <a:cxn ang="0">
+                <a:pos x="csX19" y="csY19"/>
+              </a:cxn>
+              <a:cxn ang="0">
+                <a:pos x="csX20" y="csY20"/>
+              </a:cxn>
+              <a:cxn ang="0">
+                <a:pos x="csX21" y="csY21"/>
+              </a:cxn>
+              <a:cxn ang="0">
+                <a:pos x="csX22" y="csY22"/>
+              </a:cxn>
+              <a:cxn ang="0">
+                <a:pos x="csX23" y="csY23"/>
+              </a:cxn>
+              <a:cxn ang="0">
+                <a:pos x="csX24" y="csY24"/>
+              </a:cxn>
+              <a:cxn ang="0">
+                <a:pos x="csX25" y="csY25"/>
+              </a:cxn>
+              <a:cxn ang="0">
+                <a:pos x="csX26" y="csY26"/>
+              </a:cxn>
+              <a:cxn ang="0">
+                <a:pos x="csX27" y="csY27"/>
+              </a:cxn>
+              <a:cxn ang="0">
+                <a:pos x="csX28" y="csY28"/>
+              </a:cxn>
+              <a:cxn ang="0">
+                <a:pos x="csX29" y="csY29"/>
+              </a:cxn>
+              <a:cxn ang="0">
+                <a:pos x="csX30" y="csY30"/>
+              </a:cxn>
+              <a:cxn ang="0">
+                <a:pos x="csX31" y="csY31"/>
+              </a:cxn>
+              <a:cxn ang="0">
+                <a:pos x="csX32" y="csY32"/>
+              </a:cxn>
+              <a:cxn ang="0">
+                <a:pos x="csX33" y="csY33"/>
+              </a:cxn>
+              <a:cxn ang="0">
+                <a:pos x="csX34" y="csY34"/>
+              </a:cxn>
+              <a:cxn ang="0">
+                <a:pos x="csX35" y="csY35"/>
+              </a:cxn>
+              <a:cxn ang="0">
+                <a:pos x="csX36" y="csY36"/>
+              </a:cxn>
+              <a:cxn ang="0">
+                <a:pos x="csX37" y="csY37"/>
+              </a:cxn>
+              <a:cxn ang="0">
+                <a:pos x="csX38" y="csY38"/>
+              </a:cxn>
+              <a:cxn ang="0">
+                <a:pos x="csX39" y="csY39"/>
+              </a:cxn>
+              <a:cxn ang="0">
+                <a:pos x="csX40" y="csY40"/>
+              </a:cxn>
+              <a:cxn ang="0">
+                <a:pos x="csX41" y="csY41"/>
+              </a:cxn>
+              <a:cxn ang="0">
+                <a:pos x="csX42" y="csY42"/>
+              </a:cxn>
+              <a:cxn ang="0">
+                <a:pos x="csX43" y="csY43"/>
+              </a:cxn>
+              <a:cxn ang="0">
+                <a:pos x="csX44" y="csY44"/>
+              </a:cxn>
+              <a:cxn ang="0">
+                <a:pos x="csX45" y="csY45"/>
+              </a:cxn>
+              <a:cxn ang="0">
+                <a:pos x="csX46" y="csY46"/>
+              </a:cxn>
+              <a:cxn ang="0">
+                <a:pos x="csX47" y="csY47"/>
+              </a:cxn>
+              <a:cxn ang="0">
+                <a:pos x="csX48" y="csY48"/>
+              </a:cxn>
+              <a:cxn ang="0">
+                <a:pos x="csX49" y="csY49"/>
+              </a:cxn>
+              <a:cxn ang="0">
+                <a:pos x="csX50" y="csY50"/>
+              </a:cxn>
+              <a:cxn ang="0">
+                <a:pos x="csX51" y="csY51"/>
+              </a:cxn>
+              <a:cxn ang="0">
+                <a:pos x="csX52" y="csY52"/>
+              </a:cxn>
+              <a:cxn ang="0">
+                <a:pos x="csX53" y="csY53"/>
+              </a:cxn>
+              <a:cxn ang="0">
+                <a:pos x="csX54" y="csY54"/>
+              </a:cxn>
+              <a:cxn ang="0">
+                <a:pos x="csX55" y="csY55"/>
+              </a:cxn>
+              <a:cxn ang="0">
+                <a:pos x="csX56" y="csY56"/>
+              </a:cxn>
+              <a:cxn ang="0">
+                <a:pos x="csX57" y="csY57"/>
+              </a:cxn>
+              <a:cxn ang="0">
+                <a:pos x="csX58" y="csY58"/>
               </a:cxn>
             </a:cxnLst>
             <a:rect l="l" t="t" r="r" b="b"/>
             <a:pathLst>
-              <a:path w="5102" h="5102">
+              <a:path w="3240000" h="3240000">
                 <a:moveTo>
-                  <a:pt x="3892" y="2924"/>
+                  <a:pt x="1620000" y="0"/>
                 </a:moveTo>
                 <a:cubicBezTo>
-                  <a:pt x="3851" y="2924"/>
-                  <a:pt x="3753" y="2938"/>
-                  <a:pt x="3599" y="2965"/>
+                  <a:pt x="2514779" y="0"/>
+                  <a:pt x="3240000" y="725222"/>
+                  <a:pt x="3240000" y="1620000"/>
                 </a:cubicBezTo>
                 <a:cubicBezTo>
-                  <a:pt x="3181" y="3029"/>
-                  <a:pt x="2645" y="3097"/>
-                  <a:pt x="1990" y="3170"/>
+                  <a:pt x="3240000" y="2514779"/>
+                  <a:pt x="2514779" y="3240000"/>
+                  <a:pt x="1620000" y="3240000"/>
                 </a:cubicBezTo>
                 <a:cubicBezTo>
-                  <a:pt x="1904" y="3188"/>
-                  <a:pt x="1861" y="3215"/>
-                  <a:pt x="1861" y="3249"/>
+                  <a:pt x="725222" y="3240000"/>
+                  <a:pt x="0" y="2514779"/>
+                  <a:pt x="0" y="1620000"/>
                 </a:cubicBezTo>
                 <a:cubicBezTo>
-                  <a:pt x="1861" y="3298"/>
-                  <a:pt x="1912" y="3343"/>
-                  <a:pt x="2013" y="3384"/>
-                </a:cubicBezTo>
-                <a:cubicBezTo>
-                  <a:pt x="2087" y="3423"/>
-                  <a:pt x="2164" y="3443"/>
-                  <a:pt x="2242" y="3443"/>
-                </a:cubicBezTo>
-                <a:cubicBezTo>
-                  <a:pt x="2260" y="3443"/>
-                  <a:pt x="2302" y="3437"/>
-                  <a:pt x="2368" y="3426"/>
-                </a:cubicBezTo>
-                <a:cubicBezTo>
-                  <a:pt x="2691" y="3380"/>
-                  <a:pt x="2949" y="3348"/>
-                  <a:pt x="3143" y="3332"/>
-                </a:cubicBezTo>
-                <a:cubicBezTo>
-                  <a:pt x="3492" y="3302"/>
-                  <a:pt x="3801" y="3284"/>
-                  <a:pt x="4070" y="3278"/>
-                </a:cubicBezTo>
-                <a:cubicBezTo>
-                  <a:pt x="4197" y="3274"/>
-                  <a:pt x="4263" y="3240"/>
-                  <a:pt x="4269" y="3174"/>
-                </a:cubicBezTo>
-                <a:cubicBezTo>
-                  <a:pt x="4269" y="3125"/>
-                  <a:pt x="4205" y="3060"/>
-                  <a:pt x="4075" y="2979"/>
-                </a:cubicBezTo>
-                <a:cubicBezTo>
-                  <a:pt x="3975" y="2942"/>
-                  <a:pt x="3914" y="2924"/>
-                  <a:pt x="3892" y="2924"/>
+                  <a:pt x="0" y="725222"/>
+                  <a:pt x="725222" y="0"/>
+                  <a:pt x="1620000" y="0"/>
                 </a:cubicBezTo>
                 <a:close/>
                 <a:moveTo>
-                  <a:pt x="1521" y="1878"/>
+                  <a:pt x="1141811" y="560745"/>
                 </a:moveTo>
                 <a:cubicBezTo>
-                  <a:pt x="1545" y="1878"/>
-                  <a:pt x="1584" y="1906"/>
-                  <a:pt x="1637" y="1961"/>
+                  <a:pt x="1103073" y="560745"/>
+                  <a:pt x="1083387" y="585512"/>
+                  <a:pt x="1083387" y="634410"/>
+                </a:cubicBezTo>
+                <a:cubicBezTo>
+                  <a:pt x="1083387" y="718871"/>
+                  <a:pt x="1059890" y="809683"/>
+                  <a:pt x="1013532" y="908115"/>
+                </a:cubicBezTo>
+                <a:cubicBezTo>
+                  <a:pt x="936057" y="1073226"/>
+                  <a:pt x="851596" y="1219287"/>
+                  <a:pt x="758879" y="1346931"/>
+                </a:cubicBezTo>
+                <a:cubicBezTo>
+                  <a:pt x="656002" y="1489181"/>
+                  <a:pt x="554395" y="1609839"/>
+                  <a:pt x="454057" y="1708271"/>
+                </a:cubicBezTo>
+                <a:cubicBezTo>
+                  <a:pt x="428021" y="1727323"/>
+                  <a:pt x="414685" y="1745104"/>
+                  <a:pt x="414685" y="1762885"/>
+                </a:cubicBezTo>
+                <a:cubicBezTo>
+                  <a:pt x="414685" y="1785747"/>
+                  <a:pt x="429291" y="1797178"/>
+                  <a:pt x="458503" y="1797178"/>
+                </a:cubicBezTo>
+                <a:cubicBezTo>
+                  <a:pt x="487715" y="1797178"/>
+                  <a:pt x="541694" y="1768601"/>
+                  <a:pt x="621074" y="1710812"/>
+                </a:cubicBezTo>
+                <a:cubicBezTo>
+                  <a:pt x="733477" y="1629526"/>
+                  <a:pt x="835719" y="1530459"/>
+                  <a:pt x="927801" y="1413611"/>
                 </a:cubicBezTo>
                 <a:lnTo>
-                  <a:pt x="1646" y="1970"/>
+                  <a:pt x="936057" y="1402815"/>
                 </a:lnTo>
                 <a:lnTo>
-                  <a:pt x="1643" y="1974"/>
+                  <a:pt x="937962" y="1418056"/>
                 </a:lnTo>
                 <a:cubicBezTo>
-                  <a:pt x="1593" y="2050"/>
-                  <a:pt x="1542" y="2121"/>
-                  <a:pt x="1491" y="2187"/>
+                  <a:pt x="941772" y="1451078"/>
+                  <a:pt x="943677" y="1484736"/>
+                  <a:pt x="943677" y="1517758"/>
+                </a:cubicBezTo>
+                <a:cubicBezTo>
+                  <a:pt x="943677" y="1874018"/>
+                  <a:pt x="925896" y="2106445"/>
+                  <a:pt x="890968" y="2214402"/>
+                </a:cubicBezTo>
+                <a:cubicBezTo>
+                  <a:pt x="875092" y="2272826"/>
+                  <a:pt x="865567" y="2309659"/>
+                  <a:pt x="863026" y="2324900"/>
+                </a:cubicBezTo>
+                <a:cubicBezTo>
+                  <a:pt x="863026" y="2361733"/>
+                  <a:pt x="880173" y="2418252"/>
+                  <a:pt x="913195" y="2494457"/>
+                </a:cubicBezTo>
+                <a:cubicBezTo>
+                  <a:pt x="936692" y="2554786"/>
+                  <a:pt x="965904" y="2585269"/>
+                  <a:pt x="1000831" y="2585269"/>
+                </a:cubicBezTo>
+                <a:cubicBezTo>
+                  <a:pt x="1030678" y="2585269"/>
+                  <a:pt x="1053540" y="2557327"/>
+                  <a:pt x="1070686" y="2502078"/>
+                </a:cubicBezTo>
+                <a:cubicBezTo>
+                  <a:pt x="1092913" y="2440478"/>
+                  <a:pt x="1103709" y="2383324"/>
+                  <a:pt x="1103709" y="2331251"/>
                 </a:cubicBezTo>
                 <a:lnTo>
-                  <a:pt x="1474" y="2209"/>
+                  <a:pt x="1111329" y="1936253"/>
+                </a:lnTo>
+                <a:cubicBezTo>
+                  <a:pt x="1111329" y="1704461"/>
+                  <a:pt x="1116409" y="1562211"/>
+                  <a:pt x="1125935" y="1509502"/>
+                </a:cubicBezTo>
+                <a:cubicBezTo>
+                  <a:pt x="1137366" y="1456794"/>
+                  <a:pt x="1143081" y="1424406"/>
+                  <a:pt x="1143081" y="1412975"/>
+                </a:cubicBezTo>
+                <a:cubicBezTo>
+                  <a:pt x="1143081" y="1386939"/>
+                  <a:pt x="1116409" y="1339945"/>
+                  <a:pt x="1064336" y="1271995"/>
+                </a:cubicBezTo>
+                <a:cubicBezTo>
+                  <a:pt x="1057985" y="1265645"/>
+                  <a:pt x="1052905" y="1259295"/>
+                  <a:pt x="1047189" y="1253579"/>
+                </a:cubicBezTo>
+                <a:lnTo>
+                  <a:pt x="1045284" y="1251039"/>
                 </a:lnTo>
                 <a:lnTo>
-                  <a:pt x="1473" y="2207"/>
+                  <a:pt x="1062431" y="1224367"/>
                 </a:lnTo>
                 <a:cubicBezTo>
-                  <a:pt x="1462" y="2128"/>
-                  <a:pt x="1444" y="2049"/>
-                  <a:pt x="1418" y="1969"/>
+                  <a:pt x="1119585" y="1135461"/>
+                  <a:pt x="1174834" y="1035124"/>
+                  <a:pt x="1229447" y="924626"/>
                 </a:cubicBezTo>
                 <a:cubicBezTo>
-                  <a:pt x="1418" y="1909"/>
-                  <a:pt x="1452" y="1878"/>
-                  <a:pt x="1521" y="1878"/>
+                  <a:pt x="1265010" y="871282"/>
+                  <a:pt x="1291682" y="831274"/>
+                  <a:pt x="1310733" y="804602"/>
+                </a:cubicBezTo>
+                <a:cubicBezTo>
+                  <a:pt x="1338675" y="781106"/>
+                  <a:pt x="1353281" y="757609"/>
+                  <a:pt x="1353281" y="734747"/>
+                </a:cubicBezTo>
+                <a:cubicBezTo>
+                  <a:pt x="1353281" y="692199"/>
+                  <a:pt x="1314544" y="645841"/>
+                  <a:pt x="1237703" y="595037"/>
+                </a:cubicBezTo>
+                <a:cubicBezTo>
+                  <a:pt x="1197060" y="572176"/>
+                  <a:pt x="1165308" y="560745"/>
+                  <a:pt x="1141811" y="560745"/>
                 </a:cubicBezTo>
                 <a:close/>
                 <a:moveTo>
-                  <a:pt x="3408" y="1782"/>
+                  <a:pt x="2164234" y="1131651"/>
                 </a:moveTo>
                 <a:cubicBezTo>
-                  <a:pt x="3382" y="1782"/>
-                  <a:pt x="3322" y="1794"/>
-                  <a:pt x="3227" y="1818"/>
+                  <a:pt x="2147723" y="1131651"/>
+                  <a:pt x="2109620" y="1139271"/>
+                  <a:pt x="2049291" y="1154512"/>
                 </a:cubicBezTo>
                 <a:cubicBezTo>
-                  <a:pt x="2989" y="1868"/>
-                  <a:pt x="2677" y="1923"/>
-                  <a:pt x="2292" y="1982"/>
+                  <a:pt x="1898150" y="1186264"/>
+                  <a:pt x="1700016" y="1221192"/>
+                  <a:pt x="1455524" y="1258660"/>
                 </a:cubicBezTo>
                 <a:cubicBezTo>
-                  <a:pt x="2209" y="2000"/>
-                  <a:pt x="2168" y="2026"/>
-                  <a:pt x="2168" y="2059"/>
+                  <a:pt x="1402815" y="1270090"/>
+                  <a:pt x="1376778" y="1286602"/>
+                  <a:pt x="1376778" y="1307558"/>
                 </a:cubicBezTo>
                 <a:cubicBezTo>
-                  <a:pt x="2168" y="2106"/>
-                  <a:pt x="2215" y="2149"/>
-                  <a:pt x="2311" y="2188"/>
+                  <a:pt x="1376778" y="1337405"/>
+                  <a:pt x="1406625" y="1364712"/>
+                  <a:pt x="1467589" y="1389479"/>
                 </a:cubicBezTo>
                 <a:cubicBezTo>
-                  <a:pt x="2381" y="2225"/>
-                  <a:pt x="2453" y="2244"/>
-                  <a:pt x="2527" y="2244"/>
+                  <a:pt x="1512043" y="1412975"/>
+                  <a:pt x="1557766" y="1425041"/>
+                  <a:pt x="1604759" y="1425041"/>
                 </a:cubicBezTo>
                 <a:cubicBezTo>
-                  <a:pt x="2539" y="2244"/>
-                  <a:pt x="2567" y="2239"/>
-                  <a:pt x="2612" y="2229"/>
+                  <a:pt x="1612380" y="1425041"/>
+                  <a:pt x="1630161" y="1421866"/>
+                  <a:pt x="1658738" y="1415516"/>
                 </a:cubicBezTo>
                 <a:cubicBezTo>
-                  <a:pt x="2787" y="2195"/>
-                  <a:pt x="2938" y="2172"/>
-                  <a:pt x="3065" y="2158"/>
+                  <a:pt x="1769871" y="1393924"/>
+                  <a:pt x="1865763" y="1379318"/>
+                  <a:pt x="1946413" y="1370427"/>
                 </a:cubicBezTo>
                 <a:cubicBezTo>
-                  <a:pt x="3252" y="2137"/>
-                  <a:pt x="3423" y="2124"/>
-                  <a:pt x="3576" y="2120"/>
+                  <a:pt x="2065167" y="1357092"/>
+                  <a:pt x="2173759" y="1348836"/>
+                  <a:pt x="2270921" y="1346296"/>
                 </a:cubicBezTo>
                 <a:cubicBezTo>
-                  <a:pt x="3696" y="2116"/>
-                  <a:pt x="3758" y="2083"/>
-                  <a:pt x="3764" y="2019"/>
+                  <a:pt x="2347127" y="1343756"/>
+                  <a:pt x="2386500" y="1322799"/>
+                  <a:pt x="2390310" y="1282156"/>
                 </a:cubicBezTo>
                 <a:cubicBezTo>
-                  <a:pt x="3764" y="1973"/>
-                  <a:pt x="3703" y="1911"/>
-                  <a:pt x="3581" y="1834"/>
+                  <a:pt x="2390310" y="1252944"/>
+                  <a:pt x="2351572" y="1213571"/>
+                  <a:pt x="2274097" y="1164673"/>
                 </a:cubicBezTo>
                 <a:cubicBezTo>
-                  <a:pt x="3486" y="1800"/>
-                  <a:pt x="3429" y="1782"/>
-                  <a:pt x="3408" y="1782"/>
+                  <a:pt x="2213767" y="1143081"/>
+                  <a:pt x="2177570" y="1131651"/>
+                  <a:pt x="2164234" y="1131651"/>
                 </a:cubicBezTo>
                 <a:close/>
                 <a:moveTo>
-                  <a:pt x="1798" y="883"/>
+                  <a:pt x="2471596" y="1856872"/>
                 </a:moveTo>
                 <a:cubicBezTo>
-                  <a:pt x="1737" y="883"/>
-                  <a:pt x="1706" y="922"/>
-                  <a:pt x="1706" y="999"/>
+                  <a:pt x="2445559" y="1856872"/>
+                  <a:pt x="2383324" y="1865763"/>
+                  <a:pt x="2285527" y="1882909"/>
                 </a:cubicBezTo>
                 <a:cubicBezTo>
-                  <a:pt x="1706" y="1132"/>
-                  <a:pt x="1669" y="1275"/>
-                  <a:pt x="1596" y="1430"/>
+                  <a:pt x="2020079" y="1923552"/>
+                  <a:pt x="1679694" y="1966735"/>
+                  <a:pt x="1263740" y="2013093"/>
                 </a:cubicBezTo>
                 <a:cubicBezTo>
-                  <a:pt x="1474" y="1690"/>
-                  <a:pt x="1341" y="1920"/>
-                  <a:pt x="1195" y="2121"/>
+                  <a:pt x="1209126" y="2024524"/>
+                  <a:pt x="1181819" y="2041670"/>
+                  <a:pt x="1181819" y="2063262"/>
                 </a:cubicBezTo>
                 <a:cubicBezTo>
-                  <a:pt x="1033" y="2345"/>
-                  <a:pt x="873" y="2535"/>
-                  <a:pt x="715" y="2690"/>
+                  <a:pt x="1181819" y="2094379"/>
+                  <a:pt x="1214206" y="2122956"/>
+                  <a:pt x="1278346" y="2148993"/>
                 </a:cubicBezTo>
                 <a:cubicBezTo>
-                  <a:pt x="674" y="2720"/>
-                  <a:pt x="653" y="2748"/>
-                  <a:pt x="653" y="2776"/>
+                  <a:pt x="1325339" y="2173759"/>
+                  <a:pt x="1374238" y="2186460"/>
+                  <a:pt x="1423771" y="2186460"/>
                 </a:cubicBezTo>
                 <a:cubicBezTo>
-                  <a:pt x="653" y="2812"/>
-                  <a:pt x="676" y="2830"/>
-                  <a:pt x="722" y="2830"/>
+                  <a:pt x="1435202" y="2186460"/>
+                  <a:pt x="1461874" y="2182650"/>
+                  <a:pt x="1503787" y="2175665"/>
                 </a:cubicBezTo>
                 <a:cubicBezTo>
-                  <a:pt x="768" y="2830"/>
-                  <a:pt x="853" y="2785"/>
-                  <a:pt x="978" y="2694"/>
+                  <a:pt x="1708906" y="2146452"/>
+                  <a:pt x="1872748" y="2126131"/>
+                  <a:pt x="1995947" y="2115970"/>
                 </a:cubicBezTo>
                 <a:cubicBezTo>
-                  <a:pt x="1155" y="2566"/>
-                  <a:pt x="1316" y="2410"/>
-                  <a:pt x="1461" y="2226"/>
-                </a:cubicBezTo>
-                <a:lnTo>
-                  <a:pt x="1474" y="2209"/>
-                </a:lnTo>
-                <a:lnTo>
-                  <a:pt x="1477" y="2233"/>
-                </a:lnTo>
-                <a:cubicBezTo>
-                  <a:pt x="1483" y="2285"/>
-                  <a:pt x="1486" y="2338"/>
-                  <a:pt x="1486" y="2390"/>
+                  <a:pt x="2217578" y="2096919"/>
+                  <a:pt x="2413806" y="2085488"/>
+                  <a:pt x="2584634" y="2081678"/>
                 </a:cubicBezTo>
                 <a:cubicBezTo>
-                  <a:pt x="1486" y="2951"/>
-                  <a:pt x="1458" y="3317"/>
-                  <a:pt x="1403" y="3487"/>
+                  <a:pt x="2665284" y="2079138"/>
+                  <a:pt x="2707197" y="2057546"/>
+                  <a:pt x="2711008" y="2015633"/>
                 </a:cubicBezTo>
                 <a:cubicBezTo>
-                  <a:pt x="1378" y="3579"/>
-                  <a:pt x="1363" y="3637"/>
-                  <a:pt x="1359" y="3661"/>
+                  <a:pt x="2711008" y="1984516"/>
+                  <a:pt x="2670365" y="1943238"/>
+                  <a:pt x="2587809" y="1891799"/>
                 </a:cubicBezTo>
                 <a:cubicBezTo>
-                  <a:pt x="1359" y="3719"/>
-                  <a:pt x="1386" y="3808"/>
-                  <a:pt x="1438" y="3928"/>
-                </a:cubicBezTo>
-                <a:cubicBezTo>
-                  <a:pt x="1475" y="4023"/>
-                  <a:pt x="1521" y="4071"/>
-                  <a:pt x="1576" y="4071"/>
-                </a:cubicBezTo>
-                <a:cubicBezTo>
-                  <a:pt x="1623" y="4071"/>
-                  <a:pt x="1659" y="4027"/>
-                  <a:pt x="1686" y="3940"/>
-                </a:cubicBezTo>
-                <a:cubicBezTo>
-                  <a:pt x="1721" y="3843"/>
-                  <a:pt x="1738" y="3753"/>
-                  <a:pt x="1738" y="3671"/>
-                </a:cubicBezTo>
-                <a:lnTo>
-                  <a:pt x="1750" y="3049"/>
-                </a:lnTo>
-                <a:cubicBezTo>
-                  <a:pt x="1750" y="2684"/>
-                  <a:pt x="1758" y="2460"/>
-                  <a:pt x="1773" y="2377"/>
-                </a:cubicBezTo>
-                <a:cubicBezTo>
-                  <a:pt x="1791" y="2294"/>
-                  <a:pt x="1800" y="2243"/>
-                  <a:pt x="1800" y="2225"/>
-                </a:cubicBezTo>
-                <a:cubicBezTo>
-                  <a:pt x="1800" y="2184"/>
-                  <a:pt x="1758" y="2110"/>
-                  <a:pt x="1676" y="2003"/>
-                </a:cubicBezTo>
-                <a:cubicBezTo>
-                  <a:pt x="1666" y="1993"/>
-                  <a:pt x="1658" y="1983"/>
-                  <a:pt x="1649" y="1974"/>
-                </a:cubicBezTo>
-                <a:lnTo>
-                  <a:pt x="1646" y="1970"/>
-                </a:lnTo>
-                <a:lnTo>
-                  <a:pt x="1673" y="1928"/>
-                </a:lnTo>
-                <a:cubicBezTo>
-                  <a:pt x="1763" y="1788"/>
-                  <a:pt x="1850" y="1630"/>
-                  <a:pt x="1936" y="1456"/>
-                </a:cubicBezTo>
-                <a:cubicBezTo>
-                  <a:pt x="1992" y="1372"/>
-                  <a:pt x="2034" y="1309"/>
-                  <a:pt x="2064" y="1267"/>
-                </a:cubicBezTo>
-                <a:cubicBezTo>
-                  <a:pt x="2108" y="1230"/>
-                  <a:pt x="2131" y="1193"/>
-                  <a:pt x="2131" y="1157"/>
-                </a:cubicBezTo>
-                <a:cubicBezTo>
-                  <a:pt x="2131" y="1090"/>
-                  <a:pt x="2070" y="1017"/>
-                  <a:pt x="1949" y="937"/>
-                </a:cubicBezTo>
-                <a:cubicBezTo>
-                  <a:pt x="1885" y="901"/>
-                  <a:pt x="1835" y="883"/>
-                  <a:pt x="1798" y="883"/>
-                </a:cubicBezTo>
-                <a:close/>
-                <a:moveTo>
-                  <a:pt x="2551" y="0"/>
-                </a:moveTo>
-                <a:cubicBezTo>
-                  <a:pt x="3960" y="0"/>
-                  <a:pt x="5102" y="1142"/>
-                  <a:pt x="5102" y="2551"/>
-                </a:cubicBezTo>
-                <a:cubicBezTo>
-                  <a:pt x="5102" y="3960"/>
-                  <a:pt x="3960" y="5102"/>
-                  <a:pt x="2551" y="5102"/>
-                </a:cubicBezTo>
-                <a:cubicBezTo>
-                  <a:pt x="1142" y="5102"/>
-                  <a:pt x="0" y="3960"/>
-                  <a:pt x="0" y="2551"/>
-                </a:cubicBezTo>
-                <a:cubicBezTo>
-                  <a:pt x="0" y="1142"/>
-                  <a:pt x="1142" y="0"/>
-                  <a:pt x="2551" y="0"/>
+                  <a:pt x="2524304" y="1868303"/>
+                  <a:pt x="2485567" y="1856872"/>
+                  <a:pt x="2471596" y="1856872"/>
                 </a:cubicBezTo>
                 <a:close/>
               </a:path>
@@ -3650,6 +4391,7 @@
           <a:bodyPr wrap="square" rtlCol="0" anchor="ctr">
             <a:noAutofit/>
           </a:bodyPr>
+          <a:lstStyle/>
           <a:p>
             <a:pPr algn="ctr"/>
             <a:endParaRPr lang="zh-TW" altLang="en-US" sz="20000" b="1">
@@ -3665,9 +4407,11 @@
         </p:txBody>
       </p:sp>
     </p:spTree>
-    <p:custDataLst>
-      <p:tags r:id="rId3"/>
-    </p:custDataLst>
+    <p:extLst>
+      <p:ext uri="{BB962C8B-B14F-4D97-AF65-F5344CB8AC3E}">
+        <p14:creationId xmlns:p14="http://schemas.microsoft.com/office/powerpoint/2010/main" val="846597799"/>
+      </p:ext>
+    </p:extLst>
   </p:cSld>
   <p:clrMapOvr>
     <a:masterClrMapping/>
@@ -3676,765 +4420,7 @@
 </file>
 
 <file path=ppt/tags/tag1.xml><?xml version="1.0" encoding="utf-8"?>
-<p:tagLst xmlns:p="http://schemas.openxmlformats.org/presentationml/2006/main">
-  <p:tag name="KSO_WM_UNIT_HIGHLIGHT" val="0"/>
-  <p:tag name="KSO_WM_UNIT_COMPATIBLE" val="0"/>
-  <p:tag name="KSO_WM_UNIT_DIAGRAM_ISNUMVISUAL" val="0"/>
-  <p:tag name="KSO_WM_UNIT_DIAGRAM_ISREFERUNIT" val="0"/>
-  <p:tag name="KSO_WM_UNIT_ID" val="_1**"/>
-  <p:tag name="KSO_WM_UNIT_LAYERLEVEL" val="1"/>
-  <p:tag name="KSO_WM_TAG_VERSION" val="1.0"/>
-  <p:tag name="KSO_WM_BEAUTIFY_FLAG" val="#wm#"/>
-</p:tagLst>
-</file>
-
-<file path=ppt/tags/tag10.xml><?xml version="1.0" encoding="utf-8"?>
-<p:tagLst xmlns:p="http://schemas.openxmlformats.org/presentationml/2006/main">
-  <p:tag name="KSO_WM_UNIT_HIGHLIGHT" val="0"/>
-  <p:tag name="KSO_WM_UNIT_COMPATIBLE" val="0"/>
-  <p:tag name="KSO_WM_UNIT_DIAGRAM_ISNUMVISUAL" val="0"/>
-  <p:tag name="KSO_WM_UNIT_DIAGRAM_ISREFERUNIT" val="0"/>
-  <p:tag name="KSO_WM_UNIT_ID" val="_2**"/>
-  <p:tag name="KSO_WM_UNIT_LAYERLEVEL" val="1"/>
-  <p:tag name="KSO_WM_TAG_VERSION" val="1.0"/>
-  <p:tag name="KSO_WM_BEAUTIFY_FLAG" val="#wm#"/>
-</p:tagLst>
-</file>
-
-<file path=ppt/tags/tag11.xml><?xml version="1.0" encoding="utf-8"?>
-<p:tagLst xmlns:p="http://schemas.openxmlformats.org/presentationml/2006/main">
-  <p:tag name="KSO_WM_UNIT_HIGHLIGHT" val="0"/>
-  <p:tag name="KSO_WM_UNIT_COMPATIBLE" val="0"/>
-  <p:tag name="KSO_WM_UNIT_DIAGRAM_ISNUMVISUAL" val="0"/>
-  <p:tag name="KSO_WM_UNIT_DIAGRAM_ISREFERUNIT" val="0"/>
-  <p:tag name="KSO_WM_UNIT_ID" val="_3**"/>
-  <p:tag name="KSO_WM_UNIT_LAYERLEVEL" val="1"/>
-  <p:tag name="KSO_WM_TAG_VERSION" val="1.0"/>
-  <p:tag name="KSO_WM_BEAUTIFY_FLAG" val="#wm#"/>
-</p:tagLst>
-</file>
-
-<file path=ppt/tags/tag12.xml><?xml version="1.0" encoding="utf-8"?>
-<p:tagLst xmlns:p="http://schemas.openxmlformats.org/presentationml/2006/main">
-  <p:tag name="KSO_WM_UNIT_HIGHLIGHT" val="0"/>
-  <p:tag name="KSO_WM_UNIT_COMPATIBLE" val="0"/>
-  <p:tag name="KSO_WM_UNIT_DIAGRAM_ISNUMVISUAL" val="0"/>
-  <p:tag name="KSO_WM_UNIT_DIAGRAM_ISREFERUNIT" val="0"/>
-  <p:tag name="KSO_WM_UNIT_ID" val="_3**"/>
-  <p:tag name="KSO_WM_UNIT_LAYERLEVEL" val="1"/>
-  <p:tag name="KSO_WM_TAG_VERSION" val="1.0"/>
-  <p:tag name="KSO_WM_BEAUTIFY_FLAG" val="#wm#"/>
-</p:tagLst>
-</file>
-
-<file path=ppt/tags/tag13.xml><?xml version="1.0" encoding="utf-8"?>
-<p:tagLst xmlns:p="http://schemas.openxmlformats.org/presentationml/2006/main">
-  <p:tag name="KSO_WM_UNIT_HIGHLIGHT" val="0"/>
-  <p:tag name="KSO_WM_UNIT_COMPATIBLE" val="0"/>
-  <p:tag name="KSO_WM_UNIT_DIAGRAM_ISNUMVISUAL" val="0"/>
-  <p:tag name="KSO_WM_UNIT_DIAGRAM_ISREFERUNIT" val="0"/>
-  <p:tag name="KSO_WM_UNIT_ID" val="_3**"/>
-  <p:tag name="KSO_WM_UNIT_LAYERLEVEL" val="1"/>
-  <p:tag name="KSO_WM_TAG_VERSION" val="1.0"/>
-  <p:tag name="KSO_WM_BEAUTIFY_FLAG" val="#wm#"/>
-</p:tagLst>
-</file>
-
-<file path=ppt/tags/tag14.xml><?xml version="1.0" encoding="utf-8"?>
-<p:tagLst xmlns:p="http://schemas.openxmlformats.org/presentationml/2006/main">
-  <p:tag name="KSO_WM_UNIT_HIGHLIGHT" val="0"/>
-  <p:tag name="KSO_WM_UNIT_COMPATIBLE" val="0"/>
-  <p:tag name="KSO_WM_UNIT_DIAGRAM_ISNUMVISUAL" val="0"/>
-  <p:tag name="KSO_WM_UNIT_DIAGRAM_ISREFERUNIT" val="0"/>
-  <p:tag name="KSO_WM_UNIT_ID" val="_3**"/>
-  <p:tag name="KSO_WM_UNIT_LAYERLEVEL" val="1"/>
-  <p:tag name="KSO_WM_TAG_VERSION" val="1.0"/>
-  <p:tag name="KSO_WM_BEAUTIFY_FLAG" val="#wm#"/>
-</p:tagLst>
-</file>
-
-<file path=ppt/tags/tag15.xml><?xml version="1.0" encoding="utf-8"?>
-<p:tagLst xmlns:p="http://schemas.openxmlformats.org/presentationml/2006/main">
-  <p:tag name="KSO_WM_UNIT_HIGHLIGHT" val="0"/>
-  <p:tag name="KSO_WM_UNIT_COMPATIBLE" val="0"/>
-  <p:tag name="KSO_WM_UNIT_DIAGRAM_ISNUMVISUAL" val="0"/>
-  <p:tag name="KSO_WM_UNIT_DIAGRAM_ISREFERUNIT" val="0"/>
-  <p:tag name="KSO_WM_UNIT_ID" val="_3**"/>
-  <p:tag name="KSO_WM_UNIT_LAYERLEVEL" val="1"/>
-  <p:tag name="KSO_WM_TAG_VERSION" val="1.0"/>
-  <p:tag name="KSO_WM_BEAUTIFY_FLAG" val="#wm#"/>
-</p:tagLst>
-</file>
-
-<file path=ppt/tags/tag16.xml><?xml version="1.0" encoding="utf-8"?>
-<p:tagLst xmlns:p="http://schemas.openxmlformats.org/presentationml/2006/main">
-  <p:tag name="KSO_WM_UNIT_HIGHLIGHT" val="0"/>
-  <p:tag name="KSO_WM_UNIT_COMPATIBLE" val="0"/>
-  <p:tag name="KSO_WM_UNIT_DIAGRAM_ISNUMVISUAL" val="0"/>
-  <p:tag name="KSO_WM_UNIT_DIAGRAM_ISREFERUNIT" val="0"/>
-  <p:tag name="KSO_WM_UNIT_ID" val="_4**"/>
-  <p:tag name="KSO_WM_UNIT_LAYERLEVEL" val="1"/>
-  <p:tag name="KSO_WM_TAG_VERSION" val="1.0"/>
-  <p:tag name="KSO_WM_BEAUTIFY_FLAG" val="#wm#"/>
-</p:tagLst>
-</file>
-
-<file path=ppt/tags/tag17.xml><?xml version="1.0" encoding="utf-8"?>
-<p:tagLst xmlns:p="http://schemas.openxmlformats.org/presentationml/2006/main">
-  <p:tag name="KSO_WM_UNIT_HIGHLIGHT" val="0"/>
-  <p:tag name="KSO_WM_UNIT_COMPATIBLE" val="0"/>
-  <p:tag name="KSO_WM_UNIT_DIAGRAM_ISNUMVISUAL" val="0"/>
-  <p:tag name="KSO_WM_UNIT_DIAGRAM_ISREFERUNIT" val="0"/>
-  <p:tag name="KSO_WM_UNIT_ID" val="_4**"/>
-  <p:tag name="KSO_WM_UNIT_LAYERLEVEL" val="1"/>
-  <p:tag name="KSO_WM_TAG_VERSION" val="1.0"/>
-  <p:tag name="KSO_WM_BEAUTIFY_FLAG" val="#wm#"/>
-</p:tagLst>
-</file>
-
-<file path=ppt/tags/tag18.xml><?xml version="1.0" encoding="utf-8"?>
-<p:tagLst xmlns:p="http://schemas.openxmlformats.org/presentationml/2006/main">
-  <p:tag name="KSO_WM_UNIT_HIGHLIGHT" val="0"/>
-  <p:tag name="KSO_WM_UNIT_COMPATIBLE" val="0"/>
-  <p:tag name="KSO_WM_UNIT_DIAGRAM_ISNUMVISUAL" val="0"/>
-  <p:tag name="KSO_WM_UNIT_DIAGRAM_ISREFERUNIT" val="0"/>
-  <p:tag name="KSO_WM_UNIT_ID" val="_4**"/>
-  <p:tag name="KSO_WM_UNIT_LAYERLEVEL" val="1"/>
-  <p:tag name="KSO_WM_TAG_VERSION" val="1.0"/>
-  <p:tag name="KSO_WM_BEAUTIFY_FLAG" val="#wm#"/>
-</p:tagLst>
-</file>
-
-<file path=ppt/tags/tag19.xml><?xml version="1.0" encoding="utf-8"?>
-<p:tagLst xmlns:p="http://schemas.openxmlformats.org/presentationml/2006/main">
-  <p:tag name="KSO_WM_UNIT_HIGHLIGHT" val="0"/>
-  <p:tag name="KSO_WM_UNIT_COMPATIBLE" val="0"/>
-  <p:tag name="KSO_WM_UNIT_DIAGRAM_ISNUMVISUAL" val="0"/>
-  <p:tag name="KSO_WM_UNIT_DIAGRAM_ISREFERUNIT" val="0"/>
-  <p:tag name="KSO_WM_UNIT_ID" val="_4**"/>
-  <p:tag name="KSO_WM_UNIT_LAYERLEVEL" val="1"/>
-  <p:tag name="KSO_WM_TAG_VERSION" val="1.0"/>
-  <p:tag name="KSO_WM_BEAUTIFY_FLAG" val="#wm#"/>
-</p:tagLst>
-</file>
-
-<file path=ppt/tags/tag2.xml><?xml version="1.0" encoding="utf-8"?>
-<p:tagLst xmlns:p="http://schemas.openxmlformats.org/presentationml/2006/main">
-  <p:tag name="KSO_WM_UNIT_HIGHLIGHT" val="0"/>
-  <p:tag name="KSO_WM_UNIT_COMPATIBLE" val="0"/>
-  <p:tag name="KSO_WM_UNIT_DIAGRAM_ISNUMVISUAL" val="0"/>
-  <p:tag name="KSO_WM_UNIT_DIAGRAM_ISREFERUNIT" val="0"/>
-  <p:tag name="KSO_WM_UNIT_ID" val="_1**"/>
-  <p:tag name="KSO_WM_UNIT_LAYERLEVEL" val="1"/>
-  <p:tag name="KSO_WM_TAG_VERSION" val="1.0"/>
-  <p:tag name="KSO_WM_BEAUTIFY_FLAG" val="#wm#"/>
-</p:tagLst>
-</file>
-
-<file path=ppt/tags/tag20.xml><?xml version="1.0" encoding="utf-8"?>
-<p:tagLst xmlns:p="http://schemas.openxmlformats.org/presentationml/2006/main">
-  <p:tag name="KSO_WM_UNIT_HIGHLIGHT" val="0"/>
-  <p:tag name="KSO_WM_UNIT_COMPATIBLE" val="0"/>
-  <p:tag name="KSO_WM_UNIT_DIAGRAM_ISNUMVISUAL" val="0"/>
-  <p:tag name="KSO_WM_UNIT_DIAGRAM_ISREFERUNIT" val="0"/>
-  <p:tag name="KSO_WM_UNIT_ID" val="_4**"/>
-  <p:tag name="KSO_WM_UNIT_LAYERLEVEL" val="1"/>
-  <p:tag name="KSO_WM_TAG_VERSION" val="1.0"/>
-  <p:tag name="KSO_WM_BEAUTIFY_FLAG" val="#wm#"/>
-</p:tagLst>
-</file>
-
-<file path=ppt/tags/tag21.xml><?xml version="1.0" encoding="utf-8"?>
-<p:tagLst xmlns:p="http://schemas.openxmlformats.org/presentationml/2006/main">
-  <p:tag name="KSO_WM_UNIT_HIGHLIGHT" val="0"/>
-  <p:tag name="KSO_WM_UNIT_COMPATIBLE" val="0"/>
-  <p:tag name="KSO_WM_UNIT_DIAGRAM_ISNUMVISUAL" val="0"/>
-  <p:tag name="KSO_WM_UNIT_DIAGRAM_ISREFERUNIT" val="0"/>
-  <p:tag name="KSO_WM_UNIT_ID" val="_4**"/>
-  <p:tag name="KSO_WM_UNIT_LAYERLEVEL" val="1"/>
-  <p:tag name="KSO_WM_TAG_VERSION" val="1.0"/>
-  <p:tag name="KSO_WM_BEAUTIFY_FLAG" val="#wm#"/>
-</p:tagLst>
-</file>
-
-<file path=ppt/tags/tag22.xml><?xml version="1.0" encoding="utf-8"?>
-<p:tagLst xmlns:p="http://schemas.openxmlformats.org/presentationml/2006/main">
-  <p:tag name="KSO_WM_UNIT_HIGHLIGHT" val="0"/>
-  <p:tag name="KSO_WM_UNIT_COMPATIBLE" val="0"/>
-  <p:tag name="KSO_WM_UNIT_DIAGRAM_ISNUMVISUAL" val="0"/>
-  <p:tag name="KSO_WM_UNIT_DIAGRAM_ISREFERUNIT" val="0"/>
-  <p:tag name="KSO_WM_UNIT_ID" val="_5**"/>
-  <p:tag name="KSO_WM_UNIT_LAYERLEVEL" val="1"/>
-  <p:tag name="KSO_WM_TAG_VERSION" val="1.0"/>
-  <p:tag name="KSO_WM_BEAUTIFY_FLAG" val="#wm#"/>
-</p:tagLst>
-</file>
-
-<file path=ppt/tags/tag23.xml><?xml version="1.0" encoding="utf-8"?>
-<p:tagLst xmlns:p="http://schemas.openxmlformats.org/presentationml/2006/main">
-  <p:tag name="KSO_WM_UNIT_HIGHLIGHT" val="0"/>
-  <p:tag name="KSO_WM_UNIT_COMPATIBLE" val="0"/>
-  <p:tag name="KSO_WM_UNIT_DIAGRAM_ISNUMVISUAL" val="0"/>
-  <p:tag name="KSO_WM_UNIT_DIAGRAM_ISREFERUNIT" val="0"/>
-  <p:tag name="KSO_WM_UNIT_ID" val="_5**"/>
-  <p:tag name="KSO_WM_UNIT_LAYERLEVEL" val="1"/>
-  <p:tag name="KSO_WM_TAG_VERSION" val="1.0"/>
-  <p:tag name="KSO_WM_BEAUTIFY_FLAG" val="#wm#"/>
-</p:tagLst>
-</file>
-
-<file path=ppt/tags/tag24.xml><?xml version="1.0" encoding="utf-8"?>
-<p:tagLst xmlns:p="http://schemas.openxmlformats.org/presentationml/2006/main">
-  <p:tag name="KSO_WM_UNIT_HIGHLIGHT" val="0"/>
-  <p:tag name="KSO_WM_UNIT_COMPATIBLE" val="0"/>
-  <p:tag name="KSO_WM_UNIT_DIAGRAM_ISNUMVISUAL" val="0"/>
-  <p:tag name="KSO_WM_UNIT_DIAGRAM_ISREFERUNIT" val="0"/>
-  <p:tag name="KSO_WM_UNIT_ID" val="_5**"/>
-  <p:tag name="KSO_WM_UNIT_LAYERLEVEL" val="1"/>
-  <p:tag name="KSO_WM_TAG_VERSION" val="1.0"/>
-  <p:tag name="KSO_WM_BEAUTIFY_FLAG" val="#wm#"/>
-</p:tagLst>
-</file>
-
-<file path=ppt/tags/tag25.xml><?xml version="1.0" encoding="utf-8"?>
-<p:tagLst xmlns:p="http://schemas.openxmlformats.org/presentationml/2006/main">
-  <p:tag name="KSO_WM_UNIT_HIGHLIGHT" val="0"/>
-  <p:tag name="KSO_WM_UNIT_COMPATIBLE" val="0"/>
-  <p:tag name="KSO_WM_UNIT_DIAGRAM_ISNUMVISUAL" val="0"/>
-  <p:tag name="KSO_WM_UNIT_DIAGRAM_ISREFERUNIT" val="0"/>
-  <p:tag name="KSO_WM_UNIT_ID" val="_5**"/>
-  <p:tag name="KSO_WM_UNIT_LAYERLEVEL" val="1"/>
-  <p:tag name="KSO_WM_TAG_VERSION" val="1.0"/>
-  <p:tag name="KSO_WM_BEAUTIFY_FLAG" val="#wm#"/>
-</p:tagLst>
-</file>
-
-<file path=ppt/tags/tag26.xml><?xml version="1.0" encoding="utf-8"?>
-<p:tagLst xmlns:p="http://schemas.openxmlformats.org/presentationml/2006/main">
-  <p:tag name="KSO_WM_UNIT_HIGHLIGHT" val="0"/>
-  <p:tag name="KSO_WM_UNIT_COMPATIBLE" val="0"/>
-  <p:tag name="KSO_WM_UNIT_DIAGRAM_ISNUMVISUAL" val="0"/>
-  <p:tag name="KSO_WM_UNIT_DIAGRAM_ISREFERUNIT" val="0"/>
-  <p:tag name="KSO_WM_UNIT_ID" val="_5**"/>
-  <p:tag name="KSO_WM_UNIT_LAYERLEVEL" val="1"/>
-  <p:tag name="KSO_WM_TAG_VERSION" val="1.0"/>
-  <p:tag name="KSO_WM_BEAUTIFY_FLAG" val="#wm#"/>
-</p:tagLst>
-</file>
-
-<file path=ppt/tags/tag27.xml><?xml version="1.0" encoding="utf-8"?>
-<p:tagLst xmlns:p="http://schemas.openxmlformats.org/presentationml/2006/main">
-  <p:tag name="KSO_WM_UNIT_HIGHLIGHT" val="0"/>
-  <p:tag name="KSO_WM_UNIT_COMPATIBLE" val="0"/>
-  <p:tag name="KSO_WM_UNIT_DIAGRAM_ISNUMVISUAL" val="0"/>
-  <p:tag name="KSO_WM_UNIT_DIAGRAM_ISREFERUNIT" val="0"/>
-  <p:tag name="KSO_WM_UNIT_ID" val="_5**"/>
-  <p:tag name="KSO_WM_UNIT_LAYERLEVEL" val="1"/>
-  <p:tag name="KSO_WM_TAG_VERSION" val="1.0"/>
-  <p:tag name="KSO_WM_BEAUTIFY_FLAG" val="#wm#"/>
-</p:tagLst>
-</file>
-
-<file path=ppt/tags/tag28.xml><?xml version="1.0" encoding="utf-8"?>
-<p:tagLst xmlns:p="http://schemas.openxmlformats.org/presentationml/2006/main">
-  <p:tag name="KSO_WM_UNIT_HIGHLIGHT" val="0"/>
-  <p:tag name="KSO_WM_UNIT_COMPATIBLE" val="0"/>
-  <p:tag name="KSO_WM_UNIT_DIAGRAM_ISNUMVISUAL" val="0"/>
-  <p:tag name="KSO_WM_UNIT_DIAGRAM_ISREFERUNIT" val="0"/>
-  <p:tag name="KSO_WM_UNIT_ID" val="_5**"/>
-  <p:tag name="KSO_WM_UNIT_LAYERLEVEL" val="1"/>
-  <p:tag name="KSO_WM_TAG_VERSION" val="1.0"/>
-  <p:tag name="KSO_WM_BEAUTIFY_FLAG" val="#wm#"/>
-</p:tagLst>
-</file>
-
-<file path=ppt/tags/tag29.xml><?xml version="1.0" encoding="utf-8"?>
-<p:tagLst xmlns:p="http://schemas.openxmlformats.org/presentationml/2006/main">
-  <p:tag name="KSO_WM_UNIT_HIGHLIGHT" val="0"/>
-  <p:tag name="KSO_WM_UNIT_COMPATIBLE" val="0"/>
-  <p:tag name="KSO_WM_UNIT_DIAGRAM_ISNUMVISUAL" val="0"/>
-  <p:tag name="KSO_WM_UNIT_DIAGRAM_ISREFERUNIT" val="0"/>
-  <p:tag name="KSO_WM_UNIT_ID" val="_5**"/>
-  <p:tag name="KSO_WM_UNIT_LAYERLEVEL" val="1"/>
-  <p:tag name="KSO_WM_TAG_VERSION" val="1.0"/>
-  <p:tag name="KSO_WM_BEAUTIFY_FLAG" val="#wm#"/>
-</p:tagLst>
-</file>
-
-<file path=ppt/tags/tag3.xml><?xml version="1.0" encoding="utf-8"?>
-<p:tagLst xmlns:p="http://schemas.openxmlformats.org/presentationml/2006/main">
-  <p:tag name="KSO_WM_UNIT_HIGHLIGHT" val="0"/>
-  <p:tag name="KSO_WM_UNIT_COMPATIBLE" val="0"/>
-  <p:tag name="KSO_WM_UNIT_DIAGRAM_ISNUMVISUAL" val="0"/>
-  <p:tag name="KSO_WM_UNIT_DIAGRAM_ISREFERUNIT" val="0"/>
-  <p:tag name="KSO_WM_UNIT_ID" val="_1**"/>
-  <p:tag name="KSO_WM_UNIT_LAYERLEVEL" val="1"/>
-  <p:tag name="KSO_WM_TAG_VERSION" val="1.0"/>
-  <p:tag name="KSO_WM_BEAUTIFY_FLAG" val="#wm#"/>
-</p:tagLst>
-</file>
-
-<file path=ppt/tags/tag30.xml><?xml version="1.0" encoding="utf-8"?>
-<p:tagLst xmlns:p="http://schemas.openxmlformats.org/presentationml/2006/main">
-  <p:tag name="KSO_WM_UNIT_HIGHLIGHT" val="0"/>
-  <p:tag name="KSO_WM_UNIT_COMPATIBLE" val="0"/>
-  <p:tag name="KSO_WM_UNIT_DIAGRAM_ISNUMVISUAL" val="0"/>
-  <p:tag name="KSO_WM_UNIT_DIAGRAM_ISREFERUNIT" val="0"/>
-  <p:tag name="KSO_WM_UNIT_ID" val="_6**"/>
-  <p:tag name="KSO_WM_UNIT_LAYERLEVEL" val="1"/>
-  <p:tag name="KSO_WM_TAG_VERSION" val="1.0"/>
-  <p:tag name="KSO_WM_BEAUTIFY_FLAG" val="#wm#"/>
-</p:tagLst>
-</file>
-
-<file path=ppt/tags/tag31.xml><?xml version="1.0" encoding="utf-8"?>
-<p:tagLst xmlns:p="http://schemas.openxmlformats.org/presentationml/2006/main">
-  <p:tag name="KSO_WM_UNIT_HIGHLIGHT" val="0"/>
-  <p:tag name="KSO_WM_UNIT_COMPATIBLE" val="0"/>
-  <p:tag name="KSO_WM_UNIT_DIAGRAM_ISNUMVISUAL" val="0"/>
-  <p:tag name="KSO_WM_UNIT_DIAGRAM_ISREFERUNIT" val="0"/>
-  <p:tag name="KSO_WM_UNIT_ID" val="_6**"/>
-  <p:tag name="KSO_WM_UNIT_LAYERLEVEL" val="1"/>
-  <p:tag name="KSO_WM_TAG_VERSION" val="1.0"/>
-  <p:tag name="KSO_WM_BEAUTIFY_FLAG" val="#wm#"/>
-</p:tagLst>
-</file>
-
-<file path=ppt/tags/tag32.xml><?xml version="1.0" encoding="utf-8"?>
-<p:tagLst xmlns:p="http://schemas.openxmlformats.org/presentationml/2006/main">
-  <p:tag name="KSO_WM_UNIT_HIGHLIGHT" val="0"/>
-  <p:tag name="KSO_WM_UNIT_COMPATIBLE" val="0"/>
-  <p:tag name="KSO_WM_UNIT_DIAGRAM_ISNUMVISUAL" val="0"/>
-  <p:tag name="KSO_WM_UNIT_DIAGRAM_ISREFERUNIT" val="0"/>
-  <p:tag name="KSO_WM_UNIT_ID" val="_6**"/>
-  <p:tag name="KSO_WM_UNIT_LAYERLEVEL" val="1"/>
-  <p:tag name="KSO_WM_TAG_VERSION" val="1.0"/>
-  <p:tag name="KSO_WM_BEAUTIFY_FLAG" val="#wm#"/>
-</p:tagLst>
-</file>
-
-<file path=ppt/tags/tag33.xml><?xml version="1.0" encoding="utf-8"?>
-<p:tagLst xmlns:p="http://schemas.openxmlformats.org/presentationml/2006/main">
-  <p:tag name="KSO_WM_UNIT_HIGHLIGHT" val="0"/>
-  <p:tag name="KSO_WM_UNIT_COMPATIBLE" val="0"/>
-  <p:tag name="KSO_WM_UNIT_DIAGRAM_ISNUMVISUAL" val="0"/>
-  <p:tag name="KSO_WM_UNIT_DIAGRAM_ISREFERUNIT" val="0"/>
-  <p:tag name="KSO_WM_UNIT_ID" val="_6**"/>
-  <p:tag name="KSO_WM_UNIT_LAYERLEVEL" val="1"/>
-  <p:tag name="KSO_WM_TAG_VERSION" val="1.0"/>
-  <p:tag name="KSO_WM_BEAUTIFY_FLAG" val="#wm#"/>
-</p:tagLst>
-</file>
-
-<file path=ppt/tags/tag34.xml><?xml version="1.0" encoding="utf-8"?>
-<p:tagLst xmlns:p="http://schemas.openxmlformats.org/presentationml/2006/main">
-  <p:tag name="KSO_WM_UNIT_HIGHLIGHT" val="0"/>
-  <p:tag name="KSO_WM_UNIT_COMPATIBLE" val="0"/>
-  <p:tag name="KSO_WM_UNIT_DIAGRAM_ISNUMVISUAL" val="0"/>
-  <p:tag name="KSO_WM_UNIT_DIAGRAM_ISREFERUNIT" val="0"/>
-  <p:tag name="KSO_WM_UNIT_ID" val="_7**"/>
-  <p:tag name="KSO_WM_UNIT_LAYERLEVEL" val="1"/>
-  <p:tag name="KSO_WM_TAG_VERSION" val="1.0"/>
-  <p:tag name="KSO_WM_BEAUTIFY_FLAG" val="#wm#"/>
-</p:tagLst>
-</file>
-
-<file path=ppt/tags/tag35.xml><?xml version="1.0" encoding="utf-8"?>
-<p:tagLst xmlns:p="http://schemas.openxmlformats.org/presentationml/2006/main">
-  <p:tag name="KSO_WM_UNIT_HIGHLIGHT" val="0"/>
-  <p:tag name="KSO_WM_UNIT_COMPATIBLE" val="0"/>
-  <p:tag name="KSO_WM_UNIT_DIAGRAM_ISNUMVISUAL" val="0"/>
-  <p:tag name="KSO_WM_UNIT_DIAGRAM_ISREFERUNIT" val="0"/>
-  <p:tag name="KSO_WM_UNIT_ID" val="_7**"/>
-  <p:tag name="KSO_WM_UNIT_LAYERLEVEL" val="1"/>
-  <p:tag name="KSO_WM_TAG_VERSION" val="1.0"/>
-  <p:tag name="KSO_WM_BEAUTIFY_FLAG" val="#wm#"/>
-</p:tagLst>
-</file>
-
-<file path=ppt/tags/tag36.xml><?xml version="1.0" encoding="utf-8"?>
-<p:tagLst xmlns:p="http://schemas.openxmlformats.org/presentationml/2006/main">
-  <p:tag name="KSO_WM_UNIT_HIGHLIGHT" val="0"/>
-  <p:tag name="KSO_WM_UNIT_COMPATIBLE" val="0"/>
-  <p:tag name="KSO_WM_UNIT_DIAGRAM_ISNUMVISUAL" val="0"/>
-  <p:tag name="KSO_WM_UNIT_DIAGRAM_ISREFERUNIT" val="0"/>
-  <p:tag name="KSO_WM_UNIT_ID" val="_7**"/>
-  <p:tag name="KSO_WM_UNIT_LAYERLEVEL" val="1"/>
-  <p:tag name="KSO_WM_TAG_VERSION" val="1.0"/>
-  <p:tag name="KSO_WM_BEAUTIFY_FLAG" val="#wm#"/>
-</p:tagLst>
-</file>
-
-<file path=ppt/tags/tag37.xml><?xml version="1.0" encoding="utf-8"?>
-<p:tagLst xmlns:p="http://schemas.openxmlformats.org/presentationml/2006/main">
-  <p:tag name="KSO_WM_UNIT_HIGHLIGHT" val="0"/>
-  <p:tag name="KSO_WM_UNIT_COMPATIBLE" val="0"/>
-  <p:tag name="KSO_WM_UNIT_DIAGRAM_ISNUMVISUAL" val="0"/>
-  <p:tag name="KSO_WM_UNIT_DIAGRAM_ISREFERUNIT" val="0"/>
-  <p:tag name="KSO_WM_UNIT_ID" val="_8**"/>
-  <p:tag name="KSO_WM_UNIT_LAYERLEVEL" val="1"/>
-  <p:tag name="KSO_WM_TAG_VERSION" val="1.0"/>
-  <p:tag name="KSO_WM_BEAUTIFY_FLAG" val="#wm#"/>
-</p:tagLst>
-</file>
-
-<file path=ppt/tags/tag38.xml><?xml version="1.0" encoding="utf-8"?>
-<p:tagLst xmlns:p="http://schemas.openxmlformats.org/presentationml/2006/main">
-  <p:tag name="KSO_WM_UNIT_HIGHLIGHT" val="0"/>
-  <p:tag name="KSO_WM_UNIT_COMPATIBLE" val="0"/>
-  <p:tag name="KSO_WM_UNIT_DIAGRAM_ISNUMVISUAL" val="0"/>
-  <p:tag name="KSO_WM_UNIT_DIAGRAM_ISREFERUNIT" val="0"/>
-  <p:tag name="KSO_WM_UNIT_ID" val="_8**"/>
-  <p:tag name="KSO_WM_UNIT_LAYERLEVEL" val="1"/>
-  <p:tag name="KSO_WM_TAG_VERSION" val="1.0"/>
-  <p:tag name="KSO_WM_BEAUTIFY_FLAG" val="#wm#"/>
-</p:tagLst>
-</file>
-
-<file path=ppt/tags/tag39.xml><?xml version="1.0" encoding="utf-8"?>
-<p:tagLst xmlns:p="http://schemas.openxmlformats.org/presentationml/2006/main">
-  <p:tag name="KSO_WM_UNIT_HIGHLIGHT" val="0"/>
-  <p:tag name="KSO_WM_UNIT_COMPATIBLE" val="0"/>
-  <p:tag name="KSO_WM_UNIT_DIAGRAM_ISNUMVISUAL" val="0"/>
-  <p:tag name="KSO_WM_UNIT_DIAGRAM_ISREFERUNIT" val="0"/>
-  <p:tag name="KSO_WM_UNIT_ID" val="_8**"/>
-  <p:tag name="KSO_WM_UNIT_LAYERLEVEL" val="1"/>
-  <p:tag name="KSO_WM_TAG_VERSION" val="1.0"/>
-  <p:tag name="KSO_WM_BEAUTIFY_FLAG" val="#wm#"/>
-</p:tagLst>
-</file>
-
-<file path=ppt/tags/tag4.xml><?xml version="1.0" encoding="utf-8"?>
-<p:tagLst xmlns:p="http://schemas.openxmlformats.org/presentationml/2006/main">
-  <p:tag name="KSO_WM_UNIT_HIGHLIGHT" val="0"/>
-  <p:tag name="KSO_WM_UNIT_COMPATIBLE" val="0"/>
-  <p:tag name="KSO_WM_UNIT_DIAGRAM_ISNUMVISUAL" val="0"/>
-  <p:tag name="KSO_WM_UNIT_DIAGRAM_ISREFERUNIT" val="0"/>
-  <p:tag name="KSO_WM_UNIT_ID" val="_1**"/>
-  <p:tag name="KSO_WM_UNIT_LAYERLEVEL" val="1"/>
-  <p:tag name="KSO_WM_TAG_VERSION" val="1.0"/>
-  <p:tag name="KSO_WM_BEAUTIFY_FLAG" val="#wm#"/>
-</p:tagLst>
-</file>
-
-<file path=ppt/tags/tag40.xml><?xml version="1.0" encoding="utf-8"?>
-<p:tagLst xmlns:p="http://schemas.openxmlformats.org/presentationml/2006/main">
-  <p:tag name="KSO_WM_UNIT_HIGHLIGHT" val="0"/>
-  <p:tag name="KSO_WM_UNIT_COMPATIBLE" val="0"/>
-  <p:tag name="KSO_WM_UNIT_DIAGRAM_ISNUMVISUAL" val="0"/>
-  <p:tag name="KSO_WM_UNIT_DIAGRAM_ISREFERUNIT" val="0"/>
-  <p:tag name="KSO_WM_UNIT_ID" val="_8**"/>
-  <p:tag name="KSO_WM_UNIT_LAYERLEVEL" val="1"/>
-  <p:tag name="KSO_WM_TAG_VERSION" val="1.0"/>
-  <p:tag name="KSO_WM_BEAUTIFY_FLAG" val="#wm#"/>
-</p:tagLst>
-</file>
-
-<file path=ppt/tags/tag41.xml><?xml version="1.0" encoding="utf-8"?>
-<p:tagLst xmlns:p="http://schemas.openxmlformats.org/presentationml/2006/main">
-  <p:tag name="KSO_WM_UNIT_HIGHLIGHT" val="0"/>
-  <p:tag name="KSO_WM_UNIT_COMPATIBLE" val="0"/>
-  <p:tag name="KSO_WM_UNIT_DIAGRAM_ISNUMVISUAL" val="0"/>
-  <p:tag name="KSO_WM_UNIT_DIAGRAM_ISREFERUNIT" val="0"/>
-  <p:tag name="KSO_WM_UNIT_ID" val="_8**"/>
-  <p:tag name="KSO_WM_UNIT_LAYERLEVEL" val="1"/>
-  <p:tag name="KSO_WM_TAG_VERSION" val="1.0"/>
-  <p:tag name="KSO_WM_BEAUTIFY_FLAG" val="#wm#"/>
-</p:tagLst>
-</file>
-
-<file path=ppt/tags/tag42.xml><?xml version="1.0" encoding="utf-8"?>
-<p:tagLst xmlns:p="http://schemas.openxmlformats.org/presentationml/2006/main">
-  <p:tag name="KSO_WM_UNIT_HIGHLIGHT" val="0"/>
-  <p:tag name="KSO_WM_UNIT_COMPATIBLE" val="0"/>
-  <p:tag name="KSO_WM_UNIT_DIAGRAM_ISNUMVISUAL" val="0"/>
-  <p:tag name="KSO_WM_UNIT_DIAGRAM_ISREFERUNIT" val="0"/>
-  <p:tag name="KSO_WM_UNIT_ID" val="_8**"/>
-  <p:tag name="KSO_WM_UNIT_LAYERLEVEL" val="1"/>
-  <p:tag name="KSO_WM_TAG_VERSION" val="1.0"/>
-  <p:tag name="KSO_WM_BEAUTIFY_FLAG" val="#wm#"/>
-</p:tagLst>
-</file>
-
-<file path=ppt/tags/tag43.xml><?xml version="1.0" encoding="utf-8"?>
-<p:tagLst xmlns:p="http://schemas.openxmlformats.org/presentationml/2006/main">
-  <p:tag name="KSO_WM_UNIT_HIGHLIGHT" val="0"/>
-  <p:tag name="KSO_WM_UNIT_COMPATIBLE" val="0"/>
-  <p:tag name="KSO_WM_UNIT_DIAGRAM_ISNUMVISUAL" val="0"/>
-  <p:tag name="KSO_WM_UNIT_DIAGRAM_ISREFERUNIT" val="0"/>
-  <p:tag name="KSO_WM_UNIT_ID" val="_9**"/>
-  <p:tag name="KSO_WM_UNIT_LAYERLEVEL" val="1"/>
-  <p:tag name="KSO_WM_TAG_VERSION" val="1.0"/>
-  <p:tag name="KSO_WM_BEAUTIFY_FLAG" val="#wm#"/>
-</p:tagLst>
-</file>
-
-<file path=ppt/tags/tag44.xml><?xml version="1.0" encoding="utf-8"?>
-<p:tagLst xmlns:p="http://schemas.openxmlformats.org/presentationml/2006/main">
-  <p:tag name="KSO_WM_UNIT_HIGHLIGHT" val="0"/>
-  <p:tag name="KSO_WM_UNIT_COMPATIBLE" val="0"/>
-  <p:tag name="KSO_WM_UNIT_DIAGRAM_ISNUMVISUAL" val="0"/>
-  <p:tag name="KSO_WM_UNIT_DIAGRAM_ISREFERUNIT" val="0"/>
-  <p:tag name="KSO_WM_UNIT_ID" val="_9**"/>
-  <p:tag name="KSO_WM_UNIT_LAYERLEVEL" val="1"/>
-  <p:tag name="KSO_WM_TAG_VERSION" val="1.0"/>
-  <p:tag name="KSO_WM_BEAUTIFY_FLAG" val="#wm#"/>
-</p:tagLst>
-</file>
-
-<file path=ppt/tags/tag45.xml><?xml version="1.0" encoding="utf-8"?>
-<p:tagLst xmlns:p="http://schemas.openxmlformats.org/presentationml/2006/main">
-  <p:tag name="KSO_WM_UNIT_HIGHLIGHT" val="0"/>
-  <p:tag name="KSO_WM_UNIT_COMPATIBLE" val="0"/>
-  <p:tag name="KSO_WM_UNIT_DIAGRAM_ISNUMVISUAL" val="0"/>
-  <p:tag name="KSO_WM_UNIT_DIAGRAM_ISREFERUNIT" val="0"/>
-  <p:tag name="KSO_WM_UNIT_ID" val="_9**"/>
-  <p:tag name="KSO_WM_UNIT_LAYERLEVEL" val="1"/>
-  <p:tag name="KSO_WM_TAG_VERSION" val="1.0"/>
-  <p:tag name="KSO_WM_BEAUTIFY_FLAG" val="#wm#"/>
-</p:tagLst>
-</file>
-
-<file path=ppt/tags/tag46.xml><?xml version="1.0" encoding="utf-8"?>
-<p:tagLst xmlns:p="http://schemas.openxmlformats.org/presentationml/2006/main">
-  <p:tag name="KSO_WM_UNIT_HIGHLIGHT" val="0"/>
-  <p:tag name="KSO_WM_UNIT_COMPATIBLE" val="0"/>
-  <p:tag name="KSO_WM_UNIT_DIAGRAM_ISNUMVISUAL" val="0"/>
-  <p:tag name="KSO_WM_UNIT_DIAGRAM_ISREFERUNIT" val="0"/>
-  <p:tag name="KSO_WM_UNIT_ID" val="_9**"/>
-  <p:tag name="KSO_WM_UNIT_LAYERLEVEL" val="1"/>
-  <p:tag name="KSO_WM_TAG_VERSION" val="1.0"/>
-  <p:tag name="KSO_WM_BEAUTIFY_FLAG" val="#wm#"/>
-</p:tagLst>
-</file>
-
-<file path=ppt/tags/tag47.xml><?xml version="1.0" encoding="utf-8"?>
-<p:tagLst xmlns:p="http://schemas.openxmlformats.org/presentationml/2006/main">
-  <p:tag name="KSO_WM_UNIT_HIGHLIGHT" val="0"/>
-  <p:tag name="KSO_WM_UNIT_COMPATIBLE" val="0"/>
-  <p:tag name="KSO_WM_UNIT_DIAGRAM_ISNUMVISUAL" val="0"/>
-  <p:tag name="KSO_WM_UNIT_DIAGRAM_ISREFERUNIT" val="0"/>
-  <p:tag name="KSO_WM_UNIT_ID" val="_9**"/>
-  <p:tag name="KSO_WM_UNIT_LAYERLEVEL" val="1"/>
-  <p:tag name="KSO_WM_TAG_VERSION" val="1.0"/>
-  <p:tag name="KSO_WM_BEAUTIFY_FLAG" val="#wm#"/>
-</p:tagLst>
-</file>
-
-<file path=ppt/tags/tag48.xml><?xml version="1.0" encoding="utf-8"?>
-<p:tagLst xmlns:p="http://schemas.openxmlformats.org/presentationml/2006/main">
-  <p:tag name="KSO_WM_UNIT_HIGHLIGHT" val="0"/>
-  <p:tag name="KSO_WM_UNIT_COMPATIBLE" val="0"/>
-  <p:tag name="KSO_WM_UNIT_DIAGRAM_ISNUMVISUAL" val="0"/>
-  <p:tag name="KSO_WM_UNIT_DIAGRAM_ISREFERUNIT" val="0"/>
-  <p:tag name="KSO_WM_UNIT_ID" val="_10**"/>
-  <p:tag name="KSO_WM_UNIT_LAYERLEVEL" val="1"/>
-  <p:tag name="KSO_WM_TAG_VERSION" val="1.0"/>
-  <p:tag name="KSO_WM_BEAUTIFY_FLAG" val="#wm#"/>
-</p:tagLst>
-</file>
-
-<file path=ppt/tags/tag49.xml><?xml version="1.0" encoding="utf-8"?>
-<p:tagLst xmlns:p="http://schemas.openxmlformats.org/presentationml/2006/main">
-  <p:tag name="KSO_WM_UNIT_HIGHLIGHT" val="0"/>
-  <p:tag name="KSO_WM_UNIT_COMPATIBLE" val="0"/>
-  <p:tag name="KSO_WM_UNIT_DIAGRAM_ISNUMVISUAL" val="0"/>
-  <p:tag name="KSO_WM_UNIT_DIAGRAM_ISREFERUNIT" val="0"/>
-  <p:tag name="KSO_WM_UNIT_ID" val="_10**"/>
-  <p:tag name="KSO_WM_UNIT_LAYERLEVEL" val="1"/>
-  <p:tag name="KSO_WM_TAG_VERSION" val="1.0"/>
-  <p:tag name="KSO_WM_BEAUTIFY_FLAG" val="#wm#"/>
-</p:tagLst>
-</file>
-
-<file path=ppt/tags/tag5.xml><?xml version="1.0" encoding="utf-8"?>
-<p:tagLst xmlns:p="http://schemas.openxmlformats.org/presentationml/2006/main">
-  <p:tag name="KSO_WM_UNIT_HIGHLIGHT" val="0"/>
-  <p:tag name="KSO_WM_UNIT_COMPATIBLE" val="0"/>
-  <p:tag name="KSO_WM_UNIT_DIAGRAM_ISNUMVISUAL" val="0"/>
-  <p:tag name="KSO_WM_UNIT_DIAGRAM_ISREFERUNIT" val="0"/>
-  <p:tag name="KSO_WM_UNIT_ID" val="_1**"/>
-  <p:tag name="KSO_WM_UNIT_LAYERLEVEL" val="1"/>
-  <p:tag name="KSO_WM_TAG_VERSION" val="1.0"/>
-  <p:tag name="KSO_WM_BEAUTIFY_FLAG" val="#wm#"/>
-</p:tagLst>
-</file>
-
-<file path=ppt/tags/tag50.xml><?xml version="1.0" encoding="utf-8"?>
-<p:tagLst xmlns:p="http://schemas.openxmlformats.org/presentationml/2006/main">
-  <p:tag name="KSO_WM_UNIT_HIGHLIGHT" val="0"/>
-  <p:tag name="KSO_WM_UNIT_COMPATIBLE" val="0"/>
-  <p:tag name="KSO_WM_UNIT_DIAGRAM_ISNUMVISUAL" val="0"/>
-  <p:tag name="KSO_WM_UNIT_DIAGRAM_ISREFERUNIT" val="0"/>
-  <p:tag name="KSO_WM_UNIT_ID" val="_10**"/>
-  <p:tag name="KSO_WM_UNIT_LAYERLEVEL" val="1"/>
-  <p:tag name="KSO_WM_TAG_VERSION" val="1.0"/>
-  <p:tag name="KSO_WM_BEAUTIFY_FLAG" val="#wm#"/>
-</p:tagLst>
-</file>
-
-<file path=ppt/tags/tag51.xml><?xml version="1.0" encoding="utf-8"?>
-<p:tagLst xmlns:p="http://schemas.openxmlformats.org/presentationml/2006/main">
-  <p:tag name="KSO_WM_UNIT_HIGHLIGHT" val="0"/>
-  <p:tag name="KSO_WM_UNIT_COMPATIBLE" val="0"/>
-  <p:tag name="KSO_WM_UNIT_DIAGRAM_ISNUMVISUAL" val="0"/>
-  <p:tag name="KSO_WM_UNIT_DIAGRAM_ISREFERUNIT" val="0"/>
-  <p:tag name="KSO_WM_UNIT_ID" val="_10**"/>
-  <p:tag name="KSO_WM_UNIT_LAYERLEVEL" val="1"/>
-  <p:tag name="KSO_WM_TAG_VERSION" val="1.0"/>
-  <p:tag name="KSO_WM_BEAUTIFY_FLAG" val="#wm#"/>
-</p:tagLst>
-</file>
-
-<file path=ppt/tags/tag52.xml><?xml version="1.0" encoding="utf-8"?>
-<p:tagLst xmlns:p="http://schemas.openxmlformats.org/presentationml/2006/main">
-  <p:tag name="KSO_WM_UNIT_HIGHLIGHT" val="0"/>
-  <p:tag name="KSO_WM_UNIT_COMPATIBLE" val="0"/>
-  <p:tag name="KSO_WM_UNIT_DIAGRAM_ISNUMVISUAL" val="0"/>
-  <p:tag name="KSO_WM_UNIT_DIAGRAM_ISREFERUNIT" val="0"/>
-  <p:tag name="KSO_WM_UNIT_ID" val="_11**"/>
-  <p:tag name="KSO_WM_UNIT_LAYERLEVEL" val="1"/>
-  <p:tag name="KSO_WM_TAG_VERSION" val="1.0"/>
-  <p:tag name="KSO_WM_BEAUTIFY_FLAG" val="#wm#"/>
-</p:tagLst>
-</file>
-
-<file path=ppt/tags/tag53.xml><?xml version="1.0" encoding="utf-8"?>
-<p:tagLst xmlns:p="http://schemas.openxmlformats.org/presentationml/2006/main">
-  <p:tag name="KSO_WM_UNIT_HIGHLIGHT" val="0"/>
-  <p:tag name="KSO_WM_UNIT_COMPATIBLE" val="0"/>
-  <p:tag name="KSO_WM_UNIT_DIAGRAM_ISNUMVISUAL" val="0"/>
-  <p:tag name="KSO_WM_UNIT_DIAGRAM_ISREFERUNIT" val="0"/>
-  <p:tag name="KSO_WM_UNIT_ID" val="_11**"/>
-  <p:tag name="KSO_WM_UNIT_LAYERLEVEL" val="1"/>
-  <p:tag name="KSO_WM_TAG_VERSION" val="1.0"/>
-  <p:tag name="KSO_WM_BEAUTIFY_FLAG" val="#wm#"/>
-</p:tagLst>
-</file>
-
-<file path=ppt/tags/tag54.xml><?xml version="1.0" encoding="utf-8"?>
-<p:tagLst xmlns:p="http://schemas.openxmlformats.org/presentationml/2006/main">
-  <p:tag name="KSO_WM_UNIT_HIGHLIGHT" val="0"/>
-  <p:tag name="KSO_WM_UNIT_COMPATIBLE" val="0"/>
-  <p:tag name="KSO_WM_UNIT_DIAGRAM_ISNUMVISUAL" val="0"/>
-  <p:tag name="KSO_WM_UNIT_DIAGRAM_ISREFERUNIT" val="0"/>
-  <p:tag name="KSO_WM_UNIT_ID" val="_11**"/>
-  <p:tag name="KSO_WM_UNIT_LAYERLEVEL" val="1"/>
-  <p:tag name="KSO_WM_TAG_VERSION" val="1.0"/>
-  <p:tag name="KSO_WM_BEAUTIFY_FLAG" val="#wm#"/>
-</p:tagLst>
-</file>
-
-<file path=ppt/tags/tag55.xml><?xml version="1.0" encoding="utf-8"?>
-<p:tagLst xmlns:p="http://schemas.openxmlformats.org/presentationml/2006/main">
-  <p:tag name="KSO_WM_UNIT_HIGHLIGHT" val="0"/>
-  <p:tag name="KSO_WM_UNIT_COMPATIBLE" val="0"/>
-  <p:tag name="KSO_WM_UNIT_DIAGRAM_ISNUMVISUAL" val="0"/>
-  <p:tag name="KSO_WM_UNIT_DIAGRAM_ISREFERUNIT" val="0"/>
-  <p:tag name="KSO_WM_UNIT_ID" val="_11**"/>
-  <p:tag name="KSO_WM_UNIT_LAYERLEVEL" val="1"/>
-  <p:tag name="KSO_WM_TAG_VERSION" val="1.0"/>
-  <p:tag name="KSO_WM_BEAUTIFY_FLAG" val="#wm#"/>
-</p:tagLst>
-</file>
-
-<file path=ppt/tags/tag56.xml><?xml version="1.0" encoding="utf-8"?>
-<p:tagLst xmlns:p="http://schemas.openxmlformats.org/presentationml/2006/main">
-  <p:tag name="KSO_WM_UNIT_HIGHLIGHT" val="0"/>
-  <p:tag name="KSO_WM_UNIT_COMPATIBLE" val="0"/>
-  <p:tag name="KSO_WM_UNIT_DIAGRAM_ISNUMVISUAL" val="0"/>
-  <p:tag name="KSO_WM_UNIT_DIAGRAM_ISREFERUNIT" val="0"/>
-  <p:tag name="KSO_WM_UNIT_ID" val="_11**"/>
-  <p:tag name="KSO_WM_UNIT_LAYERLEVEL" val="1"/>
-  <p:tag name="KSO_WM_TAG_VERSION" val="1.0"/>
-  <p:tag name="KSO_WM_BEAUTIFY_FLAG" val="#wm#"/>
-</p:tagLst>
-</file>
-
-<file path=ppt/tags/tag57.xml><?xml version="1.0" encoding="utf-8"?>
-<p:tagLst xmlns:p="http://schemas.openxmlformats.org/presentationml/2006/main">
-  <p:tag name="KSO_WM_UNIT_HIGHLIGHT" val="0"/>
-  <p:tag name="KSO_WM_UNIT_COMPATIBLE" val="0"/>
-  <p:tag name="KSO_WM_UNIT_DIAGRAM_ISNUMVISUAL" val="0"/>
-  <p:tag name="KSO_WM_UNIT_DIAGRAM_ISREFERUNIT" val="0"/>
-  <p:tag name="KSO_WM_UNIT_ID" val="_0**"/>
-  <p:tag name="KSO_WM_UNIT_LAYERLEVEL" val="1"/>
-  <p:tag name="KSO_WM_TAG_VERSION" val="1.0"/>
-  <p:tag name="KSO_WM_BEAUTIFY_FLAG" val="#wm#"/>
-  <p:tag name="KSO_WM_TEMPLATE_CATEGORY" val="custom"/>
-  <p:tag name="KSO_WM_TEMPLATE_INDEX" val="20205081"/>
-</p:tagLst>
-</file>
-
-<file path=ppt/tags/tag58.xml><?xml version="1.0" encoding="utf-8"?>
-<p:tagLst xmlns:p="http://schemas.openxmlformats.org/presentationml/2006/main">
-  <p:tag name="KSO_WM_UNIT_HIGHLIGHT" val="0"/>
-  <p:tag name="KSO_WM_UNIT_COMPATIBLE" val="0"/>
-  <p:tag name="KSO_WM_UNIT_DIAGRAM_ISNUMVISUAL" val="0"/>
-  <p:tag name="KSO_WM_UNIT_DIAGRAM_ISREFERUNIT" val="0"/>
-  <p:tag name="KSO_WM_UNIT_ID" val="_0**"/>
-  <p:tag name="KSO_WM_UNIT_LAYERLEVEL" val="1"/>
-  <p:tag name="KSO_WM_TAG_VERSION" val="1.0"/>
-  <p:tag name="KSO_WM_BEAUTIFY_FLAG" val="#wm#"/>
-  <p:tag name="KSO_WM_TEMPLATE_CATEGORY" val="custom"/>
-  <p:tag name="KSO_WM_TEMPLATE_INDEX" val="20205081"/>
-</p:tagLst>
-</file>
-
-<file path=ppt/tags/tag59.xml><?xml version="1.0" encoding="utf-8"?>
-<p:tagLst xmlns:p="http://schemas.openxmlformats.org/presentationml/2006/main">
-  <p:tag name="KSO_WM_UNIT_HIGHLIGHT" val="0"/>
-  <p:tag name="KSO_WM_UNIT_COMPATIBLE" val="0"/>
-  <p:tag name="KSO_WM_UNIT_DIAGRAM_ISNUMVISUAL" val="0"/>
-  <p:tag name="KSO_WM_UNIT_DIAGRAM_ISREFERUNIT" val="0"/>
-  <p:tag name="KSO_WM_UNIT_ID" val="_0**"/>
-  <p:tag name="KSO_WM_UNIT_LAYERLEVEL" val="1"/>
-  <p:tag name="KSO_WM_TAG_VERSION" val="1.0"/>
-  <p:tag name="KSO_WM_BEAUTIFY_FLAG" val="#wm#"/>
-</p:tagLst>
-</file>
-
-<file path=ppt/tags/tag6.xml><?xml version="1.0" encoding="utf-8"?>
-<p:tagLst xmlns:p="http://schemas.openxmlformats.org/presentationml/2006/main">
-  <p:tag name="KSO_WM_UNIT_HIGHLIGHT" val="0"/>
-  <p:tag name="KSO_WM_UNIT_COMPATIBLE" val="0"/>
-  <p:tag name="KSO_WM_UNIT_DIAGRAM_ISNUMVISUAL" val="0"/>
-  <p:tag name="KSO_WM_UNIT_DIAGRAM_ISREFERUNIT" val="0"/>
-  <p:tag name="KSO_WM_UNIT_ID" val="_2**"/>
-  <p:tag name="KSO_WM_UNIT_LAYERLEVEL" val="1"/>
-  <p:tag name="KSO_WM_TAG_VERSION" val="1.0"/>
-  <p:tag name="KSO_WM_BEAUTIFY_FLAG" val="#wm#"/>
-</p:tagLst>
-</file>
-
-<file path=ppt/tags/tag60.xml><?xml version="1.0" encoding="utf-8"?>
-<p:tagLst xmlns:p="http://schemas.openxmlformats.org/presentationml/2006/main">
-  <p:tag name="KSO_WM_UNIT_HIGHLIGHT" val="0"/>
-  <p:tag name="KSO_WM_UNIT_COMPATIBLE" val="0"/>
-  <p:tag name="KSO_WM_UNIT_DIAGRAM_ISNUMVISUAL" val="0"/>
-  <p:tag name="KSO_WM_UNIT_DIAGRAM_ISREFERUNIT" val="0"/>
-  <p:tag name="KSO_WM_UNIT_ID" val="_0**"/>
-  <p:tag name="KSO_WM_UNIT_LAYERLEVEL" val="1"/>
-  <p:tag name="KSO_WM_TAG_VERSION" val="1.0"/>
-  <p:tag name="KSO_WM_BEAUTIFY_FLAG" val="#wm#"/>
-</p:tagLst>
-</file>
-
-<file path=ppt/tags/tag61.xml><?xml version="1.0" encoding="utf-8"?>
-<p:tagLst xmlns:p="http://schemas.openxmlformats.org/presentationml/2006/main">
-  <p:tag name="KSO_WM_UNIT_HIGHLIGHT" val="0"/>
-  <p:tag name="KSO_WM_UNIT_COMPATIBLE" val="0"/>
-  <p:tag name="KSO_WM_UNIT_DIAGRAM_ISNUMVISUAL" val="0"/>
-  <p:tag name="KSO_WM_UNIT_DIAGRAM_ISREFERUNIT" val="0"/>
-  <p:tag name="KSO_WM_UNIT_ID" val="_0**"/>
-  <p:tag name="KSO_WM_UNIT_LAYERLEVEL" val="1"/>
-  <p:tag name="KSO_WM_TAG_VERSION" val="1.0"/>
-  <p:tag name="KSO_WM_BEAUTIFY_FLAG" val="#wm#"/>
-</p:tagLst>
-</file>
-
-<file path=ppt/tags/tag62.xml><?xml version="1.0" encoding="utf-8"?>
-<p:tagLst xmlns:p="http://schemas.openxmlformats.org/presentationml/2006/main">
+<p:tagLst xmlns:a="http://schemas.openxmlformats.org/drawingml/2006/main" xmlns:r="http://schemas.openxmlformats.org/officeDocument/2006/relationships" xmlns:p="http://schemas.openxmlformats.org/presentationml/2006/main">
   <p:tag name="KSO_WM_TEMPLATE_THUMBS_INDEX" val="1、4、7、12、13、14、15、16、17、18、20、24、25、28、33、36、40、43、44"/>
   <p:tag name="KSO_WM_TEMPLATE_SUBCATEGORY" val="19"/>
   <p:tag name="KSO_WM_TAG_VERSION" val="1.0"/>
@@ -4447,52 +4433,766 @@
 </p:tagLst>
 </file>
 
-<file path=ppt/tags/tag63.xml><?xml version="1.0" encoding="utf-8"?>
-<p:tagLst xmlns:p="http://schemas.openxmlformats.org/presentationml/2006/main">
-  <p:tag name="KSO_WM_UNIT_ISCONTENTSTITLE" val="0"/>
-  <p:tag name="KSO_WM_UNIT_ISNUMDGMTITLE" val="0"/>
-  <p:tag name="KSO_WM_UNIT_NOCLEAR" val="0"/>
-  <p:tag name="KSO_WM_UNIT_SHOW_EDIT_AREA_INDICATION" val="1"/>
-  <p:tag name="KSO_WM_UNIT_VALUE" val="28"/>
-  <p:tag name="KSO_WM_UNIT_HIGHLIGHT" val="0"/>
-  <p:tag name="KSO_WM_UNIT_COMPATIBLE" val="0"/>
-  <p:tag name="KSO_WM_UNIT_DIAGRAM_ISNUMVISUAL" val="0"/>
-  <p:tag name="KSO_WM_UNIT_DIAGRAM_ISREFERUNIT" val="0"/>
-  <p:tag name="KSO_WM_UNIT_TYPE" val="a"/>
-  <p:tag name="KSO_WM_UNIT_INDEX" val="1"/>
-  <p:tag name="KSO_WM_UNIT_ID" val="custom20205081_1*a*1"/>
+<file path=ppt/tags/tag10.xml><?xml version="1.0" encoding="utf-8"?>
+<p:tagLst xmlns:a="http://schemas.openxmlformats.org/drawingml/2006/main" xmlns:r="http://schemas.openxmlformats.org/officeDocument/2006/relationships" xmlns:p="http://schemas.openxmlformats.org/presentationml/2006/main">
+  <p:tag name="KSO_WM_UNIT_HIGHLIGHT" val="0"/>
+  <p:tag name="KSO_WM_UNIT_COMPATIBLE" val="0"/>
+  <p:tag name="KSO_WM_UNIT_DIAGRAM_ISNUMVISUAL" val="0"/>
+  <p:tag name="KSO_WM_UNIT_DIAGRAM_ISREFERUNIT" val="0"/>
+  <p:tag name="KSO_WM_UNIT_ID" val="_1**"/>
+  <p:tag name="KSO_WM_UNIT_LAYERLEVEL" val="1"/>
+  <p:tag name="KSO_WM_TAG_VERSION" val="1.0"/>
+  <p:tag name="KSO_WM_BEAUTIFY_FLAG" val="#wm#"/>
+</p:tagLst>
+</file>
+
+<file path=ppt/tags/tag11.xml><?xml version="1.0" encoding="utf-8"?>
+<p:tagLst xmlns:a="http://schemas.openxmlformats.org/drawingml/2006/main" xmlns:r="http://schemas.openxmlformats.org/officeDocument/2006/relationships" xmlns:p="http://schemas.openxmlformats.org/presentationml/2006/main">
+  <p:tag name="KSO_WM_UNIT_HIGHLIGHT" val="0"/>
+  <p:tag name="KSO_WM_UNIT_COMPATIBLE" val="0"/>
+  <p:tag name="KSO_WM_UNIT_DIAGRAM_ISNUMVISUAL" val="0"/>
+  <p:tag name="KSO_WM_UNIT_DIAGRAM_ISREFERUNIT" val="0"/>
+  <p:tag name="KSO_WM_UNIT_ID" val="_1**"/>
+  <p:tag name="KSO_WM_UNIT_LAYERLEVEL" val="1"/>
+  <p:tag name="KSO_WM_TAG_VERSION" val="1.0"/>
+  <p:tag name="KSO_WM_BEAUTIFY_FLAG" val="#wm#"/>
+</p:tagLst>
+</file>
+
+<file path=ppt/tags/tag12.xml><?xml version="1.0" encoding="utf-8"?>
+<p:tagLst xmlns:a="http://schemas.openxmlformats.org/drawingml/2006/main" xmlns:r="http://schemas.openxmlformats.org/officeDocument/2006/relationships" xmlns:p="http://schemas.openxmlformats.org/presentationml/2006/main">
+  <p:tag name="KSO_WM_UNIT_HIGHLIGHT" val="0"/>
+  <p:tag name="KSO_WM_UNIT_COMPATIBLE" val="0"/>
+  <p:tag name="KSO_WM_UNIT_DIAGRAM_ISNUMVISUAL" val="0"/>
+  <p:tag name="KSO_WM_UNIT_DIAGRAM_ISREFERUNIT" val="0"/>
+  <p:tag name="KSO_WM_UNIT_ID" val="_2**"/>
+  <p:tag name="KSO_WM_UNIT_LAYERLEVEL" val="1"/>
+  <p:tag name="KSO_WM_TAG_VERSION" val="1.0"/>
+  <p:tag name="KSO_WM_BEAUTIFY_FLAG" val="#wm#"/>
+</p:tagLst>
+</file>
+
+<file path=ppt/tags/tag13.xml><?xml version="1.0" encoding="utf-8"?>
+<p:tagLst xmlns:a="http://schemas.openxmlformats.org/drawingml/2006/main" xmlns:r="http://schemas.openxmlformats.org/officeDocument/2006/relationships" xmlns:p="http://schemas.openxmlformats.org/presentationml/2006/main">
+  <p:tag name="KSO_WM_UNIT_HIGHLIGHT" val="0"/>
+  <p:tag name="KSO_WM_UNIT_COMPATIBLE" val="0"/>
+  <p:tag name="KSO_WM_UNIT_DIAGRAM_ISNUMVISUAL" val="0"/>
+  <p:tag name="KSO_WM_UNIT_DIAGRAM_ISREFERUNIT" val="0"/>
+  <p:tag name="KSO_WM_UNIT_ID" val="_2**"/>
+  <p:tag name="KSO_WM_UNIT_LAYERLEVEL" val="1"/>
+  <p:tag name="KSO_WM_TAG_VERSION" val="1.0"/>
+  <p:tag name="KSO_WM_BEAUTIFY_FLAG" val="#wm#"/>
+</p:tagLst>
+</file>
+
+<file path=ppt/tags/tag14.xml><?xml version="1.0" encoding="utf-8"?>
+<p:tagLst xmlns:a="http://schemas.openxmlformats.org/drawingml/2006/main" xmlns:r="http://schemas.openxmlformats.org/officeDocument/2006/relationships" xmlns:p="http://schemas.openxmlformats.org/presentationml/2006/main">
+  <p:tag name="KSO_WM_UNIT_HIGHLIGHT" val="0"/>
+  <p:tag name="KSO_WM_UNIT_COMPATIBLE" val="0"/>
+  <p:tag name="KSO_WM_UNIT_DIAGRAM_ISNUMVISUAL" val="0"/>
+  <p:tag name="KSO_WM_UNIT_DIAGRAM_ISREFERUNIT" val="0"/>
+  <p:tag name="KSO_WM_UNIT_ID" val="_2**"/>
+  <p:tag name="KSO_WM_UNIT_LAYERLEVEL" val="1"/>
+  <p:tag name="KSO_WM_TAG_VERSION" val="1.0"/>
+  <p:tag name="KSO_WM_BEAUTIFY_FLAG" val="#wm#"/>
+</p:tagLst>
+</file>
+
+<file path=ppt/tags/tag15.xml><?xml version="1.0" encoding="utf-8"?>
+<p:tagLst xmlns:a="http://schemas.openxmlformats.org/drawingml/2006/main" xmlns:r="http://schemas.openxmlformats.org/officeDocument/2006/relationships" xmlns:p="http://schemas.openxmlformats.org/presentationml/2006/main">
+  <p:tag name="KSO_WM_UNIT_HIGHLIGHT" val="0"/>
+  <p:tag name="KSO_WM_UNIT_COMPATIBLE" val="0"/>
+  <p:tag name="KSO_WM_UNIT_DIAGRAM_ISNUMVISUAL" val="0"/>
+  <p:tag name="KSO_WM_UNIT_DIAGRAM_ISREFERUNIT" val="0"/>
+  <p:tag name="KSO_WM_UNIT_ID" val="_2**"/>
+  <p:tag name="KSO_WM_UNIT_LAYERLEVEL" val="1"/>
+  <p:tag name="KSO_WM_TAG_VERSION" val="1.0"/>
+  <p:tag name="KSO_WM_BEAUTIFY_FLAG" val="#wm#"/>
+</p:tagLst>
+</file>
+
+<file path=ppt/tags/tag16.xml><?xml version="1.0" encoding="utf-8"?>
+<p:tagLst xmlns:a="http://schemas.openxmlformats.org/drawingml/2006/main" xmlns:r="http://schemas.openxmlformats.org/officeDocument/2006/relationships" xmlns:p="http://schemas.openxmlformats.org/presentationml/2006/main">
+  <p:tag name="KSO_WM_UNIT_HIGHLIGHT" val="0"/>
+  <p:tag name="KSO_WM_UNIT_COMPATIBLE" val="0"/>
+  <p:tag name="KSO_WM_UNIT_DIAGRAM_ISNUMVISUAL" val="0"/>
+  <p:tag name="KSO_WM_UNIT_DIAGRAM_ISREFERUNIT" val="0"/>
+  <p:tag name="KSO_WM_UNIT_ID" val="_2**"/>
+  <p:tag name="KSO_WM_UNIT_LAYERLEVEL" val="1"/>
+  <p:tag name="KSO_WM_TAG_VERSION" val="1.0"/>
+  <p:tag name="KSO_WM_BEAUTIFY_FLAG" val="#wm#"/>
+</p:tagLst>
+</file>
+
+<file path=ppt/tags/tag17.xml><?xml version="1.0" encoding="utf-8"?>
+<p:tagLst xmlns:a="http://schemas.openxmlformats.org/drawingml/2006/main" xmlns:r="http://schemas.openxmlformats.org/officeDocument/2006/relationships" xmlns:p="http://schemas.openxmlformats.org/presentationml/2006/main">
+  <p:tag name="KSO_WM_UNIT_HIGHLIGHT" val="0"/>
+  <p:tag name="KSO_WM_UNIT_COMPATIBLE" val="0"/>
+  <p:tag name="KSO_WM_UNIT_DIAGRAM_ISNUMVISUAL" val="0"/>
+  <p:tag name="KSO_WM_UNIT_DIAGRAM_ISREFERUNIT" val="0"/>
+  <p:tag name="KSO_WM_UNIT_ID" val="_3**"/>
+  <p:tag name="KSO_WM_UNIT_LAYERLEVEL" val="1"/>
+  <p:tag name="KSO_WM_TAG_VERSION" val="1.0"/>
+  <p:tag name="KSO_WM_BEAUTIFY_FLAG" val="#wm#"/>
+</p:tagLst>
+</file>
+
+<file path=ppt/tags/tag18.xml><?xml version="1.0" encoding="utf-8"?>
+<p:tagLst xmlns:a="http://schemas.openxmlformats.org/drawingml/2006/main" xmlns:r="http://schemas.openxmlformats.org/officeDocument/2006/relationships" xmlns:p="http://schemas.openxmlformats.org/presentationml/2006/main">
+  <p:tag name="KSO_WM_UNIT_HIGHLIGHT" val="0"/>
+  <p:tag name="KSO_WM_UNIT_COMPATIBLE" val="0"/>
+  <p:tag name="KSO_WM_UNIT_DIAGRAM_ISNUMVISUAL" val="0"/>
+  <p:tag name="KSO_WM_UNIT_DIAGRAM_ISREFERUNIT" val="0"/>
+  <p:tag name="KSO_WM_UNIT_ID" val="_3**"/>
+  <p:tag name="KSO_WM_UNIT_LAYERLEVEL" val="1"/>
+  <p:tag name="KSO_WM_TAG_VERSION" val="1.0"/>
+  <p:tag name="KSO_WM_BEAUTIFY_FLAG" val="#wm#"/>
+</p:tagLst>
+</file>
+
+<file path=ppt/tags/tag19.xml><?xml version="1.0" encoding="utf-8"?>
+<p:tagLst xmlns:a="http://schemas.openxmlformats.org/drawingml/2006/main" xmlns:r="http://schemas.openxmlformats.org/officeDocument/2006/relationships" xmlns:p="http://schemas.openxmlformats.org/presentationml/2006/main">
+  <p:tag name="KSO_WM_UNIT_HIGHLIGHT" val="0"/>
+  <p:tag name="KSO_WM_UNIT_COMPATIBLE" val="0"/>
+  <p:tag name="KSO_WM_UNIT_DIAGRAM_ISNUMVISUAL" val="0"/>
+  <p:tag name="KSO_WM_UNIT_DIAGRAM_ISREFERUNIT" val="0"/>
+  <p:tag name="KSO_WM_UNIT_ID" val="_3**"/>
+  <p:tag name="KSO_WM_UNIT_LAYERLEVEL" val="1"/>
+  <p:tag name="KSO_WM_TAG_VERSION" val="1.0"/>
+  <p:tag name="KSO_WM_BEAUTIFY_FLAG" val="#wm#"/>
+</p:tagLst>
+</file>
+
+<file path=ppt/tags/tag2.xml><?xml version="1.0" encoding="utf-8"?>
+<p:tagLst xmlns:a="http://schemas.openxmlformats.org/drawingml/2006/main" xmlns:r="http://schemas.openxmlformats.org/officeDocument/2006/relationships" xmlns:p="http://schemas.openxmlformats.org/presentationml/2006/main">
+  <p:tag name="KSO_WM_UNIT_HIGHLIGHT" val="0"/>
+  <p:tag name="KSO_WM_UNIT_COMPATIBLE" val="0"/>
+  <p:tag name="KSO_WM_UNIT_DIAGRAM_ISNUMVISUAL" val="0"/>
+  <p:tag name="KSO_WM_UNIT_DIAGRAM_ISREFERUNIT" val="0"/>
+  <p:tag name="KSO_WM_UNIT_ID" val="_0**"/>
+  <p:tag name="KSO_WM_UNIT_LAYERLEVEL" val="1"/>
+  <p:tag name="KSO_WM_TAG_VERSION" val="1.0"/>
+  <p:tag name="KSO_WM_BEAUTIFY_FLAG" val="#wm#"/>
   <p:tag name="KSO_WM_TEMPLATE_CATEGORY" val="custom"/>
   <p:tag name="KSO_WM_TEMPLATE_INDEX" val="20205081"/>
-  <p:tag name="KSO_WM_UNIT_LAYERLEVEL" val="1"/>
-  <p:tag name="KSO_WM_TAG_VERSION" val="1.0"/>
-  <p:tag name="KSO_WM_BEAUTIFY_FLAG" val="#wm#"/>
-</p:tagLst>
-</file>
-
-<file path=ppt/tags/tag64.xml><?xml version="1.0" encoding="utf-8"?>
-<p:tagLst xmlns:p="http://schemas.openxmlformats.org/presentationml/2006/main">
-  <p:tag name="KSO_WM_UNIT_ISCONTENTSTITLE" val="0"/>
-  <p:tag name="KSO_WM_UNIT_ISNUMDGMTITLE" val="0"/>
-  <p:tag name="KSO_WM_UNIT_NOCLEAR" val="0"/>
-  <p:tag name="KSO_WM_UNIT_SHOW_EDIT_AREA_INDICATION" val="1"/>
-  <p:tag name="KSO_WM_UNIT_VALUE" val="111"/>
-  <p:tag name="KSO_WM_UNIT_HIGHLIGHT" val="0"/>
-  <p:tag name="KSO_WM_UNIT_COMPATIBLE" val="0"/>
-  <p:tag name="KSO_WM_UNIT_DIAGRAM_ISNUMVISUAL" val="0"/>
-  <p:tag name="KSO_WM_UNIT_DIAGRAM_ISREFERUNIT" val="0"/>
-  <p:tag name="KSO_WM_UNIT_TYPE" val="b"/>
-  <p:tag name="KSO_WM_UNIT_INDEX" val="1"/>
-  <p:tag name="KSO_WM_UNIT_ID" val="custom20205081_1*b*1"/>
+</p:tagLst>
+</file>
+
+<file path=ppt/tags/tag20.xml><?xml version="1.0" encoding="utf-8"?>
+<p:tagLst xmlns:a="http://schemas.openxmlformats.org/drawingml/2006/main" xmlns:r="http://schemas.openxmlformats.org/officeDocument/2006/relationships" xmlns:p="http://schemas.openxmlformats.org/presentationml/2006/main">
+  <p:tag name="KSO_WM_UNIT_HIGHLIGHT" val="0"/>
+  <p:tag name="KSO_WM_UNIT_COMPATIBLE" val="0"/>
+  <p:tag name="KSO_WM_UNIT_DIAGRAM_ISNUMVISUAL" val="0"/>
+  <p:tag name="KSO_WM_UNIT_DIAGRAM_ISREFERUNIT" val="0"/>
+  <p:tag name="KSO_WM_UNIT_ID" val="_3**"/>
+  <p:tag name="KSO_WM_UNIT_LAYERLEVEL" val="1"/>
+  <p:tag name="KSO_WM_TAG_VERSION" val="1.0"/>
+  <p:tag name="KSO_WM_BEAUTIFY_FLAG" val="#wm#"/>
+</p:tagLst>
+</file>
+
+<file path=ppt/tags/tag21.xml><?xml version="1.0" encoding="utf-8"?>
+<p:tagLst xmlns:a="http://schemas.openxmlformats.org/drawingml/2006/main" xmlns:r="http://schemas.openxmlformats.org/officeDocument/2006/relationships" xmlns:p="http://schemas.openxmlformats.org/presentationml/2006/main">
+  <p:tag name="KSO_WM_UNIT_HIGHLIGHT" val="0"/>
+  <p:tag name="KSO_WM_UNIT_COMPATIBLE" val="0"/>
+  <p:tag name="KSO_WM_UNIT_DIAGRAM_ISNUMVISUAL" val="0"/>
+  <p:tag name="KSO_WM_UNIT_DIAGRAM_ISREFERUNIT" val="0"/>
+  <p:tag name="KSO_WM_UNIT_ID" val="_3**"/>
+  <p:tag name="KSO_WM_UNIT_LAYERLEVEL" val="1"/>
+  <p:tag name="KSO_WM_TAG_VERSION" val="1.0"/>
+  <p:tag name="KSO_WM_BEAUTIFY_FLAG" val="#wm#"/>
+</p:tagLst>
+</file>
+
+<file path=ppt/tags/tag22.xml><?xml version="1.0" encoding="utf-8"?>
+<p:tagLst xmlns:a="http://schemas.openxmlformats.org/drawingml/2006/main" xmlns:r="http://schemas.openxmlformats.org/officeDocument/2006/relationships" xmlns:p="http://schemas.openxmlformats.org/presentationml/2006/main">
+  <p:tag name="KSO_WM_UNIT_HIGHLIGHT" val="0"/>
+  <p:tag name="KSO_WM_UNIT_COMPATIBLE" val="0"/>
+  <p:tag name="KSO_WM_UNIT_DIAGRAM_ISNUMVISUAL" val="0"/>
+  <p:tag name="KSO_WM_UNIT_DIAGRAM_ISREFERUNIT" val="0"/>
+  <p:tag name="KSO_WM_UNIT_ID" val="_4**"/>
+  <p:tag name="KSO_WM_UNIT_LAYERLEVEL" val="1"/>
+  <p:tag name="KSO_WM_TAG_VERSION" val="1.0"/>
+  <p:tag name="KSO_WM_BEAUTIFY_FLAG" val="#wm#"/>
+</p:tagLst>
+</file>
+
+<file path=ppt/tags/tag23.xml><?xml version="1.0" encoding="utf-8"?>
+<p:tagLst xmlns:a="http://schemas.openxmlformats.org/drawingml/2006/main" xmlns:r="http://schemas.openxmlformats.org/officeDocument/2006/relationships" xmlns:p="http://schemas.openxmlformats.org/presentationml/2006/main">
+  <p:tag name="KSO_WM_UNIT_HIGHLIGHT" val="0"/>
+  <p:tag name="KSO_WM_UNIT_COMPATIBLE" val="0"/>
+  <p:tag name="KSO_WM_UNIT_DIAGRAM_ISNUMVISUAL" val="0"/>
+  <p:tag name="KSO_WM_UNIT_DIAGRAM_ISREFERUNIT" val="0"/>
+  <p:tag name="KSO_WM_UNIT_ID" val="_4**"/>
+  <p:tag name="KSO_WM_UNIT_LAYERLEVEL" val="1"/>
+  <p:tag name="KSO_WM_TAG_VERSION" val="1.0"/>
+  <p:tag name="KSO_WM_BEAUTIFY_FLAG" val="#wm#"/>
+</p:tagLst>
+</file>
+
+<file path=ppt/tags/tag24.xml><?xml version="1.0" encoding="utf-8"?>
+<p:tagLst xmlns:a="http://schemas.openxmlformats.org/drawingml/2006/main" xmlns:r="http://schemas.openxmlformats.org/officeDocument/2006/relationships" xmlns:p="http://schemas.openxmlformats.org/presentationml/2006/main">
+  <p:tag name="KSO_WM_UNIT_HIGHLIGHT" val="0"/>
+  <p:tag name="KSO_WM_UNIT_COMPATIBLE" val="0"/>
+  <p:tag name="KSO_WM_UNIT_DIAGRAM_ISNUMVISUAL" val="0"/>
+  <p:tag name="KSO_WM_UNIT_DIAGRAM_ISREFERUNIT" val="0"/>
+  <p:tag name="KSO_WM_UNIT_ID" val="_4**"/>
+  <p:tag name="KSO_WM_UNIT_LAYERLEVEL" val="1"/>
+  <p:tag name="KSO_WM_TAG_VERSION" val="1.0"/>
+  <p:tag name="KSO_WM_BEAUTIFY_FLAG" val="#wm#"/>
+</p:tagLst>
+</file>
+
+<file path=ppt/tags/tag25.xml><?xml version="1.0" encoding="utf-8"?>
+<p:tagLst xmlns:a="http://schemas.openxmlformats.org/drawingml/2006/main" xmlns:r="http://schemas.openxmlformats.org/officeDocument/2006/relationships" xmlns:p="http://schemas.openxmlformats.org/presentationml/2006/main">
+  <p:tag name="KSO_WM_UNIT_HIGHLIGHT" val="0"/>
+  <p:tag name="KSO_WM_UNIT_COMPATIBLE" val="0"/>
+  <p:tag name="KSO_WM_UNIT_DIAGRAM_ISNUMVISUAL" val="0"/>
+  <p:tag name="KSO_WM_UNIT_DIAGRAM_ISREFERUNIT" val="0"/>
+  <p:tag name="KSO_WM_UNIT_ID" val="_4**"/>
+  <p:tag name="KSO_WM_UNIT_LAYERLEVEL" val="1"/>
+  <p:tag name="KSO_WM_TAG_VERSION" val="1.0"/>
+  <p:tag name="KSO_WM_BEAUTIFY_FLAG" val="#wm#"/>
+</p:tagLst>
+</file>
+
+<file path=ppt/tags/tag26.xml><?xml version="1.0" encoding="utf-8"?>
+<p:tagLst xmlns:a="http://schemas.openxmlformats.org/drawingml/2006/main" xmlns:r="http://schemas.openxmlformats.org/officeDocument/2006/relationships" xmlns:p="http://schemas.openxmlformats.org/presentationml/2006/main">
+  <p:tag name="KSO_WM_UNIT_HIGHLIGHT" val="0"/>
+  <p:tag name="KSO_WM_UNIT_COMPATIBLE" val="0"/>
+  <p:tag name="KSO_WM_UNIT_DIAGRAM_ISNUMVISUAL" val="0"/>
+  <p:tag name="KSO_WM_UNIT_DIAGRAM_ISREFERUNIT" val="0"/>
+  <p:tag name="KSO_WM_UNIT_ID" val="_4**"/>
+  <p:tag name="KSO_WM_UNIT_LAYERLEVEL" val="1"/>
+  <p:tag name="KSO_WM_TAG_VERSION" val="1.0"/>
+  <p:tag name="KSO_WM_BEAUTIFY_FLAG" val="#wm#"/>
+</p:tagLst>
+</file>
+
+<file path=ppt/tags/tag27.xml><?xml version="1.0" encoding="utf-8"?>
+<p:tagLst xmlns:a="http://schemas.openxmlformats.org/drawingml/2006/main" xmlns:r="http://schemas.openxmlformats.org/officeDocument/2006/relationships" xmlns:p="http://schemas.openxmlformats.org/presentationml/2006/main">
+  <p:tag name="KSO_WM_UNIT_HIGHLIGHT" val="0"/>
+  <p:tag name="KSO_WM_UNIT_COMPATIBLE" val="0"/>
+  <p:tag name="KSO_WM_UNIT_DIAGRAM_ISNUMVISUAL" val="0"/>
+  <p:tag name="KSO_WM_UNIT_DIAGRAM_ISREFERUNIT" val="0"/>
+  <p:tag name="KSO_WM_UNIT_ID" val="_4**"/>
+  <p:tag name="KSO_WM_UNIT_LAYERLEVEL" val="1"/>
+  <p:tag name="KSO_WM_TAG_VERSION" val="1.0"/>
+  <p:tag name="KSO_WM_BEAUTIFY_FLAG" val="#wm#"/>
+</p:tagLst>
+</file>
+
+<file path=ppt/tags/tag28.xml><?xml version="1.0" encoding="utf-8"?>
+<p:tagLst xmlns:a="http://schemas.openxmlformats.org/drawingml/2006/main" xmlns:r="http://schemas.openxmlformats.org/officeDocument/2006/relationships" xmlns:p="http://schemas.openxmlformats.org/presentationml/2006/main">
+  <p:tag name="KSO_WM_UNIT_HIGHLIGHT" val="0"/>
+  <p:tag name="KSO_WM_UNIT_COMPATIBLE" val="0"/>
+  <p:tag name="KSO_WM_UNIT_DIAGRAM_ISNUMVISUAL" val="0"/>
+  <p:tag name="KSO_WM_UNIT_DIAGRAM_ISREFERUNIT" val="0"/>
+  <p:tag name="KSO_WM_UNIT_ID" val="_5**"/>
+  <p:tag name="KSO_WM_UNIT_LAYERLEVEL" val="1"/>
+  <p:tag name="KSO_WM_TAG_VERSION" val="1.0"/>
+  <p:tag name="KSO_WM_BEAUTIFY_FLAG" val="#wm#"/>
+</p:tagLst>
+</file>
+
+<file path=ppt/tags/tag29.xml><?xml version="1.0" encoding="utf-8"?>
+<p:tagLst xmlns:a="http://schemas.openxmlformats.org/drawingml/2006/main" xmlns:r="http://schemas.openxmlformats.org/officeDocument/2006/relationships" xmlns:p="http://schemas.openxmlformats.org/presentationml/2006/main">
+  <p:tag name="KSO_WM_UNIT_HIGHLIGHT" val="0"/>
+  <p:tag name="KSO_WM_UNIT_COMPATIBLE" val="0"/>
+  <p:tag name="KSO_WM_UNIT_DIAGRAM_ISNUMVISUAL" val="0"/>
+  <p:tag name="KSO_WM_UNIT_DIAGRAM_ISREFERUNIT" val="0"/>
+  <p:tag name="KSO_WM_UNIT_ID" val="_5**"/>
+  <p:tag name="KSO_WM_UNIT_LAYERLEVEL" val="1"/>
+  <p:tag name="KSO_WM_TAG_VERSION" val="1.0"/>
+  <p:tag name="KSO_WM_BEAUTIFY_FLAG" val="#wm#"/>
+</p:tagLst>
+</file>
+
+<file path=ppt/tags/tag3.xml><?xml version="1.0" encoding="utf-8"?>
+<p:tagLst xmlns:a="http://schemas.openxmlformats.org/drawingml/2006/main" xmlns:r="http://schemas.openxmlformats.org/officeDocument/2006/relationships" xmlns:p="http://schemas.openxmlformats.org/presentationml/2006/main">
+  <p:tag name="KSO_WM_UNIT_HIGHLIGHT" val="0"/>
+  <p:tag name="KSO_WM_UNIT_COMPATIBLE" val="0"/>
+  <p:tag name="KSO_WM_UNIT_DIAGRAM_ISNUMVISUAL" val="0"/>
+  <p:tag name="KSO_WM_UNIT_DIAGRAM_ISREFERUNIT" val="0"/>
+  <p:tag name="KSO_WM_UNIT_ID" val="_0**"/>
+  <p:tag name="KSO_WM_UNIT_LAYERLEVEL" val="1"/>
+  <p:tag name="KSO_WM_TAG_VERSION" val="1.0"/>
+  <p:tag name="KSO_WM_BEAUTIFY_FLAG" val="#wm#"/>
   <p:tag name="KSO_WM_TEMPLATE_CATEGORY" val="custom"/>
   <p:tag name="KSO_WM_TEMPLATE_INDEX" val="20205081"/>
-  <p:tag name="KSO_WM_UNIT_LAYERLEVEL" val="1"/>
-  <p:tag name="KSO_WM_TAG_VERSION" val="1.0"/>
-  <p:tag name="KSO_WM_BEAUTIFY_FLAG" val="#wm#"/>
-</p:tagLst>
-</file>
-
-<file path=ppt/tags/tag65.xml><?xml version="1.0" encoding="utf-8"?>
-<p:tagLst xmlns:p="http://schemas.openxmlformats.org/presentationml/2006/main">
+</p:tagLst>
+</file>
+
+<file path=ppt/tags/tag30.xml><?xml version="1.0" encoding="utf-8"?>
+<p:tagLst xmlns:a="http://schemas.openxmlformats.org/drawingml/2006/main" xmlns:r="http://schemas.openxmlformats.org/officeDocument/2006/relationships" xmlns:p="http://schemas.openxmlformats.org/presentationml/2006/main">
+  <p:tag name="KSO_WM_UNIT_HIGHLIGHT" val="0"/>
+  <p:tag name="KSO_WM_UNIT_COMPATIBLE" val="0"/>
+  <p:tag name="KSO_WM_UNIT_DIAGRAM_ISNUMVISUAL" val="0"/>
+  <p:tag name="KSO_WM_UNIT_DIAGRAM_ISREFERUNIT" val="0"/>
+  <p:tag name="KSO_WM_UNIT_ID" val="_5**"/>
+  <p:tag name="KSO_WM_UNIT_LAYERLEVEL" val="1"/>
+  <p:tag name="KSO_WM_TAG_VERSION" val="1.0"/>
+  <p:tag name="KSO_WM_BEAUTIFY_FLAG" val="#wm#"/>
+</p:tagLst>
+</file>
+
+<file path=ppt/tags/tag31.xml><?xml version="1.0" encoding="utf-8"?>
+<p:tagLst xmlns:a="http://schemas.openxmlformats.org/drawingml/2006/main" xmlns:r="http://schemas.openxmlformats.org/officeDocument/2006/relationships" xmlns:p="http://schemas.openxmlformats.org/presentationml/2006/main">
+  <p:tag name="KSO_WM_UNIT_HIGHLIGHT" val="0"/>
+  <p:tag name="KSO_WM_UNIT_COMPATIBLE" val="0"/>
+  <p:tag name="KSO_WM_UNIT_DIAGRAM_ISNUMVISUAL" val="0"/>
+  <p:tag name="KSO_WM_UNIT_DIAGRAM_ISREFERUNIT" val="0"/>
+  <p:tag name="KSO_WM_UNIT_ID" val="_5**"/>
+  <p:tag name="KSO_WM_UNIT_LAYERLEVEL" val="1"/>
+  <p:tag name="KSO_WM_TAG_VERSION" val="1.0"/>
+  <p:tag name="KSO_WM_BEAUTIFY_FLAG" val="#wm#"/>
+</p:tagLst>
+</file>
+
+<file path=ppt/tags/tag32.xml><?xml version="1.0" encoding="utf-8"?>
+<p:tagLst xmlns:a="http://schemas.openxmlformats.org/drawingml/2006/main" xmlns:r="http://schemas.openxmlformats.org/officeDocument/2006/relationships" xmlns:p="http://schemas.openxmlformats.org/presentationml/2006/main">
+  <p:tag name="KSO_WM_UNIT_HIGHLIGHT" val="0"/>
+  <p:tag name="KSO_WM_UNIT_COMPATIBLE" val="0"/>
+  <p:tag name="KSO_WM_UNIT_DIAGRAM_ISNUMVISUAL" val="0"/>
+  <p:tag name="KSO_WM_UNIT_DIAGRAM_ISREFERUNIT" val="0"/>
+  <p:tag name="KSO_WM_UNIT_ID" val="_5**"/>
+  <p:tag name="KSO_WM_UNIT_LAYERLEVEL" val="1"/>
+  <p:tag name="KSO_WM_TAG_VERSION" val="1.0"/>
+  <p:tag name="KSO_WM_BEAUTIFY_FLAG" val="#wm#"/>
+</p:tagLst>
+</file>
+
+<file path=ppt/tags/tag33.xml><?xml version="1.0" encoding="utf-8"?>
+<p:tagLst xmlns:a="http://schemas.openxmlformats.org/drawingml/2006/main" xmlns:r="http://schemas.openxmlformats.org/officeDocument/2006/relationships" xmlns:p="http://schemas.openxmlformats.org/presentationml/2006/main">
+  <p:tag name="KSO_WM_UNIT_HIGHLIGHT" val="0"/>
+  <p:tag name="KSO_WM_UNIT_COMPATIBLE" val="0"/>
+  <p:tag name="KSO_WM_UNIT_DIAGRAM_ISNUMVISUAL" val="0"/>
+  <p:tag name="KSO_WM_UNIT_DIAGRAM_ISREFERUNIT" val="0"/>
+  <p:tag name="KSO_WM_UNIT_ID" val="_5**"/>
+  <p:tag name="KSO_WM_UNIT_LAYERLEVEL" val="1"/>
+  <p:tag name="KSO_WM_TAG_VERSION" val="1.0"/>
+  <p:tag name="KSO_WM_BEAUTIFY_FLAG" val="#wm#"/>
+</p:tagLst>
+</file>
+
+<file path=ppt/tags/tag34.xml><?xml version="1.0" encoding="utf-8"?>
+<p:tagLst xmlns:a="http://schemas.openxmlformats.org/drawingml/2006/main" xmlns:r="http://schemas.openxmlformats.org/officeDocument/2006/relationships" xmlns:p="http://schemas.openxmlformats.org/presentationml/2006/main">
+  <p:tag name="KSO_WM_UNIT_HIGHLIGHT" val="0"/>
+  <p:tag name="KSO_WM_UNIT_COMPATIBLE" val="0"/>
+  <p:tag name="KSO_WM_UNIT_DIAGRAM_ISNUMVISUAL" val="0"/>
+  <p:tag name="KSO_WM_UNIT_DIAGRAM_ISREFERUNIT" val="0"/>
+  <p:tag name="KSO_WM_UNIT_ID" val="_5**"/>
+  <p:tag name="KSO_WM_UNIT_LAYERLEVEL" val="1"/>
+  <p:tag name="KSO_WM_TAG_VERSION" val="1.0"/>
+  <p:tag name="KSO_WM_BEAUTIFY_FLAG" val="#wm#"/>
+</p:tagLst>
+</file>
+
+<file path=ppt/tags/tag35.xml><?xml version="1.0" encoding="utf-8"?>
+<p:tagLst xmlns:a="http://schemas.openxmlformats.org/drawingml/2006/main" xmlns:r="http://schemas.openxmlformats.org/officeDocument/2006/relationships" xmlns:p="http://schemas.openxmlformats.org/presentationml/2006/main">
+  <p:tag name="KSO_WM_UNIT_HIGHLIGHT" val="0"/>
+  <p:tag name="KSO_WM_UNIT_COMPATIBLE" val="0"/>
+  <p:tag name="KSO_WM_UNIT_DIAGRAM_ISNUMVISUAL" val="0"/>
+  <p:tag name="KSO_WM_UNIT_DIAGRAM_ISREFERUNIT" val="0"/>
+  <p:tag name="KSO_WM_UNIT_ID" val="_5**"/>
+  <p:tag name="KSO_WM_UNIT_LAYERLEVEL" val="1"/>
+  <p:tag name="KSO_WM_TAG_VERSION" val="1.0"/>
+  <p:tag name="KSO_WM_BEAUTIFY_FLAG" val="#wm#"/>
+</p:tagLst>
+</file>
+
+<file path=ppt/tags/tag36.xml><?xml version="1.0" encoding="utf-8"?>
+<p:tagLst xmlns:a="http://schemas.openxmlformats.org/drawingml/2006/main" xmlns:r="http://schemas.openxmlformats.org/officeDocument/2006/relationships" xmlns:p="http://schemas.openxmlformats.org/presentationml/2006/main">
+  <p:tag name="KSO_WM_UNIT_HIGHLIGHT" val="0"/>
+  <p:tag name="KSO_WM_UNIT_COMPATIBLE" val="0"/>
+  <p:tag name="KSO_WM_UNIT_DIAGRAM_ISNUMVISUAL" val="0"/>
+  <p:tag name="KSO_WM_UNIT_DIAGRAM_ISREFERUNIT" val="0"/>
+  <p:tag name="KSO_WM_UNIT_ID" val="_6**"/>
+  <p:tag name="KSO_WM_UNIT_LAYERLEVEL" val="1"/>
+  <p:tag name="KSO_WM_TAG_VERSION" val="1.0"/>
+  <p:tag name="KSO_WM_BEAUTIFY_FLAG" val="#wm#"/>
+</p:tagLst>
+</file>
+
+<file path=ppt/tags/tag37.xml><?xml version="1.0" encoding="utf-8"?>
+<p:tagLst xmlns:a="http://schemas.openxmlformats.org/drawingml/2006/main" xmlns:r="http://schemas.openxmlformats.org/officeDocument/2006/relationships" xmlns:p="http://schemas.openxmlformats.org/presentationml/2006/main">
+  <p:tag name="KSO_WM_UNIT_HIGHLIGHT" val="0"/>
+  <p:tag name="KSO_WM_UNIT_COMPATIBLE" val="0"/>
+  <p:tag name="KSO_WM_UNIT_DIAGRAM_ISNUMVISUAL" val="0"/>
+  <p:tag name="KSO_WM_UNIT_DIAGRAM_ISREFERUNIT" val="0"/>
+  <p:tag name="KSO_WM_UNIT_ID" val="_6**"/>
+  <p:tag name="KSO_WM_UNIT_LAYERLEVEL" val="1"/>
+  <p:tag name="KSO_WM_TAG_VERSION" val="1.0"/>
+  <p:tag name="KSO_WM_BEAUTIFY_FLAG" val="#wm#"/>
+</p:tagLst>
+</file>
+
+<file path=ppt/tags/tag38.xml><?xml version="1.0" encoding="utf-8"?>
+<p:tagLst xmlns:a="http://schemas.openxmlformats.org/drawingml/2006/main" xmlns:r="http://schemas.openxmlformats.org/officeDocument/2006/relationships" xmlns:p="http://schemas.openxmlformats.org/presentationml/2006/main">
+  <p:tag name="KSO_WM_UNIT_HIGHLIGHT" val="0"/>
+  <p:tag name="KSO_WM_UNIT_COMPATIBLE" val="0"/>
+  <p:tag name="KSO_WM_UNIT_DIAGRAM_ISNUMVISUAL" val="0"/>
+  <p:tag name="KSO_WM_UNIT_DIAGRAM_ISREFERUNIT" val="0"/>
+  <p:tag name="KSO_WM_UNIT_ID" val="_6**"/>
+  <p:tag name="KSO_WM_UNIT_LAYERLEVEL" val="1"/>
+  <p:tag name="KSO_WM_TAG_VERSION" val="1.0"/>
+  <p:tag name="KSO_WM_BEAUTIFY_FLAG" val="#wm#"/>
+</p:tagLst>
+</file>
+
+<file path=ppt/tags/tag39.xml><?xml version="1.0" encoding="utf-8"?>
+<p:tagLst xmlns:a="http://schemas.openxmlformats.org/drawingml/2006/main" xmlns:r="http://schemas.openxmlformats.org/officeDocument/2006/relationships" xmlns:p="http://schemas.openxmlformats.org/presentationml/2006/main">
+  <p:tag name="KSO_WM_UNIT_HIGHLIGHT" val="0"/>
+  <p:tag name="KSO_WM_UNIT_COMPATIBLE" val="0"/>
+  <p:tag name="KSO_WM_UNIT_DIAGRAM_ISNUMVISUAL" val="0"/>
+  <p:tag name="KSO_WM_UNIT_DIAGRAM_ISREFERUNIT" val="0"/>
+  <p:tag name="KSO_WM_UNIT_ID" val="_6**"/>
+  <p:tag name="KSO_WM_UNIT_LAYERLEVEL" val="1"/>
+  <p:tag name="KSO_WM_TAG_VERSION" val="1.0"/>
+  <p:tag name="KSO_WM_BEAUTIFY_FLAG" val="#wm#"/>
+</p:tagLst>
+</file>
+
+<file path=ppt/tags/tag4.xml><?xml version="1.0" encoding="utf-8"?>
+<p:tagLst xmlns:a="http://schemas.openxmlformats.org/drawingml/2006/main" xmlns:r="http://schemas.openxmlformats.org/officeDocument/2006/relationships" xmlns:p="http://schemas.openxmlformats.org/presentationml/2006/main">
+  <p:tag name="KSO_WM_UNIT_HIGHLIGHT" val="0"/>
+  <p:tag name="KSO_WM_UNIT_COMPATIBLE" val="0"/>
+  <p:tag name="KSO_WM_UNIT_DIAGRAM_ISNUMVISUAL" val="0"/>
+  <p:tag name="KSO_WM_UNIT_DIAGRAM_ISREFERUNIT" val="0"/>
+  <p:tag name="KSO_WM_UNIT_ID" val="_0**"/>
+  <p:tag name="KSO_WM_UNIT_LAYERLEVEL" val="1"/>
+  <p:tag name="KSO_WM_TAG_VERSION" val="1.0"/>
+  <p:tag name="KSO_WM_BEAUTIFY_FLAG" val="#wm#"/>
+</p:tagLst>
+</file>
+
+<file path=ppt/tags/tag40.xml><?xml version="1.0" encoding="utf-8"?>
+<p:tagLst xmlns:a="http://schemas.openxmlformats.org/drawingml/2006/main" xmlns:r="http://schemas.openxmlformats.org/officeDocument/2006/relationships" xmlns:p="http://schemas.openxmlformats.org/presentationml/2006/main">
+  <p:tag name="KSO_WM_UNIT_HIGHLIGHT" val="0"/>
+  <p:tag name="KSO_WM_UNIT_COMPATIBLE" val="0"/>
+  <p:tag name="KSO_WM_UNIT_DIAGRAM_ISNUMVISUAL" val="0"/>
+  <p:tag name="KSO_WM_UNIT_DIAGRAM_ISREFERUNIT" val="0"/>
+  <p:tag name="KSO_WM_UNIT_ID" val="_7**"/>
+  <p:tag name="KSO_WM_UNIT_LAYERLEVEL" val="1"/>
+  <p:tag name="KSO_WM_TAG_VERSION" val="1.0"/>
+  <p:tag name="KSO_WM_BEAUTIFY_FLAG" val="#wm#"/>
+</p:tagLst>
+</file>
+
+<file path=ppt/tags/tag41.xml><?xml version="1.0" encoding="utf-8"?>
+<p:tagLst xmlns:a="http://schemas.openxmlformats.org/drawingml/2006/main" xmlns:r="http://schemas.openxmlformats.org/officeDocument/2006/relationships" xmlns:p="http://schemas.openxmlformats.org/presentationml/2006/main">
+  <p:tag name="KSO_WM_UNIT_HIGHLIGHT" val="0"/>
+  <p:tag name="KSO_WM_UNIT_COMPATIBLE" val="0"/>
+  <p:tag name="KSO_WM_UNIT_DIAGRAM_ISNUMVISUAL" val="0"/>
+  <p:tag name="KSO_WM_UNIT_DIAGRAM_ISREFERUNIT" val="0"/>
+  <p:tag name="KSO_WM_UNIT_ID" val="_7**"/>
+  <p:tag name="KSO_WM_UNIT_LAYERLEVEL" val="1"/>
+  <p:tag name="KSO_WM_TAG_VERSION" val="1.0"/>
+  <p:tag name="KSO_WM_BEAUTIFY_FLAG" val="#wm#"/>
+</p:tagLst>
+</file>
+
+<file path=ppt/tags/tag42.xml><?xml version="1.0" encoding="utf-8"?>
+<p:tagLst xmlns:a="http://schemas.openxmlformats.org/drawingml/2006/main" xmlns:r="http://schemas.openxmlformats.org/officeDocument/2006/relationships" xmlns:p="http://schemas.openxmlformats.org/presentationml/2006/main">
+  <p:tag name="KSO_WM_UNIT_HIGHLIGHT" val="0"/>
+  <p:tag name="KSO_WM_UNIT_COMPATIBLE" val="0"/>
+  <p:tag name="KSO_WM_UNIT_DIAGRAM_ISNUMVISUAL" val="0"/>
+  <p:tag name="KSO_WM_UNIT_DIAGRAM_ISREFERUNIT" val="0"/>
+  <p:tag name="KSO_WM_UNIT_ID" val="_7**"/>
+  <p:tag name="KSO_WM_UNIT_LAYERLEVEL" val="1"/>
+  <p:tag name="KSO_WM_TAG_VERSION" val="1.0"/>
+  <p:tag name="KSO_WM_BEAUTIFY_FLAG" val="#wm#"/>
+</p:tagLst>
+</file>
+
+<file path=ppt/tags/tag43.xml><?xml version="1.0" encoding="utf-8"?>
+<p:tagLst xmlns:a="http://schemas.openxmlformats.org/drawingml/2006/main" xmlns:r="http://schemas.openxmlformats.org/officeDocument/2006/relationships" xmlns:p="http://schemas.openxmlformats.org/presentationml/2006/main">
+  <p:tag name="KSO_WM_UNIT_HIGHLIGHT" val="0"/>
+  <p:tag name="KSO_WM_UNIT_COMPATIBLE" val="0"/>
+  <p:tag name="KSO_WM_UNIT_DIAGRAM_ISNUMVISUAL" val="0"/>
+  <p:tag name="KSO_WM_UNIT_DIAGRAM_ISREFERUNIT" val="0"/>
+  <p:tag name="KSO_WM_UNIT_ID" val="_8**"/>
+  <p:tag name="KSO_WM_UNIT_LAYERLEVEL" val="1"/>
+  <p:tag name="KSO_WM_TAG_VERSION" val="1.0"/>
+  <p:tag name="KSO_WM_BEAUTIFY_FLAG" val="#wm#"/>
+</p:tagLst>
+</file>
+
+<file path=ppt/tags/tag44.xml><?xml version="1.0" encoding="utf-8"?>
+<p:tagLst xmlns:a="http://schemas.openxmlformats.org/drawingml/2006/main" xmlns:r="http://schemas.openxmlformats.org/officeDocument/2006/relationships" xmlns:p="http://schemas.openxmlformats.org/presentationml/2006/main">
+  <p:tag name="KSO_WM_UNIT_HIGHLIGHT" val="0"/>
+  <p:tag name="KSO_WM_UNIT_COMPATIBLE" val="0"/>
+  <p:tag name="KSO_WM_UNIT_DIAGRAM_ISNUMVISUAL" val="0"/>
+  <p:tag name="KSO_WM_UNIT_DIAGRAM_ISREFERUNIT" val="0"/>
+  <p:tag name="KSO_WM_UNIT_ID" val="_8**"/>
+  <p:tag name="KSO_WM_UNIT_LAYERLEVEL" val="1"/>
+  <p:tag name="KSO_WM_TAG_VERSION" val="1.0"/>
+  <p:tag name="KSO_WM_BEAUTIFY_FLAG" val="#wm#"/>
+</p:tagLst>
+</file>
+
+<file path=ppt/tags/tag45.xml><?xml version="1.0" encoding="utf-8"?>
+<p:tagLst xmlns:a="http://schemas.openxmlformats.org/drawingml/2006/main" xmlns:r="http://schemas.openxmlformats.org/officeDocument/2006/relationships" xmlns:p="http://schemas.openxmlformats.org/presentationml/2006/main">
+  <p:tag name="KSO_WM_UNIT_HIGHLIGHT" val="0"/>
+  <p:tag name="KSO_WM_UNIT_COMPATIBLE" val="0"/>
+  <p:tag name="KSO_WM_UNIT_DIAGRAM_ISNUMVISUAL" val="0"/>
+  <p:tag name="KSO_WM_UNIT_DIAGRAM_ISREFERUNIT" val="0"/>
+  <p:tag name="KSO_WM_UNIT_ID" val="_8**"/>
+  <p:tag name="KSO_WM_UNIT_LAYERLEVEL" val="1"/>
+  <p:tag name="KSO_WM_TAG_VERSION" val="1.0"/>
+  <p:tag name="KSO_WM_BEAUTIFY_FLAG" val="#wm#"/>
+</p:tagLst>
+</file>
+
+<file path=ppt/tags/tag46.xml><?xml version="1.0" encoding="utf-8"?>
+<p:tagLst xmlns:a="http://schemas.openxmlformats.org/drawingml/2006/main" xmlns:r="http://schemas.openxmlformats.org/officeDocument/2006/relationships" xmlns:p="http://schemas.openxmlformats.org/presentationml/2006/main">
+  <p:tag name="KSO_WM_UNIT_HIGHLIGHT" val="0"/>
+  <p:tag name="KSO_WM_UNIT_COMPATIBLE" val="0"/>
+  <p:tag name="KSO_WM_UNIT_DIAGRAM_ISNUMVISUAL" val="0"/>
+  <p:tag name="KSO_WM_UNIT_DIAGRAM_ISREFERUNIT" val="0"/>
+  <p:tag name="KSO_WM_UNIT_ID" val="_8**"/>
+  <p:tag name="KSO_WM_UNIT_LAYERLEVEL" val="1"/>
+  <p:tag name="KSO_WM_TAG_VERSION" val="1.0"/>
+  <p:tag name="KSO_WM_BEAUTIFY_FLAG" val="#wm#"/>
+</p:tagLst>
+</file>
+
+<file path=ppt/tags/tag47.xml><?xml version="1.0" encoding="utf-8"?>
+<p:tagLst xmlns:a="http://schemas.openxmlformats.org/drawingml/2006/main" xmlns:r="http://schemas.openxmlformats.org/officeDocument/2006/relationships" xmlns:p="http://schemas.openxmlformats.org/presentationml/2006/main">
+  <p:tag name="KSO_WM_UNIT_HIGHLIGHT" val="0"/>
+  <p:tag name="KSO_WM_UNIT_COMPATIBLE" val="0"/>
+  <p:tag name="KSO_WM_UNIT_DIAGRAM_ISNUMVISUAL" val="0"/>
+  <p:tag name="KSO_WM_UNIT_DIAGRAM_ISREFERUNIT" val="0"/>
+  <p:tag name="KSO_WM_UNIT_ID" val="_8**"/>
+  <p:tag name="KSO_WM_UNIT_LAYERLEVEL" val="1"/>
+  <p:tag name="KSO_WM_TAG_VERSION" val="1.0"/>
+  <p:tag name="KSO_WM_BEAUTIFY_FLAG" val="#wm#"/>
+</p:tagLst>
+</file>
+
+<file path=ppt/tags/tag48.xml><?xml version="1.0" encoding="utf-8"?>
+<p:tagLst xmlns:a="http://schemas.openxmlformats.org/drawingml/2006/main" xmlns:r="http://schemas.openxmlformats.org/officeDocument/2006/relationships" xmlns:p="http://schemas.openxmlformats.org/presentationml/2006/main">
+  <p:tag name="KSO_WM_UNIT_HIGHLIGHT" val="0"/>
+  <p:tag name="KSO_WM_UNIT_COMPATIBLE" val="0"/>
+  <p:tag name="KSO_WM_UNIT_DIAGRAM_ISNUMVISUAL" val="0"/>
+  <p:tag name="KSO_WM_UNIT_DIAGRAM_ISREFERUNIT" val="0"/>
+  <p:tag name="KSO_WM_UNIT_ID" val="_8**"/>
+  <p:tag name="KSO_WM_UNIT_LAYERLEVEL" val="1"/>
+  <p:tag name="KSO_WM_TAG_VERSION" val="1.0"/>
+  <p:tag name="KSO_WM_BEAUTIFY_FLAG" val="#wm#"/>
+</p:tagLst>
+</file>
+
+<file path=ppt/tags/tag49.xml><?xml version="1.0" encoding="utf-8"?>
+<p:tagLst xmlns:a="http://schemas.openxmlformats.org/drawingml/2006/main" xmlns:r="http://schemas.openxmlformats.org/officeDocument/2006/relationships" xmlns:p="http://schemas.openxmlformats.org/presentationml/2006/main">
+  <p:tag name="KSO_WM_UNIT_HIGHLIGHT" val="0"/>
+  <p:tag name="KSO_WM_UNIT_COMPATIBLE" val="0"/>
+  <p:tag name="KSO_WM_UNIT_DIAGRAM_ISNUMVISUAL" val="0"/>
+  <p:tag name="KSO_WM_UNIT_DIAGRAM_ISREFERUNIT" val="0"/>
+  <p:tag name="KSO_WM_UNIT_ID" val="_9**"/>
+  <p:tag name="KSO_WM_UNIT_LAYERLEVEL" val="1"/>
+  <p:tag name="KSO_WM_TAG_VERSION" val="1.0"/>
+  <p:tag name="KSO_WM_BEAUTIFY_FLAG" val="#wm#"/>
+</p:tagLst>
+</file>
+
+<file path=ppt/tags/tag5.xml><?xml version="1.0" encoding="utf-8"?>
+<p:tagLst xmlns:a="http://schemas.openxmlformats.org/drawingml/2006/main" xmlns:r="http://schemas.openxmlformats.org/officeDocument/2006/relationships" xmlns:p="http://schemas.openxmlformats.org/presentationml/2006/main">
+  <p:tag name="KSO_WM_UNIT_HIGHLIGHT" val="0"/>
+  <p:tag name="KSO_WM_UNIT_COMPATIBLE" val="0"/>
+  <p:tag name="KSO_WM_UNIT_DIAGRAM_ISNUMVISUAL" val="0"/>
+  <p:tag name="KSO_WM_UNIT_DIAGRAM_ISREFERUNIT" val="0"/>
+  <p:tag name="KSO_WM_UNIT_ID" val="_0**"/>
+  <p:tag name="KSO_WM_UNIT_LAYERLEVEL" val="1"/>
+  <p:tag name="KSO_WM_TAG_VERSION" val="1.0"/>
+  <p:tag name="KSO_WM_BEAUTIFY_FLAG" val="#wm#"/>
+</p:tagLst>
+</file>
+
+<file path=ppt/tags/tag50.xml><?xml version="1.0" encoding="utf-8"?>
+<p:tagLst xmlns:a="http://schemas.openxmlformats.org/drawingml/2006/main" xmlns:r="http://schemas.openxmlformats.org/officeDocument/2006/relationships" xmlns:p="http://schemas.openxmlformats.org/presentationml/2006/main">
+  <p:tag name="KSO_WM_UNIT_HIGHLIGHT" val="0"/>
+  <p:tag name="KSO_WM_UNIT_COMPATIBLE" val="0"/>
+  <p:tag name="KSO_WM_UNIT_DIAGRAM_ISNUMVISUAL" val="0"/>
+  <p:tag name="KSO_WM_UNIT_DIAGRAM_ISREFERUNIT" val="0"/>
+  <p:tag name="KSO_WM_UNIT_ID" val="_9**"/>
+  <p:tag name="KSO_WM_UNIT_LAYERLEVEL" val="1"/>
+  <p:tag name="KSO_WM_TAG_VERSION" val="1.0"/>
+  <p:tag name="KSO_WM_BEAUTIFY_FLAG" val="#wm#"/>
+</p:tagLst>
+</file>
+
+<file path=ppt/tags/tag51.xml><?xml version="1.0" encoding="utf-8"?>
+<p:tagLst xmlns:a="http://schemas.openxmlformats.org/drawingml/2006/main" xmlns:r="http://schemas.openxmlformats.org/officeDocument/2006/relationships" xmlns:p="http://schemas.openxmlformats.org/presentationml/2006/main">
+  <p:tag name="KSO_WM_UNIT_HIGHLIGHT" val="0"/>
+  <p:tag name="KSO_WM_UNIT_COMPATIBLE" val="0"/>
+  <p:tag name="KSO_WM_UNIT_DIAGRAM_ISNUMVISUAL" val="0"/>
+  <p:tag name="KSO_WM_UNIT_DIAGRAM_ISREFERUNIT" val="0"/>
+  <p:tag name="KSO_WM_UNIT_ID" val="_9**"/>
+  <p:tag name="KSO_WM_UNIT_LAYERLEVEL" val="1"/>
+  <p:tag name="KSO_WM_TAG_VERSION" val="1.0"/>
+  <p:tag name="KSO_WM_BEAUTIFY_FLAG" val="#wm#"/>
+</p:tagLst>
+</file>
+
+<file path=ppt/tags/tag52.xml><?xml version="1.0" encoding="utf-8"?>
+<p:tagLst xmlns:a="http://schemas.openxmlformats.org/drawingml/2006/main" xmlns:r="http://schemas.openxmlformats.org/officeDocument/2006/relationships" xmlns:p="http://schemas.openxmlformats.org/presentationml/2006/main">
+  <p:tag name="KSO_WM_UNIT_HIGHLIGHT" val="0"/>
+  <p:tag name="KSO_WM_UNIT_COMPATIBLE" val="0"/>
+  <p:tag name="KSO_WM_UNIT_DIAGRAM_ISNUMVISUAL" val="0"/>
+  <p:tag name="KSO_WM_UNIT_DIAGRAM_ISREFERUNIT" val="0"/>
+  <p:tag name="KSO_WM_UNIT_ID" val="_9**"/>
+  <p:tag name="KSO_WM_UNIT_LAYERLEVEL" val="1"/>
+  <p:tag name="KSO_WM_TAG_VERSION" val="1.0"/>
+  <p:tag name="KSO_WM_BEAUTIFY_FLAG" val="#wm#"/>
+</p:tagLst>
+</file>
+
+<file path=ppt/tags/tag53.xml><?xml version="1.0" encoding="utf-8"?>
+<p:tagLst xmlns:a="http://schemas.openxmlformats.org/drawingml/2006/main" xmlns:r="http://schemas.openxmlformats.org/officeDocument/2006/relationships" xmlns:p="http://schemas.openxmlformats.org/presentationml/2006/main">
+  <p:tag name="KSO_WM_UNIT_HIGHLIGHT" val="0"/>
+  <p:tag name="KSO_WM_UNIT_COMPATIBLE" val="0"/>
+  <p:tag name="KSO_WM_UNIT_DIAGRAM_ISNUMVISUAL" val="0"/>
+  <p:tag name="KSO_WM_UNIT_DIAGRAM_ISREFERUNIT" val="0"/>
+  <p:tag name="KSO_WM_UNIT_ID" val="_9**"/>
+  <p:tag name="KSO_WM_UNIT_LAYERLEVEL" val="1"/>
+  <p:tag name="KSO_WM_TAG_VERSION" val="1.0"/>
+  <p:tag name="KSO_WM_BEAUTIFY_FLAG" val="#wm#"/>
+</p:tagLst>
+</file>
+
+<file path=ppt/tags/tag54.xml><?xml version="1.0" encoding="utf-8"?>
+<p:tagLst xmlns:a="http://schemas.openxmlformats.org/drawingml/2006/main" xmlns:r="http://schemas.openxmlformats.org/officeDocument/2006/relationships" xmlns:p="http://schemas.openxmlformats.org/presentationml/2006/main">
+  <p:tag name="KSO_WM_UNIT_HIGHLIGHT" val="0"/>
+  <p:tag name="KSO_WM_UNIT_COMPATIBLE" val="0"/>
+  <p:tag name="KSO_WM_UNIT_DIAGRAM_ISNUMVISUAL" val="0"/>
+  <p:tag name="KSO_WM_UNIT_DIAGRAM_ISREFERUNIT" val="0"/>
+  <p:tag name="KSO_WM_UNIT_ID" val="_10**"/>
+  <p:tag name="KSO_WM_UNIT_LAYERLEVEL" val="1"/>
+  <p:tag name="KSO_WM_TAG_VERSION" val="1.0"/>
+  <p:tag name="KSO_WM_BEAUTIFY_FLAG" val="#wm#"/>
+</p:tagLst>
+</file>
+
+<file path=ppt/tags/tag55.xml><?xml version="1.0" encoding="utf-8"?>
+<p:tagLst xmlns:a="http://schemas.openxmlformats.org/drawingml/2006/main" xmlns:r="http://schemas.openxmlformats.org/officeDocument/2006/relationships" xmlns:p="http://schemas.openxmlformats.org/presentationml/2006/main">
+  <p:tag name="KSO_WM_UNIT_HIGHLIGHT" val="0"/>
+  <p:tag name="KSO_WM_UNIT_COMPATIBLE" val="0"/>
+  <p:tag name="KSO_WM_UNIT_DIAGRAM_ISNUMVISUAL" val="0"/>
+  <p:tag name="KSO_WM_UNIT_DIAGRAM_ISREFERUNIT" val="0"/>
+  <p:tag name="KSO_WM_UNIT_ID" val="_10**"/>
+  <p:tag name="KSO_WM_UNIT_LAYERLEVEL" val="1"/>
+  <p:tag name="KSO_WM_TAG_VERSION" val="1.0"/>
+  <p:tag name="KSO_WM_BEAUTIFY_FLAG" val="#wm#"/>
+</p:tagLst>
+</file>
+
+<file path=ppt/tags/tag56.xml><?xml version="1.0" encoding="utf-8"?>
+<p:tagLst xmlns:a="http://schemas.openxmlformats.org/drawingml/2006/main" xmlns:r="http://schemas.openxmlformats.org/officeDocument/2006/relationships" xmlns:p="http://schemas.openxmlformats.org/presentationml/2006/main">
+  <p:tag name="KSO_WM_UNIT_HIGHLIGHT" val="0"/>
+  <p:tag name="KSO_WM_UNIT_COMPATIBLE" val="0"/>
+  <p:tag name="KSO_WM_UNIT_DIAGRAM_ISNUMVISUAL" val="0"/>
+  <p:tag name="KSO_WM_UNIT_DIAGRAM_ISREFERUNIT" val="0"/>
+  <p:tag name="KSO_WM_UNIT_ID" val="_10**"/>
+  <p:tag name="KSO_WM_UNIT_LAYERLEVEL" val="1"/>
+  <p:tag name="KSO_WM_TAG_VERSION" val="1.0"/>
+  <p:tag name="KSO_WM_BEAUTIFY_FLAG" val="#wm#"/>
+</p:tagLst>
+</file>
+
+<file path=ppt/tags/tag57.xml><?xml version="1.0" encoding="utf-8"?>
+<p:tagLst xmlns:a="http://schemas.openxmlformats.org/drawingml/2006/main" xmlns:r="http://schemas.openxmlformats.org/officeDocument/2006/relationships" xmlns:p="http://schemas.openxmlformats.org/presentationml/2006/main">
+  <p:tag name="KSO_WM_UNIT_HIGHLIGHT" val="0"/>
+  <p:tag name="KSO_WM_UNIT_COMPATIBLE" val="0"/>
+  <p:tag name="KSO_WM_UNIT_DIAGRAM_ISNUMVISUAL" val="0"/>
+  <p:tag name="KSO_WM_UNIT_DIAGRAM_ISREFERUNIT" val="0"/>
+  <p:tag name="KSO_WM_UNIT_ID" val="_10**"/>
+  <p:tag name="KSO_WM_UNIT_LAYERLEVEL" val="1"/>
+  <p:tag name="KSO_WM_TAG_VERSION" val="1.0"/>
+  <p:tag name="KSO_WM_BEAUTIFY_FLAG" val="#wm#"/>
+</p:tagLst>
+</file>
+
+<file path=ppt/tags/tag58.xml><?xml version="1.0" encoding="utf-8"?>
+<p:tagLst xmlns:a="http://schemas.openxmlformats.org/drawingml/2006/main" xmlns:r="http://schemas.openxmlformats.org/officeDocument/2006/relationships" xmlns:p="http://schemas.openxmlformats.org/presentationml/2006/main">
+  <p:tag name="KSO_WM_UNIT_HIGHLIGHT" val="0"/>
+  <p:tag name="KSO_WM_UNIT_COMPATIBLE" val="0"/>
+  <p:tag name="KSO_WM_UNIT_DIAGRAM_ISNUMVISUAL" val="0"/>
+  <p:tag name="KSO_WM_UNIT_DIAGRAM_ISREFERUNIT" val="0"/>
+  <p:tag name="KSO_WM_UNIT_ID" val="_11**"/>
+  <p:tag name="KSO_WM_UNIT_LAYERLEVEL" val="1"/>
+  <p:tag name="KSO_WM_TAG_VERSION" val="1.0"/>
+  <p:tag name="KSO_WM_BEAUTIFY_FLAG" val="#wm#"/>
+</p:tagLst>
+</file>
+
+<file path=ppt/tags/tag59.xml><?xml version="1.0" encoding="utf-8"?>
+<p:tagLst xmlns:a="http://schemas.openxmlformats.org/drawingml/2006/main" xmlns:r="http://schemas.openxmlformats.org/officeDocument/2006/relationships" xmlns:p="http://schemas.openxmlformats.org/presentationml/2006/main">
+  <p:tag name="KSO_WM_UNIT_HIGHLIGHT" val="0"/>
+  <p:tag name="KSO_WM_UNIT_COMPATIBLE" val="0"/>
+  <p:tag name="KSO_WM_UNIT_DIAGRAM_ISNUMVISUAL" val="0"/>
+  <p:tag name="KSO_WM_UNIT_DIAGRAM_ISREFERUNIT" val="0"/>
+  <p:tag name="KSO_WM_UNIT_ID" val="_11**"/>
+  <p:tag name="KSO_WM_UNIT_LAYERLEVEL" val="1"/>
+  <p:tag name="KSO_WM_TAG_VERSION" val="1.0"/>
+  <p:tag name="KSO_WM_BEAUTIFY_FLAG" val="#wm#"/>
+</p:tagLst>
+</file>
+
+<file path=ppt/tags/tag6.xml><?xml version="1.0" encoding="utf-8"?>
+<p:tagLst xmlns:a="http://schemas.openxmlformats.org/drawingml/2006/main" xmlns:r="http://schemas.openxmlformats.org/officeDocument/2006/relationships" xmlns:p="http://schemas.openxmlformats.org/presentationml/2006/main">
+  <p:tag name="KSO_WM_UNIT_HIGHLIGHT" val="0"/>
+  <p:tag name="KSO_WM_UNIT_COMPATIBLE" val="0"/>
+  <p:tag name="KSO_WM_UNIT_DIAGRAM_ISNUMVISUAL" val="0"/>
+  <p:tag name="KSO_WM_UNIT_DIAGRAM_ISREFERUNIT" val="0"/>
+  <p:tag name="KSO_WM_UNIT_ID" val="_0**"/>
+  <p:tag name="KSO_WM_UNIT_LAYERLEVEL" val="1"/>
+  <p:tag name="KSO_WM_TAG_VERSION" val="1.0"/>
+  <p:tag name="KSO_WM_BEAUTIFY_FLAG" val="#wm#"/>
+</p:tagLst>
+</file>
+
+<file path=ppt/tags/tag60.xml><?xml version="1.0" encoding="utf-8"?>
+<p:tagLst xmlns:a="http://schemas.openxmlformats.org/drawingml/2006/main" xmlns:r="http://schemas.openxmlformats.org/officeDocument/2006/relationships" xmlns:p="http://schemas.openxmlformats.org/presentationml/2006/main">
+  <p:tag name="KSO_WM_UNIT_HIGHLIGHT" val="0"/>
+  <p:tag name="KSO_WM_UNIT_COMPATIBLE" val="0"/>
+  <p:tag name="KSO_WM_UNIT_DIAGRAM_ISNUMVISUAL" val="0"/>
+  <p:tag name="KSO_WM_UNIT_DIAGRAM_ISREFERUNIT" val="0"/>
+  <p:tag name="KSO_WM_UNIT_ID" val="_11**"/>
+  <p:tag name="KSO_WM_UNIT_LAYERLEVEL" val="1"/>
+  <p:tag name="KSO_WM_TAG_VERSION" val="1.0"/>
+  <p:tag name="KSO_WM_BEAUTIFY_FLAG" val="#wm#"/>
+</p:tagLst>
+</file>
+
+<file path=ppt/tags/tag61.xml><?xml version="1.0" encoding="utf-8"?>
+<p:tagLst xmlns:a="http://schemas.openxmlformats.org/drawingml/2006/main" xmlns:r="http://schemas.openxmlformats.org/officeDocument/2006/relationships" xmlns:p="http://schemas.openxmlformats.org/presentationml/2006/main">
+  <p:tag name="KSO_WM_UNIT_HIGHLIGHT" val="0"/>
+  <p:tag name="KSO_WM_UNIT_COMPATIBLE" val="0"/>
+  <p:tag name="KSO_WM_UNIT_DIAGRAM_ISNUMVISUAL" val="0"/>
+  <p:tag name="KSO_WM_UNIT_DIAGRAM_ISREFERUNIT" val="0"/>
+  <p:tag name="KSO_WM_UNIT_ID" val="_11**"/>
+  <p:tag name="KSO_WM_UNIT_LAYERLEVEL" val="1"/>
+  <p:tag name="KSO_WM_TAG_VERSION" val="1.0"/>
+  <p:tag name="KSO_WM_BEAUTIFY_FLAG" val="#wm#"/>
+</p:tagLst>
+</file>
+
+<file path=ppt/tags/tag62.xml><?xml version="1.0" encoding="utf-8"?>
+<p:tagLst xmlns:a="http://schemas.openxmlformats.org/drawingml/2006/main" xmlns:r="http://schemas.openxmlformats.org/officeDocument/2006/relationships" xmlns:p="http://schemas.openxmlformats.org/presentationml/2006/main">
+  <p:tag name="KSO_WM_UNIT_HIGHLIGHT" val="0"/>
+  <p:tag name="KSO_WM_UNIT_COMPATIBLE" val="0"/>
+  <p:tag name="KSO_WM_UNIT_DIAGRAM_ISNUMVISUAL" val="0"/>
+  <p:tag name="KSO_WM_UNIT_DIAGRAM_ISREFERUNIT" val="0"/>
+  <p:tag name="KSO_WM_UNIT_ID" val="_11**"/>
+  <p:tag name="KSO_WM_UNIT_LAYERLEVEL" val="1"/>
+  <p:tag name="KSO_WM_TAG_VERSION" val="1.0"/>
+  <p:tag name="KSO_WM_BEAUTIFY_FLAG" val="#wm#"/>
+</p:tagLst>
+</file>
+
+<file path=ppt/tags/tag63.xml><?xml version="1.0" encoding="utf-8"?>
+<p:tagLst xmlns:a="http://schemas.openxmlformats.org/drawingml/2006/main" xmlns:r="http://schemas.openxmlformats.org/officeDocument/2006/relationships" xmlns:p="http://schemas.openxmlformats.org/presentationml/2006/main">
   <p:tag name="KSO_WM_SLIDE_ID" val="custom20205081_1"/>
   <p:tag name="KSO_WM_TEMPLATE_SUBCATEGORY" val="19"/>
   <p:tag name="KSO_WM_TEMPLATE_MASTER_TYPE" val="0"/>
@@ -4512,13 +5212,35 @@
 </p:tagLst>
 </file>
 
+<file path=ppt/tags/tag64.xml><?xml version="1.0" encoding="utf-8"?>
+<p:tagLst xmlns:a="http://schemas.openxmlformats.org/drawingml/2006/main" xmlns:r="http://schemas.openxmlformats.org/officeDocument/2006/relationships" xmlns:p="http://schemas.openxmlformats.org/presentationml/2006/main">
+  <p:tag name="KSO_WM_UNIT_ISCONTENTSTITLE" val="0"/>
+  <p:tag name="KSO_WM_UNIT_ISNUMDGMTITLE" val="0"/>
+  <p:tag name="KSO_WM_UNIT_NOCLEAR" val="0"/>
+  <p:tag name="KSO_WM_UNIT_SHOW_EDIT_AREA_INDICATION" val="1"/>
+  <p:tag name="KSO_WM_UNIT_VALUE" val="111"/>
+  <p:tag name="KSO_WM_UNIT_HIGHLIGHT" val="0"/>
+  <p:tag name="KSO_WM_UNIT_COMPATIBLE" val="0"/>
+  <p:tag name="KSO_WM_UNIT_DIAGRAM_ISNUMVISUAL" val="0"/>
+  <p:tag name="KSO_WM_UNIT_DIAGRAM_ISREFERUNIT" val="0"/>
+  <p:tag name="KSO_WM_UNIT_TYPE" val="b"/>
+  <p:tag name="KSO_WM_UNIT_INDEX" val="1"/>
+  <p:tag name="KSO_WM_UNIT_ID" val="custom20205081_1*b*1"/>
+  <p:tag name="KSO_WM_TEMPLATE_CATEGORY" val="custom"/>
+  <p:tag name="KSO_WM_TEMPLATE_INDEX" val="20205081"/>
+  <p:tag name="KSO_WM_UNIT_LAYERLEVEL" val="1"/>
+  <p:tag name="KSO_WM_TAG_VERSION" val="1.0"/>
+  <p:tag name="KSO_WM_BEAUTIFY_FLAG" val="#wm#"/>
+</p:tagLst>
+</file>
+
 <file path=ppt/tags/tag7.xml><?xml version="1.0" encoding="utf-8"?>
-<p:tagLst xmlns:p="http://schemas.openxmlformats.org/presentationml/2006/main">
-  <p:tag name="KSO_WM_UNIT_HIGHLIGHT" val="0"/>
-  <p:tag name="KSO_WM_UNIT_COMPATIBLE" val="0"/>
-  <p:tag name="KSO_WM_UNIT_DIAGRAM_ISNUMVISUAL" val="0"/>
-  <p:tag name="KSO_WM_UNIT_DIAGRAM_ISREFERUNIT" val="0"/>
-  <p:tag name="KSO_WM_UNIT_ID" val="_2**"/>
+<p:tagLst xmlns:a="http://schemas.openxmlformats.org/drawingml/2006/main" xmlns:r="http://schemas.openxmlformats.org/officeDocument/2006/relationships" xmlns:p="http://schemas.openxmlformats.org/presentationml/2006/main">
+  <p:tag name="KSO_WM_UNIT_HIGHLIGHT" val="0"/>
+  <p:tag name="KSO_WM_UNIT_COMPATIBLE" val="0"/>
+  <p:tag name="KSO_WM_UNIT_DIAGRAM_ISNUMVISUAL" val="0"/>
+  <p:tag name="KSO_WM_UNIT_DIAGRAM_ISREFERUNIT" val="0"/>
+  <p:tag name="KSO_WM_UNIT_ID" val="_1**"/>
   <p:tag name="KSO_WM_UNIT_LAYERLEVEL" val="1"/>
   <p:tag name="KSO_WM_TAG_VERSION" val="1.0"/>
   <p:tag name="KSO_WM_BEAUTIFY_FLAG" val="#wm#"/>
@@ -4526,12 +5248,12 @@
 </file>
 
 <file path=ppt/tags/tag8.xml><?xml version="1.0" encoding="utf-8"?>
-<p:tagLst xmlns:p="http://schemas.openxmlformats.org/presentationml/2006/main">
-  <p:tag name="KSO_WM_UNIT_HIGHLIGHT" val="0"/>
-  <p:tag name="KSO_WM_UNIT_COMPATIBLE" val="0"/>
-  <p:tag name="KSO_WM_UNIT_DIAGRAM_ISNUMVISUAL" val="0"/>
-  <p:tag name="KSO_WM_UNIT_DIAGRAM_ISREFERUNIT" val="0"/>
-  <p:tag name="KSO_WM_UNIT_ID" val="_2**"/>
+<p:tagLst xmlns:a="http://schemas.openxmlformats.org/drawingml/2006/main" xmlns:r="http://schemas.openxmlformats.org/officeDocument/2006/relationships" xmlns:p="http://schemas.openxmlformats.org/presentationml/2006/main">
+  <p:tag name="KSO_WM_UNIT_HIGHLIGHT" val="0"/>
+  <p:tag name="KSO_WM_UNIT_COMPATIBLE" val="0"/>
+  <p:tag name="KSO_WM_UNIT_DIAGRAM_ISNUMVISUAL" val="0"/>
+  <p:tag name="KSO_WM_UNIT_DIAGRAM_ISREFERUNIT" val="0"/>
+  <p:tag name="KSO_WM_UNIT_ID" val="_1**"/>
   <p:tag name="KSO_WM_UNIT_LAYERLEVEL" val="1"/>
   <p:tag name="KSO_WM_TAG_VERSION" val="1.0"/>
   <p:tag name="KSO_WM_BEAUTIFY_FLAG" val="#wm#"/>
@@ -4539,12 +5261,12 @@
 </file>
 
 <file path=ppt/tags/tag9.xml><?xml version="1.0" encoding="utf-8"?>
-<p:tagLst xmlns:p="http://schemas.openxmlformats.org/presentationml/2006/main">
-  <p:tag name="KSO_WM_UNIT_HIGHLIGHT" val="0"/>
-  <p:tag name="KSO_WM_UNIT_COMPATIBLE" val="0"/>
-  <p:tag name="KSO_WM_UNIT_DIAGRAM_ISNUMVISUAL" val="0"/>
-  <p:tag name="KSO_WM_UNIT_DIAGRAM_ISREFERUNIT" val="0"/>
-  <p:tag name="KSO_WM_UNIT_ID" val="_2**"/>
+<p:tagLst xmlns:a="http://schemas.openxmlformats.org/drawingml/2006/main" xmlns:r="http://schemas.openxmlformats.org/officeDocument/2006/relationships" xmlns:p="http://schemas.openxmlformats.org/presentationml/2006/main">
+  <p:tag name="KSO_WM_UNIT_HIGHLIGHT" val="0"/>
+  <p:tag name="KSO_WM_UNIT_COMPATIBLE" val="0"/>
+  <p:tag name="KSO_WM_UNIT_DIAGRAM_ISNUMVISUAL" val="0"/>
+  <p:tag name="KSO_WM_UNIT_DIAGRAM_ISREFERUNIT" val="0"/>
+  <p:tag name="KSO_WM_UNIT_ID" val="_1**"/>
   <p:tag name="KSO_WM_UNIT_LAYERLEVEL" val="1"/>
   <p:tag name="KSO_WM_TAG_VERSION" val="1.0"/>
   <p:tag name="KSO_WM_BEAUTIFY_FLAG" val="#wm#"/>
@@ -4794,6 +5516,8 @@
       </a:bgFillStyleLst>
     </a:fmtScheme>
   </a:themeElements>
+  <a:objectDefaults/>
+  <a:extraClrSchemeLst/>
   <a:extLst>
     <a:ext uri="{05A4C25C-085E-4340-85A3-A5531E510DB2}">
       <thm15:themeFamily xmlns:thm15="http://schemas.microsoft.com/office/thememl/2012/main" name="Office Theme" id="{62F939B6-93AF-4DB8-9C6B-D6C7DFDC589F}" vid="{4A3C46E8-61CC-4603-A589-7422A47A8E4A}"/>

</xml_diff>

<commit_message>
改新icon Signed-off-by: jeniuluo <jeniuluo@gmail.com>
</commit_message>
<xml_diff>
--- a/articles/pics/個人-icon.pptx
+++ b/articles/pics/個人-icon.pptx
@@ -272,7 +272,7 @@
           <a:p>
             <a:fld id="{760FBDFE-C587-4B4C-A407-44438C67B59E}" type="datetimeFigureOut">
               <a:rPr lang="zh-HK" altLang="en-US" smtClean="0"/>
-              <a:t>27/8/2026</a:t>
+              <a:t>7/9/2026</a:t>
             </a:fld>
             <a:endParaRPr lang="zh-HK" altLang="en-US"/>
           </a:p>
@@ -371,7 +371,7 @@
           <a:p>
             <a:fld id="{760FBDFE-C587-4B4C-A407-44438C67B59E}" type="datetimeFigureOut">
               <a:rPr lang="zh-HK" altLang="en-US" smtClean="0"/>
-              <a:t>27/8/2026</a:t>
+              <a:t>7/9/2026</a:t>
             </a:fld>
             <a:endParaRPr lang="zh-HK" altLang="en-US"/>
           </a:p>
@@ -529,7 +529,7 @@
           <a:p>
             <a:fld id="{760FBDFE-C587-4B4C-A407-44438C67B59E}" type="datetimeFigureOut">
               <a:rPr lang="zh-HK" altLang="en-US" smtClean="0"/>
-              <a:t>27/8/2026</a:t>
+              <a:t>7/9/2026</a:t>
             </a:fld>
             <a:endParaRPr lang="zh-HK" altLang="en-US"/>
           </a:p>
@@ -800,7 +800,7 @@
           <a:p>
             <a:fld id="{760FBDFE-C587-4B4C-A407-44438C67B59E}" type="datetimeFigureOut">
               <a:rPr lang="zh-HK" altLang="en-US" smtClean="0"/>
-              <a:t>27/8/2026</a:t>
+              <a:t>7/9/2026</a:t>
             </a:fld>
             <a:endParaRPr lang="zh-HK" altLang="en-US"/>
           </a:p>
@@ -1060,7 +1060,7 @@
           <a:p>
             <a:fld id="{760FBDFE-C587-4B4C-A407-44438C67B59E}" type="datetimeFigureOut">
               <a:rPr lang="zh-HK" altLang="en-US" smtClean="0"/>
-              <a:t>27/8/2026</a:t>
+              <a:t>7/9/2026</a:t>
             </a:fld>
             <a:endParaRPr lang="zh-HK" altLang="en-US"/>
           </a:p>
@@ -1314,7 +1314,7 @@
           <a:p>
             <a:fld id="{760FBDFE-C587-4B4C-A407-44438C67B59E}" type="datetimeFigureOut">
               <a:rPr lang="zh-HK" altLang="en-US" smtClean="0"/>
-              <a:t>27/8/2026</a:t>
+              <a:t>7/9/2026</a:t>
             </a:fld>
             <a:endParaRPr lang="zh-HK" altLang="en-US"/>
           </a:p>
@@ -1728,7 +1728,7 @@
           <a:p>
             <a:fld id="{760FBDFE-C587-4B4C-A407-44438C67B59E}" type="datetimeFigureOut">
               <a:rPr lang="zh-HK" altLang="en-US" smtClean="0"/>
-              <a:t>27/8/2026</a:t>
+              <a:t>7/9/2026</a:t>
             </a:fld>
             <a:endParaRPr lang="zh-HK" altLang="en-US"/>
           </a:p>
@@ -1860,7 +1860,7 @@
           <a:p>
             <a:fld id="{760FBDFE-C587-4B4C-A407-44438C67B59E}" type="datetimeFigureOut">
               <a:rPr lang="zh-HK" altLang="en-US" smtClean="0"/>
-              <a:t>27/8/2026</a:t>
+              <a:t>7/9/2026</a:t>
             </a:fld>
             <a:endParaRPr lang="zh-HK" altLang="en-US"/>
           </a:p>
@@ -1959,7 +1959,7 @@
           <a:p>
             <a:fld id="{760FBDFE-C587-4B4C-A407-44438C67B59E}" type="datetimeFigureOut">
               <a:rPr lang="zh-HK" altLang="en-US" smtClean="0"/>
-              <a:t>27/8/2026</a:t>
+              <a:t>7/9/2026</a:t>
             </a:fld>
             <a:endParaRPr lang="zh-HK" altLang="en-US"/>
           </a:p>
@@ -2131,7 +2131,7 @@
           <a:p>
             <a:fld id="{9EFD9D74-47D9-4702-A33C-335B63B48DBF}" type="datetimeFigureOut">
               <a:rPr lang="zh-HK" altLang="en-US" smtClean="0"/>
-              <a:t>27/8/2026</a:t>
+              <a:t>7/9/2026</a:t>
             </a:fld>
             <a:endParaRPr lang="zh-HK" altLang="en-US" dirty="0"/>
           </a:p>
@@ -2371,7 +2371,7 @@
           <a:p>
             <a:fld id="{760FBDFE-C587-4B4C-A407-44438C67B59E}" type="datetimeFigureOut">
               <a:rPr lang="zh-HK" altLang="en-US" smtClean="0"/>
-              <a:t>27/8/2026</a:t>
+              <a:t>7/9/2026</a:t>
             </a:fld>
             <a:endParaRPr lang="zh-HK" altLang="en-US"/>
           </a:p>
@@ -2594,7 +2594,7 @@
           <a:p>
             <a:fld id="{760FBDFE-C587-4B4C-A407-44438C67B59E}" type="datetimeFigureOut">
               <a:rPr lang="zh-HK" altLang="en-US" smtClean="0"/>
-              <a:t>27/8/2026</a:t>
+              <a:t>7/9/2026</a:t>
             </a:fld>
             <a:endParaRPr lang="zh-HK" altLang="en-US"/>
           </a:p>
@@ -3227,7 +3227,7 @@
         </p:nvGrpSpPr>
         <p:grpSpPr>
           <a:xfrm>
-            <a:off x="4471280" y="2096759"/>
+            <a:off x="4984179" y="1402058"/>
             <a:ext cx="2473674" cy="2026942"/>
             <a:chOff x="5842880" y="1237245"/>
             <a:chExt cx="2473674" cy="2026942"/>
@@ -3682,7 +3682,7 @@
         </p:nvSpPr>
         <p:spPr>
           <a:xfrm>
-            <a:off x="885478" y="1490230"/>
+            <a:off x="340112" y="189000"/>
             <a:ext cx="3240000" cy="3240000"/>
           </a:xfrm>
           <a:prstGeom prst="ellipse">
@@ -4406,6 +4406,699 @@
           </a:p>
         </p:txBody>
       </p:sp>
+      <p:sp>
+        <p:nvSpPr>
+          <p:cNvPr id="15" name="文字方塊 14">
+            <a:extLst>
+              <a:ext uri="{FF2B5EF4-FFF2-40B4-BE49-F238E27FC236}">
+                <a16:creationId xmlns:a16="http://schemas.microsoft.com/office/drawing/2014/main" id="{68D30058-9C45-D106-2E43-7A7272C9CA9E}"/>
+              </a:ext>
+            </a:extLst>
+          </p:cNvPr>
+          <p:cNvSpPr txBox="1"/>
+          <p:nvPr/>
+        </p:nvSpPr>
+        <p:spPr>
+          <a:xfrm>
+            <a:off x="7136424" y="1055077"/>
+            <a:ext cx="321430" cy="292752"/>
+          </a:xfrm>
+          <a:custGeom>
+            <a:avLst/>
+            <a:gdLst/>
+            <a:ahLst/>
+            <a:cxnLst/>
+            <a:rect l="l" t="t" r="r" b="b"/>
+            <a:pathLst>
+              <a:path w="321430" h="292752">
+                <a:moveTo>
+                  <a:pt x="160715" y="0"/>
+                </a:moveTo>
+                <a:cubicBezTo>
+                  <a:pt x="249475" y="0"/>
+                  <a:pt x="321430" y="65535"/>
+                  <a:pt x="321430" y="146376"/>
+                </a:cubicBezTo>
+                <a:cubicBezTo>
+                  <a:pt x="321430" y="227217"/>
+                  <a:pt x="249475" y="292752"/>
+                  <a:pt x="160715" y="292752"/>
+                </a:cubicBezTo>
+                <a:cubicBezTo>
+                  <a:pt x="71955" y="292752"/>
+                  <a:pt x="0" y="227217"/>
+                  <a:pt x="0" y="146376"/>
+                </a:cubicBezTo>
+                <a:cubicBezTo>
+                  <a:pt x="0" y="65535"/>
+                  <a:pt x="71955" y="0"/>
+                  <a:pt x="160715" y="0"/>
+                </a:cubicBezTo>
+                <a:close/>
+              </a:path>
+            </a:pathLst>
+          </a:custGeom>
+          <a:solidFill>
+            <a:schemeClr val="tx1"/>
+          </a:solidFill>
+          <a:ln>
+            <a:noFill/>
+          </a:ln>
+          <a:effectLst/>
+        </p:spPr>
+        <p:txBody>
+          <a:bodyPr rot="0" spcFirstLastPara="0" vertOverflow="overflow" horzOverflow="overflow" vert="horz" wrap="square" lIns="91440" tIns="45720" rIns="91440" bIns="45720" numCol="1" spcCol="0" rtlCol="0" fromWordArt="0" anchor="t" anchorCtr="0" forceAA="0" compatLnSpc="1">
+            <a:prstTxWarp prst="textNoShape">
+              <a:avLst/>
+            </a:prstTxWarp>
+            <a:noAutofit/>
+          </a:bodyPr>
+          <a:lstStyle/>
+          <a:p>
+            <a:endParaRPr lang="zh-TW" altLang="en-US" sz="18000" dirty="0">
+              <a:latin typeface="標楷體" panose="03000509000000000000" pitchFamily="65" charset="-120"/>
+              <a:ea typeface="標楷體" panose="03000509000000000000" pitchFamily="65" charset="-120"/>
+            </a:endParaRPr>
+          </a:p>
+        </p:txBody>
+      </p:sp>
+      <p:grpSp>
+        <p:nvGrpSpPr>
+          <p:cNvPr id="20" name="群組 19">
+            <a:extLst>
+              <a:ext uri="{FF2B5EF4-FFF2-40B4-BE49-F238E27FC236}">
+                <a16:creationId xmlns:a16="http://schemas.microsoft.com/office/drawing/2014/main" id="{E8ABFB0D-3000-ABA3-1D4C-E37CFBB4B185}"/>
+              </a:ext>
+            </a:extLst>
+          </p:cNvPr>
+          <p:cNvGrpSpPr/>
+          <p:nvPr/>
+        </p:nvGrpSpPr>
+        <p:grpSpPr>
+          <a:xfrm>
+            <a:off x="1017055" y="3602448"/>
+            <a:ext cx="3240000" cy="3240000"/>
+            <a:chOff x="1017055" y="3602448"/>
+            <a:chExt cx="3240000" cy="3240000"/>
+          </a:xfrm>
+        </p:grpSpPr>
+        <p:sp>
+          <p:nvSpPr>
+            <p:cNvPr id="17" name="橢圓 16">
+              <a:extLst>
+                <a:ext uri="{FF2B5EF4-FFF2-40B4-BE49-F238E27FC236}">
+                  <a16:creationId xmlns:a16="http://schemas.microsoft.com/office/drawing/2014/main" id="{1E2A8255-B970-2FE8-DCD2-96ABD226D048}"/>
+                </a:ext>
+              </a:extLst>
+            </p:cNvPr>
+            <p:cNvSpPr/>
+            <p:nvPr/>
+          </p:nvSpPr>
+          <p:spPr>
+            <a:xfrm>
+              <a:off x="1017055" y="3602448"/>
+              <a:ext cx="3240000" cy="3240000"/>
+            </a:xfrm>
+            <a:prstGeom prst="ellipse">
+              <a:avLst/>
+            </a:prstGeom>
+            <a:gradFill>
+              <a:gsLst>
+                <a:gs pos="88000">
+                  <a:srgbClr val="0070C0"/>
+                </a:gs>
+                <a:gs pos="25000">
+                  <a:srgbClr val="00B0F0"/>
+                </a:gs>
+                <a:gs pos="73000">
+                  <a:srgbClr val="00B0F0"/>
+                </a:gs>
+                <a:gs pos="10000">
+                  <a:schemeClr val="bg1"/>
+                </a:gs>
+              </a:gsLst>
+              <a:lin ang="7800000" scaled="0"/>
+            </a:gradFill>
+            <a:ln w="92075">
+              <a:noFill/>
+            </a:ln>
+          </p:spPr>
+          <p:style>
+            <a:lnRef idx="2">
+              <a:schemeClr val="accent1">
+                <a:lumMod val="75000"/>
+              </a:schemeClr>
+            </a:lnRef>
+            <a:fillRef idx="1">
+              <a:schemeClr val="accent1"/>
+            </a:fillRef>
+            <a:effectRef idx="0">
+              <a:srgbClr val="FFFFFF"/>
+            </a:effectRef>
+            <a:fontRef idx="minor">
+              <a:schemeClr val="lt1"/>
+            </a:fontRef>
+          </p:style>
+          <p:txBody>
+            <a:bodyPr wrap="square" rtlCol="0" anchor="ctr">
+              <a:noAutofit/>
+            </a:bodyPr>
+            <a:lstStyle/>
+            <a:p>
+              <a:pPr algn="ctr"/>
+              <a:endParaRPr lang="zh-TW" altLang="en-US" sz="20000" b="1">
+                <a:solidFill>
+                  <a:schemeClr val="accent5">
+                    <a:lumMod val="50000"/>
+                  </a:schemeClr>
+                </a:solidFill>
+                <a:latin typeface="標楷體" panose="03000509000000000000" charset="-120"/>
+                <a:ea typeface="標楷體" panose="03000509000000000000" charset="-120"/>
+              </a:endParaRPr>
+            </a:p>
+          </p:txBody>
+        </p:sp>
+        <p:grpSp>
+          <p:nvGrpSpPr>
+            <p:cNvPr id="19" name="群組 18">
+              <a:extLst>
+                <a:ext uri="{FF2B5EF4-FFF2-40B4-BE49-F238E27FC236}">
+                  <a16:creationId xmlns:a16="http://schemas.microsoft.com/office/drawing/2014/main" id="{6D5B3F90-C0DC-3C81-F1D0-12D05406373F}"/>
+                </a:ext>
+              </a:extLst>
+            </p:cNvPr>
+            <p:cNvGrpSpPr/>
+            <p:nvPr/>
+          </p:nvGrpSpPr>
+          <p:grpSpPr>
+            <a:xfrm>
+              <a:off x="1176022" y="3960547"/>
+              <a:ext cx="2762937" cy="2460023"/>
+              <a:chOff x="4125478" y="3663949"/>
+              <a:chExt cx="2811506" cy="2026942"/>
+            </a:xfrm>
+            <a:solidFill>
+              <a:srgbClr val="FFFFFF"/>
+            </a:solidFill>
+          </p:grpSpPr>
+          <p:sp>
+            <p:nvSpPr>
+              <p:cNvPr id="4" name="手繪多邊形: 圖案 3">
+                <a:extLst>
+                  <a:ext uri="{FF2B5EF4-FFF2-40B4-BE49-F238E27FC236}">
+                    <a16:creationId xmlns:a16="http://schemas.microsoft.com/office/drawing/2014/main" id="{0752A4C9-2EB9-14A3-F725-7E0C40A8F624}"/>
+                  </a:ext>
+                </a:extLst>
+              </p:cNvPr>
+              <p:cNvSpPr/>
+              <p:nvPr/>
+            </p:nvSpPr>
+            <p:spPr>
+              <a:xfrm rot="21307286">
+                <a:off x="4125478" y="3663949"/>
+                <a:ext cx="1532673" cy="2026942"/>
+              </a:xfrm>
+              <a:custGeom>
+                <a:avLst/>
+                <a:gdLst/>
+                <a:ahLst/>
+                <a:cxnLst/>
+                <a:rect l="l" t="t" r="r" b="b"/>
+                <a:pathLst>
+                  <a:path w="941001" h="2026942">
+                    <a:moveTo>
+                      <a:pt x="727336" y="0"/>
+                    </a:moveTo>
+                    <a:cubicBezTo>
+                      <a:pt x="751551" y="0"/>
+                      <a:pt x="784109" y="11668"/>
+                      <a:pt x="825010" y="35003"/>
+                    </a:cubicBezTo>
+                    <a:cubicBezTo>
+                      <a:pt x="902337" y="85658"/>
+                      <a:pt x="941001" y="132186"/>
+                      <a:pt x="941001" y="174588"/>
+                    </a:cubicBezTo>
+                    <a:cubicBezTo>
+                      <a:pt x="941001" y="196759"/>
+                      <a:pt x="926888" y="219589"/>
+                      <a:pt x="898664" y="243080"/>
+                    </a:cubicBezTo>
+                    <a:cubicBezTo>
+                      <a:pt x="879856" y="269830"/>
+                      <a:pt x="853235" y="310046"/>
+                      <a:pt x="818801" y="363727"/>
+                    </a:cubicBezTo>
+                    <a:cubicBezTo>
+                      <a:pt x="769854" y="461996"/>
+                      <a:pt x="720034" y="551696"/>
+                      <a:pt x="669341" y="632826"/>
+                    </a:cubicBezTo>
+                    <a:lnTo>
+                      <a:pt x="631613" y="691360"/>
+                    </a:lnTo>
+                    <a:lnTo>
+                      <a:pt x="634604" y="694469"/>
+                    </a:lnTo>
+                    <a:cubicBezTo>
+                      <a:pt x="640031" y="700312"/>
+                      <a:pt x="645666" y="706573"/>
+                      <a:pt x="651510" y="713251"/>
+                    </a:cubicBezTo>
+                    <a:cubicBezTo>
+                      <a:pt x="704053" y="780876"/>
+                      <a:pt x="730324" y="827728"/>
+                      <a:pt x="730324" y="853805"/>
+                    </a:cubicBezTo>
+                    <a:cubicBezTo>
+                      <a:pt x="730324" y="864852"/>
+                      <a:pt x="724775" y="896802"/>
+                      <a:pt x="713677" y="949655"/>
+                    </a:cubicBezTo>
+                    <a:cubicBezTo>
+                      <a:pt x="703691" y="1002405"/>
+                      <a:pt x="698698" y="1144447"/>
+                      <a:pt x="698698" y="1375782"/>
+                    </a:cubicBezTo>
+                    <a:lnTo>
+                      <a:pt x="691092" y="1770165"/>
+                    </a:lnTo>
+                    <a:cubicBezTo>
+                      <a:pt x="691092" y="1823846"/>
+                      <a:pt x="680110" y="1881602"/>
+                      <a:pt x="658146" y="1943432"/>
+                    </a:cubicBezTo>
+                    <a:cubicBezTo>
+                      <a:pt x="641175" y="1999106"/>
+                      <a:pt x="617154" y="2026942"/>
+                      <a:pt x="586083" y="2026942"/>
+                    </a:cubicBezTo>
+                    <a:cubicBezTo>
+                      <a:pt x="551520" y="2026942"/>
+                      <a:pt x="522558" y="1996764"/>
+                      <a:pt x="499197" y="1936409"/>
+                    </a:cubicBezTo>
+                    <a:cubicBezTo>
+                      <a:pt x="465721" y="1860142"/>
+                      <a:pt x="448982" y="1803589"/>
+                      <a:pt x="448982" y="1766750"/>
+                    </a:cubicBezTo>
+                    <a:cubicBezTo>
+                      <a:pt x="451570" y="1751434"/>
+                      <a:pt x="460779" y="1714582"/>
+                      <a:pt x="476612" y="1656192"/>
+                    </a:cubicBezTo>
+                    <a:cubicBezTo>
+                      <a:pt x="512081" y="1547717"/>
+                      <a:pt x="529815" y="1315219"/>
+                      <a:pt x="529815" y="958697"/>
+                    </a:cubicBezTo>
+                    <a:cubicBezTo>
+                      <a:pt x="529815" y="936474"/>
+                      <a:pt x="528908" y="914225"/>
+                      <a:pt x="527094" y="891949"/>
+                    </a:cubicBezTo>
+                    <a:lnTo>
+                      <a:pt x="521047" y="842395"/>
+                    </a:lnTo>
+                    <a:lnTo>
+                      <a:pt x="514642" y="850507"/>
+                    </a:lnTo>
+                    <a:cubicBezTo>
+                      <a:pt x="423138" y="969175"/>
+                      <a:pt x="320587" y="1069397"/>
+                      <a:pt x="206990" y="1151174"/>
+                    </a:cubicBezTo>
+                    <a:cubicBezTo>
+                      <a:pt x="127955" y="1209046"/>
+                      <a:pt x="73330" y="1237982"/>
+                      <a:pt x="43113" y="1237982"/>
+                    </a:cubicBezTo>
+                    <a:cubicBezTo>
+                      <a:pt x="14371" y="1237982"/>
+                      <a:pt x="0" y="1226664"/>
+                      <a:pt x="0" y="1204027"/>
+                    </a:cubicBezTo>
+                    <a:cubicBezTo>
+                      <a:pt x="0" y="1186073"/>
+                      <a:pt x="13129" y="1167744"/>
+                      <a:pt x="39388" y="1149039"/>
+                    </a:cubicBezTo>
+                    <a:cubicBezTo>
+                      <a:pt x="139895" y="1050318"/>
+                      <a:pt x="241553" y="929839"/>
+                      <a:pt x="344362" y="787602"/>
+                    </a:cubicBezTo>
+                    <a:cubicBezTo>
+                      <a:pt x="437160" y="659621"/>
+                      <a:pt x="522093" y="513052"/>
+                      <a:pt x="599161" y="347894"/>
+                    </a:cubicBezTo>
+                    <a:cubicBezTo>
+                      <a:pt x="646167" y="249534"/>
+                      <a:pt x="669671" y="158289"/>
+                      <a:pt x="669671" y="74158"/>
+                    </a:cubicBezTo>
+                    <a:cubicBezTo>
+                      <a:pt x="669671" y="24720"/>
+                      <a:pt x="688893" y="0"/>
+                      <a:pt x="727336" y="0"/>
+                    </a:cubicBezTo>
+                    <a:close/>
+                  </a:path>
+                </a:pathLst>
+              </a:custGeom>
+              <a:grpFill/>
+              <a:ln>
+                <a:noFill/>
+              </a:ln>
+            </p:spPr>
+            <p:style>
+              <a:lnRef idx="2">
+                <a:schemeClr val="accent1">
+                  <a:shade val="15000"/>
+                </a:schemeClr>
+              </a:lnRef>
+              <a:fillRef idx="1">
+                <a:schemeClr val="accent1"/>
+              </a:fillRef>
+              <a:effectRef idx="0">
+                <a:schemeClr val="accent1"/>
+              </a:effectRef>
+              <a:fontRef idx="minor">
+                <a:schemeClr val="lt1"/>
+              </a:fontRef>
+            </p:style>
+            <p:txBody>
+              <a:bodyPr wrap="square" rtlCol="0" anchor="ctr">
+                <a:noAutofit/>
+              </a:bodyPr>
+              <a:lstStyle/>
+              <a:p>
+                <a:pPr algn="ctr"/>
+                <a:endParaRPr lang="zh-TW" altLang="en-US">
+                  <a:solidFill>
+                    <a:schemeClr val="bg1"/>
+                  </a:solidFill>
+                  <a:highlight>
+                    <a:srgbClr val="FFFFFF"/>
+                  </a:highlight>
+                </a:endParaRPr>
+              </a:p>
+            </p:txBody>
+          </p:sp>
+          <p:sp>
+            <p:nvSpPr>
+              <p:cNvPr id="5" name="手繪多邊形: 圖案 4">
+                <a:extLst>
+                  <a:ext uri="{FF2B5EF4-FFF2-40B4-BE49-F238E27FC236}">
+                    <a16:creationId xmlns:a16="http://schemas.microsoft.com/office/drawing/2014/main" id="{555D26BB-97F5-2BD4-35BF-4C8511EF4AC1}"/>
+                  </a:ext>
+                </a:extLst>
+              </p:cNvPr>
+              <p:cNvSpPr/>
+              <p:nvPr/>
+            </p:nvSpPr>
+            <p:spPr>
+              <a:xfrm rot="868034">
+                <a:off x="5528033" y="4022529"/>
+                <a:ext cx="1016440" cy="725823"/>
+              </a:xfrm>
+              <a:custGeom>
+                <a:avLst/>
+                <a:gdLst/>
+                <a:ahLst/>
+                <a:cxnLst/>
+                <a:rect l="l" t="t" r="r" b="b"/>
+                <a:pathLst>
+                  <a:path w="1016440" h="292751">
+                    <a:moveTo>
+                      <a:pt x="788223" y="0"/>
+                    </a:moveTo>
+                    <a:cubicBezTo>
+                      <a:pt x="801676" y="0"/>
+                      <a:pt x="839097" y="11189"/>
+                      <a:pt x="900488" y="33567"/>
+                    </a:cubicBezTo>
+                    <a:cubicBezTo>
+                      <a:pt x="977789" y="82048"/>
+                      <a:pt x="1016440" y="120997"/>
+                      <a:pt x="1016440" y="150411"/>
+                    </a:cubicBezTo>
+                    <a:cubicBezTo>
+                      <a:pt x="1012740" y="190278"/>
+                      <a:pt x="971813" y="211492"/>
+                      <a:pt x="893658" y="214053"/>
+                    </a:cubicBezTo>
+                    <a:cubicBezTo>
+                      <a:pt x="797265" y="216614"/>
+                      <a:pt x="685258" y="225138"/>
+                      <a:pt x="557639" y="239626"/>
+                    </a:cubicBezTo>
+                    <a:cubicBezTo>
+                      <a:pt x="485849" y="247465"/>
+                      <a:pt x="394099" y="261952"/>
+                      <a:pt x="282390" y="283088"/>
+                    </a:cubicBezTo>
+                    <a:cubicBezTo>
+                      <a:pt x="254113" y="289530"/>
+                      <a:pt x="235991" y="292751"/>
+                      <a:pt x="228023" y="292751"/>
+                    </a:cubicBezTo>
+                    <a:cubicBezTo>
+                      <a:pt x="181249" y="292751"/>
+                      <a:pt x="135976" y="281174"/>
+                      <a:pt x="92203" y="258020"/>
+                    </a:cubicBezTo>
+                    <a:cubicBezTo>
+                      <a:pt x="30734" y="233132"/>
+                      <a:pt x="0" y="205800"/>
+                      <a:pt x="0" y="176023"/>
+                    </a:cubicBezTo>
+                    <a:cubicBezTo>
+                      <a:pt x="0" y="154576"/>
+                      <a:pt x="26220" y="138213"/>
+                      <a:pt x="78660" y="126934"/>
+                    </a:cubicBezTo>
+                    <a:cubicBezTo>
+                      <a:pt x="323628" y="89189"/>
+                      <a:pt x="521964" y="54277"/>
+                      <a:pt x="673668" y="22197"/>
+                    </a:cubicBezTo>
+                    <a:cubicBezTo>
+                      <a:pt x="733662" y="7399"/>
+                      <a:pt x="771847" y="0"/>
+                      <a:pt x="788223" y="0"/>
+                    </a:cubicBezTo>
+                    <a:close/>
+                  </a:path>
+                </a:pathLst>
+              </a:custGeom>
+              <a:grpFill/>
+              <a:ln>
+                <a:noFill/>
+              </a:ln>
+            </p:spPr>
+            <p:style>
+              <a:lnRef idx="2">
+                <a:schemeClr val="accent1">
+                  <a:shade val="15000"/>
+                </a:schemeClr>
+              </a:lnRef>
+              <a:fillRef idx="1">
+                <a:schemeClr val="accent1"/>
+              </a:fillRef>
+              <a:effectRef idx="0">
+                <a:schemeClr val="accent1"/>
+              </a:effectRef>
+              <a:fontRef idx="minor">
+                <a:schemeClr val="lt1"/>
+              </a:fontRef>
+            </p:style>
+            <p:txBody>
+              <a:bodyPr wrap="square" rtlCol="0" anchor="ctr">
+                <a:noAutofit/>
+              </a:bodyPr>
+              <a:lstStyle/>
+              <a:p>
+                <a:pPr algn="ctr"/>
+                <a:endParaRPr lang="zh-TW" altLang="en-US">
+                  <a:solidFill>
+                    <a:schemeClr val="bg1"/>
+                  </a:solidFill>
+                  <a:highlight>
+                    <a:srgbClr val="FFFFFF"/>
+                  </a:highlight>
+                </a:endParaRPr>
+              </a:p>
+            </p:txBody>
+          </p:sp>
+          <p:sp>
+            <p:nvSpPr>
+              <p:cNvPr id="6" name="手繪多邊形: 圖案 5">
+                <a:extLst>
+                  <a:ext uri="{FF2B5EF4-FFF2-40B4-BE49-F238E27FC236}">
+                    <a16:creationId xmlns:a16="http://schemas.microsoft.com/office/drawing/2014/main" id="{04283961-FAB7-CFAF-6E39-629FC9AA7DF0}"/>
+                  </a:ext>
+                </a:extLst>
+              </p:cNvPr>
+              <p:cNvSpPr/>
+              <p:nvPr/>
+            </p:nvSpPr>
+            <p:spPr>
+              <a:xfrm rot="508649">
+                <a:off x="5404311" y="4813740"/>
+                <a:ext cx="1532673" cy="709908"/>
+              </a:xfrm>
+              <a:custGeom>
+                <a:avLst/>
+                <a:gdLst/>
+                <a:ahLst/>
+                <a:cxnLst/>
+                <a:rect l="l" t="t" r="r" b="b"/>
+                <a:pathLst>
+                  <a:path w="1532673" h="329694">
+                    <a:moveTo>
+                      <a:pt x="1291068" y="0"/>
+                    </a:moveTo>
+                    <a:cubicBezTo>
+                      <a:pt x="1305194" y="0"/>
+                      <a:pt x="1344452" y="11733"/>
+                      <a:pt x="1408844" y="35197"/>
+                    </a:cubicBezTo>
+                    <a:cubicBezTo>
+                      <a:pt x="1491397" y="86964"/>
+                      <a:pt x="1532673" y="128202"/>
+                      <a:pt x="1532673" y="158910"/>
+                    </a:cubicBezTo>
+                    <a:cubicBezTo>
+                      <a:pt x="1528844" y="200277"/>
+                      <a:pt x="1485783" y="222306"/>
+                      <a:pt x="1403489" y="224996"/>
+                    </a:cubicBezTo>
+                    <a:cubicBezTo>
+                      <a:pt x="1232691" y="228463"/>
+                      <a:pt x="1036321" y="239807"/>
+                      <a:pt x="814378" y="259029"/>
+                    </a:cubicBezTo>
+                    <a:cubicBezTo>
+                      <a:pt x="691907" y="269248"/>
+                      <a:pt x="527914" y="289155"/>
+                      <a:pt x="322399" y="318751"/>
+                    </a:cubicBezTo>
+                    <a:cubicBezTo>
+                      <a:pt x="280307" y="326046"/>
+                      <a:pt x="253363" y="329694"/>
+                      <a:pt x="241566" y="329694"/>
+                    </a:cubicBezTo>
+                    <a:cubicBezTo>
+                      <a:pt x="191947" y="329694"/>
+                      <a:pt x="143349" y="317108"/>
+                      <a:pt x="95773" y="291936"/>
+                    </a:cubicBezTo>
+                    <a:cubicBezTo>
+                      <a:pt x="31925" y="266117"/>
+                      <a:pt x="0" y="237750"/>
+                      <a:pt x="0" y="206835"/>
+                    </a:cubicBezTo>
+                    <a:cubicBezTo>
+                      <a:pt x="0" y="184845"/>
+                      <a:pt x="27164" y="168016"/>
+                      <a:pt x="81492" y="156349"/>
+                    </a:cubicBezTo>
+                    <a:cubicBezTo>
+                      <a:pt x="497904" y="110066"/>
+                      <a:pt x="838891" y="66695"/>
+                      <a:pt x="1104451" y="26233"/>
+                    </a:cubicBezTo>
+                    <a:cubicBezTo>
+                      <a:pt x="1202708" y="8745"/>
+                      <a:pt x="1264913" y="0"/>
+                      <a:pt x="1291068" y="0"/>
+                    </a:cubicBezTo>
+                    <a:close/>
+                  </a:path>
+                </a:pathLst>
+              </a:custGeom>
+              <a:grpFill/>
+              <a:ln>
+                <a:noFill/>
+              </a:ln>
+            </p:spPr>
+            <p:style>
+              <a:lnRef idx="2">
+                <a:schemeClr val="accent1">
+                  <a:shade val="15000"/>
+                </a:schemeClr>
+              </a:lnRef>
+              <a:fillRef idx="1">
+                <a:schemeClr val="accent1"/>
+              </a:fillRef>
+              <a:effectRef idx="0">
+                <a:schemeClr val="accent1"/>
+              </a:effectRef>
+              <a:fontRef idx="minor">
+                <a:schemeClr val="lt1"/>
+              </a:fontRef>
+            </p:style>
+            <p:txBody>
+              <a:bodyPr wrap="square" rtlCol="0" anchor="ctr">
+                <a:noAutofit/>
+              </a:bodyPr>
+              <a:lstStyle/>
+              <a:p>
+                <a:pPr algn="ctr"/>
+                <a:endParaRPr lang="zh-TW" altLang="en-US">
+                  <a:solidFill>
+                    <a:schemeClr val="bg1"/>
+                  </a:solidFill>
+                  <a:highlight>
+                    <a:srgbClr val="FFFFFF"/>
+                  </a:highlight>
+                </a:endParaRPr>
+              </a:p>
+            </p:txBody>
+          </p:sp>
+        </p:grpSp>
+      </p:grpSp>
+      <p:sp>
+        <p:nvSpPr>
+          <p:cNvPr id="21" name="文字方塊 20">
+            <a:extLst>
+              <a:ext uri="{FF2B5EF4-FFF2-40B4-BE49-F238E27FC236}">
+                <a16:creationId xmlns:a16="http://schemas.microsoft.com/office/drawing/2014/main" id="{DD3DB050-1781-24D7-E259-70F7F7441A46}"/>
+              </a:ext>
+            </a:extLst>
+          </p:cNvPr>
+          <p:cNvSpPr txBox="1"/>
+          <p:nvPr/>
+        </p:nvSpPr>
+        <p:spPr>
+          <a:xfrm>
+            <a:off x="8046720" y="914400"/>
+            <a:ext cx="2492990" cy="2862322"/>
+          </a:xfrm>
+          <a:prstGeom prst="rect">
+            <a:avLst/>
+          </a:prstGeom>
+          <a:noFill/>
+        </p:spPr>
+        <p:txBody>
+          <a:bodyPr wrap="none" rtlCol="0">
+            <a:spAutoFit/>
+          </a:bodyPr>
+          <a:lstStyle/>
+          <a:p>
+            <a:r>
+              <a:rPr lang="zh-TW" altLang="en-US" sz="18000" b="1" dirty="0">
+                <a:latin typeface="標楷體" panose="03000509000000000000" pitchFamily="65" charset="-120"/>
+                <a:ea typeface="書法家疊圓體" panose="02010609000101010101" pitchFamily="49" charset="-120"/>
+              </a:rPr>
+              <a:t>仁</a:t>
+            </a:r>
+          </a:p>
+        </p:txBody>
+      </p:sp>
     </p:spTree>
     <p:extLst>
       <p:ext uri="{BB962C8B-B14F-4D97-AF65-F5344CB8AC3E}">

</xml_diff>